<commit_message>
Added stroke ordering docs
</commit_message>
<xml_diff>
--- a/docs/stroke_algorithm/figures.pptx
+++ b/docs/stroke_algorithm/figures.pptx
@@ -5,12 +5,13 @@
     <p:sldMasterId id="2147483648" r:id="rId1"/>
   </p:sldMasterIdLst>
   <p:notesMasterIdLst>
-    <p:notesMasterId r:id="rId5"/>
+    <p:notesMasterId r:id="rId6"/>
   </p:notesMasterIdLst>
   <p:sldIdLst>
     <p:sldId id="258" r:id="rId2"/>
     <p:sldId id="260" r:id="rId3"/>
     <p:sldId id="259" r:id="rId4"/>
+    <p:sldId id="261" r:id="rId5"/>
   </p:sldIdLst>
   <p:sldSz cx="12192000" cy="6858000"/>
   <p:notesSz cx="6858000" cy="9144000"/>
@@ -865,6 +866,753 @@
 </file>
 
 <file path=ppt/diagrams/colors2.xml><?xml version="1.0" encoding="utf-8"?>
+<dgm:colorsDef xmlns:dgm="http://schemas.openxmlformats.org/drawingml/2006/diagram" xmlns:a="http://schemas.openxmlformats.org/drawingml/2006/main" uniqueId="urn:microsoft.com/office/officeart/2005/8/colors/accent1_2">
+  <dgm:title val=""/>
+  <dgm:desc val=""/>
+  <dgm:catLst>
+    <dgm:cat type="accent1" pri="11200"/>
+  </dgm:catLst>
+  <dgm:styleLbl name="node0">
+    <dgm:fillClrLst meth="repeat">
+      <a:schemeClr val="accent1"/>
+    </dgm:fillClrLst>
+    <dgm:linClrLst meth="repeat">
+      <a:schemeClr val="lt1"/>
+    </dgm:linClrLst>
+    <dgm:effectClrLst/>
+    <dgm:txLinClrLst/>
+    <dgm:txFillClrLst/>
+    <dgm:txEffectClrLst/>
+  </dgm:styleLbl>
+  <dgm:styleLbl name="alignNode1">
+    <dgm:fillClrLst meth="repeat">
+      <a:schemeClr val="accent1"/>
+    </dgm:fillClrLst>
+    <dgm:linClrLst meth="repeat">
+      <a:schemeClr val="accent1"/>
+    </dgm:linClrLst>
+    <dgm:effectClrLst/>
+    <dgm:txLinClrLst/>
+    <dgm:txFillClrLst/>
+    <dgm:txEffectClrLst/>
+  </dgm:styleLbl>
+  <dgm:styleLbl name="node1">
+    <dgm:fillClrLst meth="repeat">
+      <a:schemeClr val="accent1"/>
+    </dgm:fillClrLst>
+    <dgm:linClrLst meth="repeat">
+      <a:schemeClr val="lt1"/>
+    </dgm:linClrLst>
+    <dgm:effectClrLst/>
+    <dgm:txLinClrLst/>
+    <dgm:txFillClrLst/>
+    <dgm:txEffectClrLst/>
+  </dgm:styleLbl>
+  <dgm:styleLbl name="lnNode1">
+    <dgm:fillClrLst meth="repeat">
+      <a:schemeClr val="accent1"/>
+    </dgm:fillClrLst>
+    <dgm:linClrLst meth="repeat">
+      <a:schemeClr val="lt1"/>
+    </dgm:linClrLst>
+    <dgm:effectClrLst/>
+    <dgm:txLinClrLst/>
+    <dgm:txFillClrLst/>
+    <dgm:txEffectClrLst/>
+  </dgm:styleLbl>
+  <dgm:styleLbl name="vennNode1">
+    <dgm:fillClrLst meth="repeat">
+      <a:schemeClr val="accent1">
+        <a:alpha val="50000"/>
+      </a:schemeClr>
+    </dgm:fillClrLst>
+    <dgm:linClrLst meth="repeat">
+      <a:schemeClr val="lt1"/>
+    </dgm:linClrLst>
+    <dgm:effectClrLst/>
+    <dgm:txLinClrLst/>
+    <dgm:txFillClrLst/>
+    <dgm:txEffectClrLst/>
+  </dgm:styleLbl>
+  <dgm:styleLbl name="node2">
+    <dgm:fillClrLst meth="repeat">
+      <a:schemeClr val="accent1"/>
+    </dgm:fillClrLst>
+    <dgm:linClrLst meth="repeat">
+      <a:schemeClr val="lt1"/>
+    </dgm:linClrLst>
+    <dgm:effectClrLst/>
+    <dgm:txLinClrLst/>
+    <dgm:txFillClrLst/>
+    <dgm:txEffectClrLst/>
+  </dgm:styleLbl>
+  <dgm:styleLbl name="node3">
+    <dgm:fillClrLst meth="repeat">
+      <a:schemeClr val="accent1"/>
+    </dgm:fillClrLst>
+    <dgm:linClrLst meth="repeat">
+      <a:schemeClr val="lt1"/>
+    </dgm:linClrLst>
+    <dgm:effectClrLst/>
+    <dgm:txLinClrLst/>
+    <dgm:txFillClrLst/>
+    <dgm:txEffectClrLst/>
+  </dgm:styleLbl>
+  <dgm:styleLbl name="node4">
+    <dgm:fillClrLst meth="repeat">
+      <a:schemeClr val="accent1"/>
+    </dgm:fillClrLst>
+    <dgm:linClrLst meth="repeat">
+      <a:schemeClr val="lt1"/>
+    </dgm:linClrLst>
+    <dgm:effectClrLst/>
+    <dgm:txLinClrLst/>
+    <dgm:txFillClrLst/>
+    <dgm:txEffectClrLst/>
+  </dgm:styleLbl>
+  <dgm:styleLbl name="fgImgPlace1">
+    <dgm:fillClrLst meth="repeat">
+      <a:schemeClr val="accent1">
+        <a:tint val="50000"/>
+      </a:schemeClr>
+    </dgm:fillClrLst>
+    <dgm:linClrLst meth="repeat">
+      <a:schemeClr val="lt1"/>
+    </dgm:linClrLst>
+    <dgm:effectClrLst/>
+    <dgm:txLinClrLst/>
+    <dgm:txFillClrLst meth="repeat">
+      <a:schemeClr val="lt1"/>
+    </dgm:txFillClrLst>
+    <dgm:txEffectClrLst/>
+  </dgm:styleLbl>
+  <dgm:styleLbl name="alignImgPlace1">
+    <dgm:fillClrLst meth="repeat">
+      <a:schemeClr val="accent1">
+        <a:tint val="50000"/>
+      </a:schemeClr>
+    </dgm:fillClrLst>
+    <dgm:linClrLst meth="repeat">
+      <a:schemeClr val="lt1"/>
+    </dgm:linClrLst>
+    <dgm:effectClrLst/>
+    <dgm:txLinClrLst/>
+    <dgm:txFillClrLst meth="repeat">
+      <a:schemeClr val="lt1"/>
+    </dgm:txFillClrLst>
+    <dgm:txEffectClrLst/>
+  </dgm:styleLbl>
+  <dgm:styleLbl name="bgImgPlace1">
+    <dgm:fillClrLst meth="repeat">
+      <a:schemeClr val="accent1">
+        <a:tint val="50000"/>
+      </a:schemeClr>
+    </dgm:fillClrLst>
+    <dgm:linClrLst meth="repeat">
+      <a:schemeClr val="lt1"/>
+    </dgm:linClrLst>
+    <dgm:effectClrLst/>
+    <dgm:txLinClrLst/>
+    <dgm:txFillClrLst meth="repeat">
+      <a:schemeClr val="lt1"/>
+    </dgm:txFillClrLst>
+    <dgm:txEffectClrLst/>
+  </dgm:styleLbl>
+  <dgm:styleLbl name="sibTrans2D1">
+    <dgm:fillClrLst meth="repeat">
+      <a:schemeClr val="accent1">
+        <a:tint val="60000"/>
+      </a:schemeClr>
+    </dgm:fillClrLst>
+    <dgm:linClrLst meth="repeat">
+      <a:schemeClr val="accent1">
+        <a:tint val="60000"/>
+      </a:schemeClr>
+    </dgm:linClrLst>
+    <dgm:effectClrLst/>
+    <dgm:txLinClrLst/>
+    <dgm:txFillClrLst/>
+    <dgm:txEffectClrLst/>
+  </dgm:styleLbl>
+  <dgm:styleLbl name="fgSibTrans2D1">
+    <dgm:fillClrLst meth="repeat">
+      <a:schemeClr val="accent1">
+        <a:tint val="60000"/>
+      </a:schemeClr>
+    </dgm:fillClrLst>
+    <dgm:linClrLst meth="repeat">
+      <a:schemeClr val="accent1">
+        <a:tint val="60000"/>
+      </a:schemeClr>
+    </dgm:linClrLst>
+    <dgm:effectClrLst/>
+    <dgm:txLinClrLst/>
+    <dgm:txFillClrLst/>
+    <dgm:txEffectClrLst/>
+  </dgm:styleLbl>
+  <dgm:styleLbl name="bgSibTrans2D1">
+    <dgm:fillClrLst meth="repeat">
+      <a:schemeClr val="accent1">
+        <a:tint val="60000"/>
+      </a:schemeClr>
+    </dgm:fillClrLst>
+    <dgm:linClrLst meth="repeat">
+      <a:schemeClr val="accent1">
+        <a:tint val="60000"/>
+      </a:schemeClr>
+    </dgm:linClrLst>
+    <dgm:effectClrLst/>
+    <dgm:txLinClrLst/>
+    <dgm:txFillClrLst/>
+    <dgm:txEffectClrLst/>
+  </dgm:styleLbl>
+  <dgm:styleLbl name="sibTrans1D1">
+    <dgm:fillClrLst meth="repeat">
+      <a:schemeClr val="accent1"/>
+    </dgm:fillClrLst>
+    <dgm:linClrLst meth="repeat">
+      <a:schemeClr val="accent1"/>
+    </dgm:linClrLst>
+    <dgm:effectClrLst/>
+    <dgm:txLinClrLst/>
+    <dgm:txFillClrLst meth="repeat">
+      <a:schemeClr val="tx1"/>
+    </dgm:txFillClrLst>
+    <dgm:txEffectClrLst/>
+  </dgm:styleLbl>
+  <dgm:styleLbl name="callout">
+    <dgm:fillClrLst meth="repeat">
+      <a:schemeClr val="accent1"/>
+    </dgm:fillClrLst>
+    <dgm:linClrLst meth="repeat">
+      <a:schemeClr val="accent1">
+        <a:tint val="50000"/>
+      </a:schemeClr>
+    </dgm:linClrLst>
+    <dgm:effectClrLst/>
+    <dgm:txLinClrLst/>
+    <dgm:txFillClrLst meth="repeat">
+      <a:schemeClr val="tx1"/>
+    </dgm:txFillClrLst>
+    <dgm:txEffectClrLst/>
+  </dgm:styleLbl>
+  <dgm:styleLbl name="asst0">
+    <dgm:fillClrLst meth="repeat">
+      <a:schemeClr val="accent1"/>
+    </dgm:fillClrLst>
+    <dgm:linClrLst meth="repeat">
+      <a:schemeClr val="lt1"/>
+    </dgm:linClrLst>
+    <dgm:effectClrLst/>
+    <dgm:txLinClrLst/>
+    <dgm:txFillClrLst/>
+    <dgm:txEffectClrLst/>
+  </dgm:styleLbl>
+  <dgm:styleLbl name="asst1">
+    <dgm:fillClrLst meth="repeat">
+      <a:schemeClr val="accent1"/>
+    </dgm:fillClrLst>
+    <dgm:linClrLst meth="repeat">
+      <a:schemeClr val="lt1"/>
+    </dgm:linClrLst>
+    <dgm:effectClrLst/>
+    <dgm:txLinClrLst/>
+    <dgm:txFillClrLst/>
+    <dgm:txEffectClrLst/>
+  </dgm:styleLbl>
+  <dgm:styleLbl name="asst2">
+    <dgm:fillClrLst meth="repeat">
+      <a:schemeClr val="accent1"/>
+    </dgm:fillClrLst>
+    <dgm:linClrLst meth="repeat">
+      <a:schemeClr val="lt1"/>
+    </dgm:linClrLst>
+    <dgm:effectClrLst/>
+    <dgm:txLinClrLst/>
+    <dgm:txFillClrLst/>
+    <dgm:txEffectClrLst/>
+  </dgm:styleLbl>
+  <dgm:styleLbl name="asst3">
+    <dgm:fillClrLst meth="repeat">
+      <a:schemeClr val="accent1"/>
+    </dgm:fillClrLst>
+    <dgm:linClrLst meth="repeat">
+      <a:schemeClr val="lt1"/>
+    </dgm:linClrLst>
+    <dgm:effectClrLst/>
+    <dgm:txLinClrLst/>
+    <dgm:txFillClrLst/>
+    <dgm:txEffectClrLst/>
+  </dgm:styleLbl>
+  <dgm:styleLbl name="asst4">
+    <dgm:fillClrLst meth="repeat">
+      <a:schemeClr val="accent1"/>
+    </dgm:fillClrLst>
+    <dgm:linClrLst meth="repeat">
+      <a:schemeClr val="lt1"/>
+    </dgm:linClrLst>
+    <dgm:effectClrLst/>
+    <dgm:txLinClrLst/>
+    <dgm:txFillClrLst/>
+    <dgm:txEffectClrLst/>
+  </dgm:styleLbl>
+  <dgm:styleLbl name="parChTrans2D1">
+    <dgm:fillClrLst meth="repeat">
+      <a:schemeClr val="accent1">
+        <a:tint val="60000"/>
+      </a:schemeClr>
+    </dgm:fillClrLst>
+    <dgm:linClrLst meth="repeat">
+      <a:schemeClr val="accent1">
+        <a:tint val="60000"/>
+      </a:schemeClr>
+    </dgm:linClrLst>
+    <dgm:effectClrLst/>
+    <dgm:txLinClrLst/>
+    <dgm:txFillClrLst meth="repeat">
+      <a:schemeClr val="lt1"/>
+    </dgm:txFillClrLst>
+    <dgm:txEffectClrLst/>
+  </dgm:styleLbl>
+  <dgm:styleLbl name="parChTrans2D2">
+    <dgm:fillClrLst meth="repeat">
+      <a:schemeClr val="accent1"/>
+    </dgm:fillClrLst>
+    <dgm:linClrLst meth="repeat">
+      <a:schemeClr val="accent1"/>
+    </dgm:linClrLst>
+    <dgm:effectClrLst/>
+    <dgm:txLinClrLst/>
+    <dgm:txFillClrLst meth="repeat">
+      <a:schemeClr val="lt1"/>
+    </dgm:txFillClrLst>
+    <dgm:txEffectClrLst/>
+  </dgm:styleLbl>
+  <dgm:styleLbl name="parChTrans2D3">
+    <dgm:fillClrLst meth="repeat">
+      <a:schemeClr val="accent1"/>
+    </dgm:fillClrLst>
+    <dgm:linClrLst meth="repeat">
+      <a:schemeClr val="accent1"/>
+    </dgm:linClrLst>
+    <dgm:effectClrLst/>
+    <dgm:txLinClrLst/>
+    <dgm:txFillClrLst meth="repeat">
+      <a:schemeClr val="lt1"/>
+    </dgm:txFillClrLst>
+    <dgm:txEffectClrLst/>
+  </dgm:styleLbl>
+  <dgm:styleLbl name="parChTrans2D4">
+    <dgm:fillClrLst meth="repeat">
+      <a:schemeClr val="accent1"/>
+    </dgm:fillClrLst>
+    <dgm:linClrLst meth="repeat">
+      <a:schemeClr val="accent1"/>
+    </dgm:linClrLst>
+    <dgm:effectClrLst/>
+    <dgm:txLinClrLst/>
+    <dgm:txFillClrLst meth="repeat">
+      <a:schemeClr val="lt1"/>
+    </dgm:txFillClrLst>
+    <dgm:txEffectClrLst/>
+  </dgm:styleLbl>
+  <dgm:styleLbl name="parChTrans1D1">
+    <dgm:fillClrLst meth="repeat">
+      <a:schemeClr val="accent1"/>
+    </dgm:fillClrLst>
+    <dgm:linClrLst meth="repeat">
+      <a:schemeClr val="accent1">
+        <a:shade val="60000"/>
+      </a:schemeClr>
+    </dgm:linClrLst>
+    <dgm:effectClrLst/>
+    <dgm:txLinClrLst/>
+    <dgm:txFillClrLst meth="repeat">
+      <a:schemeClr val="tx1"/>
+    </dgm:txFillClrLst>
+    <dgm:txEffectClrLst/>
+  </dgm:styleLbl>
+  <dgm:styleLbl name="parChTrans1D2">
+    <dgm:fillClrLst meth="repeat">
+      <a:schemeClr val="accent1"/>
+    </dgm:fillClrLst>
+    <dgm:linClrLst meth="repeat">
+      <a:schemeClr val="accent1">
+        <a:shade val="60000"/>
+      </a:schemeClr>
+    </dgm:linClrLst>
+    <dgm:effectClrLst/>
+    <dgm:txLinClrLst/>
+    <dgm:txFillClrLst meth="repeat">
+      <a:schemeClr val="tx1"/>
+    </dgm:txFillClrLst>
+    <dgm:txEffectClrLst/>
+  </dgm:styleLbl>
+  <dgm:styleLbl name="parChTrans1D3">
+    <dgm:fillClrLst meth="repeat">
+      <a:schemeClr val="accent1"/>
+    </dgm:fillClrLst>
+    <dgm:linClrLst meth="repeat">
+      <a:schemeClr val="accent1">
+        <a:shade val="80000"/>
+      </a:schemeClr>
+    </dgm:linClrLst>
+    <dgm:effectClrLst/>
+    <dgm:txLinClrLst/>
+    <dgm:txFillClrLst meth="repeat">
+      <a:schemeClr val="tx1"/>
+    </dgm:txFillClrLst>
+    <dgm:txEffectClrLst/>
+  </dgm:styleLbl>
+  <dgm:styleLbl name="parChTrans1D4">
+    <dgm:fillClrLst meth="repeat">
+      <a:schemeClr val="accent1"/>
+    </dgm:fillClrLst>
+    <dgm:linClrLst meth="repeat">
+      <a:schemeClr val="accent1">
+        <a:shade val="80000"/>
+      </a:schemeClr>
+    </dgm:linClrLst>
+    <dgm:effectClrLst/>
+    <dgm:txLinClrLst/>
+    <dgm:txFillClrLst meth="repeat">
+      <a:schemeClr val="tx1"/>
+    </dgm:txFillClrLst>
+    <dgm:txEffectClrLst/>
+  </dgm:styleLbl>
+  <dgm:styleLbl name="fgAcc1">
+    <dgm:fillClrLst meth="repeat">
+      <a:schemeClr val="lt1">
+        <a:alpha val="90000"/>
+      </a:schemeClr>
+    </dgm:fillClrLst>
+    <dgm:linClrLst meth="repeat">
+      <a:schemeClr val="accent1"/>
+    </dgm:linClrLst>
+    <dgm:effectClrLst/>
+    <dgm:txLinClrLst/>
+    <dgm:txFillClrLst meth="repeat">
+      <a:schemeClr val="dk1"/>
+    </dgm:txFillClrLst>
+    <dgm:txEffectClrLst/>
+  </dgm:styleLbl>
+  <dgm:styleLbl name="conFgAcc1">
+    <dgm:fillClrLst meth="repeat">
+      <a:schemeClr val="lt1">
+        <a:alpha val="90000"/>
+      </a:schemeClr>
+    </dgm:fillClrLst>
+    <dgm:linClrLst meth="repeat">
+      <a:schemeClr val="accent1"/>
+    </dgm:linClrLst>
+    <dgm:effectClrLst/>
+    <dgm:txLinClrLst/>
+    <dgm:txFillClrLst meth="repeat">
+      <a:schemeClr val="dk1"/>
+    </dgm:txFillClrLst>
+    <dgm:txEffectClrLst/>
+  </dgm:styleLbl>
+  <dgm:styleLbl name="alignAcc1">
+    <dgm:fillClrLst meth="repeat">
+      <a:schemeClr val="lt1">
+        <a:alpha val="90000"/>
+      </a:schemeClr>
+    </dgm:fillClrLst>
+    <dgm:linClrLst meth="repeat">
+      <a:schemeClr val="accent1"/>
+    </dgm:linClrLst>
+    <dgm:effectClrLst/>
+    <dgm:txLinClrLst/>
+    <dgm:txFillClrLst meth="repeat">
+      <a:schemeClr val="dk1"/>
+    </dgm:txFillClrLst>
+    <dgm:txEffectClrLst/>
+  </dgm:styleLbl>
+  <dgm:styleLbl name="trAlignAcc1">
+    <dgm:fillClrLst meth="repeat">
+      <a:schemeClr val="lt1">
+        <a:alpha val="40000"/>
+      </a:schemeClr>
+    </dgm:fillClrLst>
+    <dgm:linClrLst meth="repeat">
+      <a:schemeClr val="accent1"/>
+    </dgm:linClrLst>
+    <dgm:effectClrLst/>
+    <dgm:txLinClrLst/>
+    <dgm:txFillClrLst meth="repeat">
+      <a:schemeClr val="dk1"/>
+    </dgm:txFillClrLst>
+    <dgm:txEffectClrLst/>
+  </dgm:styleLbl>
+  <dgm:styleLbl name="bgAcc1">
+    <dgm:fillClrLst meth="repeat">
+      <a:schemeClr val="lt1">
+        <a:alpha val="90000"/>
+      </a:schemeClr>
+    </dgm:fillClrLst>
+    <dgm:linClrLst meth="repeat">
+      <a:schemeClr val="accent1"/>
+    </dgm:linClrLst>
+    <dgm:effectClrLst/>
+    <dgm:txLinClrLst/>
+    <dgm:txFillClrLst meth="repeat">
+      <a:schemeClr val="dk1"/>
+    </dgm:txFillClrLst>
+    <dgm:txEffectClrLst/>
+  </dgm:styleLbl>
+  <dgm:styleLbl name="solidFgAcc1">
+    <dgm:fillClrLst meth="repeat">
+      <a:schemeClr val="lt1"/>
+    </dgm:fillClrLst>
+    <dgm:linClrLst meth="repeat">
+      <a:schemeClr val="accent1"/>
+    </dgm:linClrLst>
+    <dgm:effectClrLst/>
+    <dgm:txLinClrLst/>
+    <dgm:txFillClrLst meth="repeat">
+      <a:schemeClr val="dk1"/>
+    </dgm:txFillClrLst>
+    <dgm:txEffectClrLst/>
+  </dgm:styleLbl>
+  <dgm:styleLbl name="solidAlignAcc1">
+    <dgm:fillClrLst meth="repeat">
+      <a:schemeClr val="lt1"/>
+    </dgm:fillClrLst>
+    <dgm:linClrLst meth="repeat">
+      <a:schemeClr val="accent1"/>
+    </dgm:linClrLst>
+    <dgm:effectClrLst/>
+    <dgm:txLinClrLst/>
+    <dgm:txFillClrLst meth="repeat">
+      <a:schemeClr val="dk1"/>
+    </dgm:txFillClrLst>
+    <dgm:txEffectClrLst/>
+  </dgm:styleLbl>
+  <dgm:styleLbl name="solidBgAcc1">
+    <dgm:fillClrLst meth="repeat">
+      <a:schemeClr val="lt1"/>
+    </dgm:fillClrLst>
+    <dgm:linClrLst meth="repeat">
+      <a:schemeClr val="accent1"/>
+    </dgm:linClrLst>
+    <dgm:effectClrLst/>
+    <dgm:txLinClrLst/>
+    <dgm:txFillClrLst meth="repeat">
+      <a:schemeClr val="dk1"/>
+    </dgm:txFillClrLst>
+    <dgm:txEffectClrLst/>
+  </dgm:styleLbl>
+  <dgm:styleLbl name="fgAccFollowNode1">
+    <dgm:fillClrLst meth="repeat">
+      <a:schemeClr val="accent1">
+        <a:alpha val="90000"/>
+        <a:tint val="40000"/>
+      </a:schemeClr>
+    </dgm:fillClrLst>
+    <dgm:linClrLst meth="repeat">
+      <a:schemeClr val="accent1">
+        <a:alpha val="90000"/>
+        <a:tint val="40000"/>
+      </a:schemeClr>
+    </dgm:linClrLst>
+    <dgm:effectClrLst/>
+    <dgm:txLinClrLst/>
+    <dgm:txFillClrLst meth="repeat">
+      <a:schemeClr val="dk1"/>
+    </dgm:txFillClrLst>
+    <dgm:txEffectClrLst/>
+  </dgm:styleLbl>
+  <dgm:styleLbl name="alignAccFollowNode1">
+    <dgm:fillClrLst meth="repeat">
+      <a:schemeClr val="accent1">
+        <a:alpha val="90000"/>
+        <a:tint val="40000"/>
+      </a:schemeClr>
+    </dgm:fillClrLst>
+    <dgm:linClrLst meth="repeat">
+      <a:schemeClr val="accent1">
+        <a:alpha val="90000"/>
+        <a:tint val="40000"/>
+      </a:schemeClr>
+    </dgm:linClrLst>
+    <dgm:effectClrLst/>
+    <dgm:txLinClrLst/>
+    <dgm:txFillClrLst meth="repeat">
+      <a:schemeClr val="dk1"/>
+    </dgm:txFillClrLst>
+    <dgm:txEffectClrLst/>
+  </dgm:styleLbl>
+  <dgm:styleLbl name="bgAccFollowNode1">
+    <dgm:fillClrLst meth="repeat">
+      <a:schemeClr val="accent1">
+        <a:alpha val="90000"/>
+        <a:tint val="40000"/>
+      </a:schemeClr>
+    </dgm:fillClrLst>
+    <dgm:linClrLst meth="repeat">
+      <a:schemeClr val="accent1">
+        <a:alpha val="90000"/>
+        <a:tint val="40000"/>
+      </a:schemeClr>
+    </dgm:linClrLst>
+    <dgm:effectClrLst/>
+    <dgm:txLinClrLst/>
+    <dgm:txFillClrLst meth="repeat">
+      <a:schemeClr val="dk1"/>
+    </dgm:txFillClrLst>
+    <dgm:txEffectClrLst/>
+  </dgm:styleLbl>
+  <dgm:styleLbl name="fgAcc0">
+    <dgm:fillClrLst meth="repeat">
+      <a:schemeClr val="lt1">
+        <a:alpha val="90000"/>
+      </a:schemeClr>
+    </dgm:fillClrLst>
+    <dgm:linClrLst meth="repeat">
+      <a:schemeClr val="accent1"/>
+    </dgm:linClrLst>
+    <dgm:effectClrLst/>
+    <dgm:txLinClrLst/>
+    <dgm:txFillClrLst meth="repeat">
+      <a:schemeClr val="dk1"/>
+    </dgm:txFillClrLst>
+    <dgm:txEffectClrLst/>
+  </dgm:styleLbl>
+  <dgm:styleLbl name="fgAcc2">
+    <dgm:fillClrLst meth="repeat">
+      <a:schemeClr val="lt1">
+        <a:alpha val="90000"/>
+      </a:schemeClr>
+    </dgm:fillClrLst>
+    <dgm:linClrLst meth="repeat">
+      <a:schemeClr val="accent1"/>
+    </dgm:linClrLst>
+    <dgm:effectClrLst/>
+    <dgm:txLinClrLst/>
+    <dgm:txFillClrLst meth="repeat">
+      <a:schemeClr val="dk1"/>
+    </dgm:txFillClrLst>
+    <dgm:txEffectClrLst/>
+  </dgm:styleLbl>
+  <dgm:styleLbl name="fgAcc3">
+    <dgm:fillClrLst meth="repeat">
+      <a:schemeClr val="lt1">
+        <a:alpha val="90000"/>
+      </a:schemeClr>
+    </dgm:fillClrLst>
+    <dgm:linClrLst meth="repeat">
+      <a:schemeClr val="accent1"/>
+    </dgm:linClrLst>
+    <dgm:effectClrLst/>
+    <dgm:txLinClrLst/>
+    <dgm:txFillClrLst meth="repeat">
+      <a:schemeClr val="dk1"/>
+    </dgm:txFillClrLst>
+    <dgm:txEffectClrLst/>
+  </dgm:styleLbl>
+  <dgm:styleLbl name="fgAcc4">
+    <dgm:fillClrLst meth="repeat">
+      <a:schemeClr val="lt1">
+        <a:alpha val="90000"/>
+      </a:schemeClr>
+    </dgm:fillClrLst>
+    <dgm:linClrLst meth="repeat">
+      <a:schemeClr val="accent1"/>
+    </dgm:linClrLst>
+    <dgm:effectClrLst/>
+    <dgm:txLinClrLst/>
+    <dgm:txFillClrLst meth="repeat">
+      <a:schemeClr val="dk1"/>
+    </dgm:txFillClrLst>
+    <dgm:txEffectClrLst/>
+  </dgm:styleLbl>
+  <dgm:styleLbl name="bgShp">
+    <dgm:fillClrLst meth="repeat">
+      <a:schemeClr val="accent1">
+        <a:tint val="40000"/>
+      </a:schemeClr>
+    </dgm:fillClrLst>
+    <dgm:linClrLst meth="repeat">
+      <a:schemeClr val="accent1"/>
+    </dgm:linClrLst>
+    <dgm:effectClrLst/>
+    <dgm:txLinClrLst/>
+    <dgm:txFillClrLst meth="repeat">
+      <a:schemeClr val="dk1"/>
+    </dgm:txFillClrLst>
+    <dgm:txEffectClrLst/>
+  </dgm:styleLbl>
+  <dgm:styleLbl name="dkBgShp">
+    <dgm:fillClrLst meth="repeat">
+      <a:schemeClr val="accent1">
+        <a:shade val="80000"/>
+      </a:schemeClr>
+    </dgm:fillClrLst>
+    <dgm:linClrLst meth="repeat">
+      <a:schemeClr val="accent1"/>
+    </dgm:linClrLst>
+    <dgm:effectClrLst/>
+    <dgm:txLinClrLst/>
+    <dgm:txFillClrLst meth="repeat">
+      <a:schemeClr val="lt1"/>
+    </dgm:txFillClrLst>
+    <dgm:txEffectClrLst/>
+  </dgm:styleLbl>
+  <dgm:styleLbl name="trBgShp">
+    <dgm:fillClrLst meth="repeat">
+      <a:schemeClr val="accent1">
+        <a:tint val="50000"/>
+        <a:alpha val="40000"/>
+      </a:schemeClr>
+    </dgm:fillClrLst>
+    <dgm:linClrLst meth="repeat">
+      <a:schemeClr val="accent1"/>
+    </dgm:linClrLst>
+    <dgm:effectClrLst/>
+    <dgm:txLinClrLst/>
+    <dgm:txFillClrLst meth="repeat">
+      <a:schemeClr val="lt1"/>
+    </dgm:txFillClrLst>
+    <dgm:txEffectClrLst/>
+  </dgm:styleLbl>
+  <dgm:styleLbl name="fgShp">
+    <dgm:fillClrLst meth="repeat">
+      <a:schemeClr val="accent1">
+        <a:tint val="60000"/>
+      </a:schemeClr>
+    </dgm:fillClrLst>
+    <dgm:linClrLst meth="repeat">
+      <a:schemeClr val="lt1"/>
+    </dgm:linClrLst>
+    <dgm:effectClrLst/>
+    <dgm:txLinClrLst/>
+    <dgm:txFillClrLst meth="repeat">
+      <a:schemeClr val="dk1"/>
+    </dgm:txFillClrLst>
+    <dgm:txEffectClrLst/>
+  </dgm:styleLbl>
+  <dgm:styleLbl name="revTx">
+    <dgm:fillClrLst meth="repeat">
+      <a:schemeClr val="lt1">
+        <a:alpha val="0"/>
+      </a:schemeClr>
+    </dgm:fillClrLst>
+    <dgm:linClrLst meth="repeat">
+      <a:schemeClr val="dk1">
+        <a:alpha val="0"/>
+      </a:schemeClr>
+    </dgm:linClrLst>
+    <dgm:effectClrLst/>
+    <dgm:txLinClrLst/>
+    <dgm:txFillClrLst meth="repeat">
+      <a:schemeClr val="tx1"/>
+    </dgm:txFillClrLst>
+    <dgm:txEffectClrLst/>
+  </dgm:styleLbl>
+</dgm:colorsDef>
+</file>
+
+<file path=ppt/diagrams/colors3.xml><?xml version="1.0" encoding="utf-8"?>
 <dgm:colorsDef xmlns:dgm="http://schemas.openxmlformats.org/drawingml/2006/diagram" xmlns:a="http://schemas.openxmlformats.org/drawingml/2006/main" uniqueId="urn:microsoft.com/office/officeart/2005/8/colors/accent1_2">
   <dgm:title val=""/>
   <dgm:desc val=""/>
@@ -2607,6 +3355,115 @@
 </dgm:dataModel>
 </file>
 
+<file path=ppt/diagrams/data4.xml><?xml version="1.0" encoding="utf-8"?>
+<dgm:dataModel xmlns:dgm="http://schemas.openxmlformats.org/drawingml/2006/diagram" xmlns:a="http://schemas.openxmlformats.org/drawingml/2006/main">
+  <dgm:ptLst>
+    <dgm:pt modelId="{9E85A773-D9BF-4D40-9E6A-4BF4EFDB69D2}" type="doc">
+      <dgm:prSet loTypeId="urn:microsoft.com/office/officeart/2024/layout/HorizontalActionList" loCatId="list" qsTypeId="urn:microsoft.com/office/officeart/2005/8/quickstyle/simple1" qsCatId="simple" csTypeId="urn:microsoft.com/office/officeart/2005/8/colors/accent1_2" csCatId="accent1" phldr="1"/>
+      <dgm:spPr/>
+      <dgm:t>
+        <a:bodyPr/>
+        <a:lstStyle/>
+        <a:p>
+          <a:endParaRPr lang="nl-BE"/>
+        </a:p>
+      </dgm:t>
+    </dgm:pt>
+    <dgm:pt modelId="{D897B666-ABBD-4E93-AF3A-510746A7F42F}">
+      <dgm:prSet phldrT="[Tekst]" phldr="0" custT="1"/>
+      <dgm:spPr/>
+      <dgm:t>
+        <a:bodyPr/>
+        <a:lstStyle/>
+        <a:p>
+          <a:r>
+            <a:rPr lang="en-US" sz="1600" dirty="0"/>
+            <a:t>Render segments: far to near</a:t>
+          </a:r>
+          <a:endParaRPr lang="nl-BE" sz="1600" dirty="0"/>
+        </a:p>
+      </dgm:t>
+    </dgm:pt>
+    <dgm:pt modelId="{A9AE9D1E-6A40-4FBF-A864-76BF176969E9}" type="parTrans" cxnId="{F88CB7DD-2C7C-40BF-960D-AAA0016A557B}">
+      <dgm:prSet/>
+      <dgm:spPr/>
+      <dgm:t>
+        <a:bodyPr/>
+        <a:lstStyle/>
+        <a:p>
+          <a:endParaRPr lang="nl-BE"/>
+        </a:p>
+      </dgm:t>
+    </dgm:pt>
+    <dgm:pt modelId="{5DCA0BFB-CF12-4EA2-A484-47D3ACEDCBD9}" type="sibTrans" cxnId="{F88CB7DD-2C7C-40BF-960D-AAA0016A557B}">
+      <dgm:prSet/>
+      <dgm:spPr/>
+      <dgm:t>
+        <a:bodyPr/>
+        <a:lstStyle/>
+        <a:p>
+          <a:endParaRPr lang="nl-BE"/>
+        </a:p>
+      </dgm:t>
+    </dgm:pt>
+    <dgm:pt modelId="{5CF902B4-BEAD-40BD-94A2-28B436A03C85}" type="pres">
+      <dgm:prSet presAssocID="{9E85A773-D9BF-4D40-9E6A-4BF4EFDB69D2}" presName="Name0" presStyleCnt="0">
+        <dgm:presLayoutVars>
+          <dgm:dir/>
+          <dgm:animLvl val="lvl"/>
+          <dgm:resizeHandles val="exact"/>
+        </dgm:presLayoutVars>
+      </dgm:prSet>
+      <dgm:spPr/>
+    </dgm:pt>
+    <dgm:pt modelId="{50344753-7736-4087-8784-B2F368EBEB67}" type="pres">
+      <dgm:prSet presAssocID="{D897B666-ABBD-4E93-AF3A-510746A7F42F}" presName="composite" presStyleCnt="0"/>
+      <dgm:spPr/>
+    </dgm:pt>
+    <dgm:pt modelId="{0E212F84-7E44-498C-9BA2-9A97CD663A75}" type="pres">
+      <dgm:prSet presAssocID="{D897B666-ABBD-4E93-AF3A-510746A7F42F}" presName="parTx" presStyleLbl="alignNode1" presStyleIdx="0" presStyleCnt="1">
+        <dgm:presLayoutVars>
+          <dgm:chMax val="0"/>
+          <dgm:chPref val="0"/>
+        </dgm:presLayoutVars>
+      </dgm:prSet>
+      <dgm:spPr/>
+    </dgm:pt>
+    <dgm:pt modelId="{4A53E8B5-2823-4717-8317-6CB2437F8960}" type="pres">
+      <dgm:prSet presAssocID="{D897B666-ABBD-4E93-AF3A-510746A7F42F}" presName="bgOutline" presStyleLbl="fgAcc1" presStyleIdx="0" presStyleCnt="1">
+        <dgm:presLayoutVars>
+          <dgm:bulletEnabled/>
+        </dgm:presLayoutVars>
+      </dgm:prSet>
+      <dgm:spPr>
+        <a:blipFill rotWithShape="0">
+          <a:blip xmlns:r="http://schemas.openxmlformats.org/officeDocument/2006/relationships" r:embed="rId1"/>
+          <a:srcRect/>
+          <a:stretch>
+            <a:fillRect l="-6000" r="-6000"/>
+          </a:stretch>
+        </a:blipFill>
+      </dgm:spPr>
+    </dgm:pt>
+  </dgm:ptLst>
+  <dgm:cxnLst>
+    <dgm:cxn modelId="{74F3EBB4-BE09-4FAD-AA09-EADA69846853}" type="presOf" srcId="{9E85A773-D9BF-4D40-9E6A-4BF4EFDB69D2}" destId="{5CF902B4-BEAD-40BD-94A2-28B436A03C85}" srcOrd="0" destOrd="0" presId="urn:microsoft.com/office/officeart/2024/layout/HorizontalActionList"/>
+    <dgm:cxn modelId="{20C6FECD-6010-40D8-A2E3-7AB145FB35E9}" type="presOf" srcId="{D897B666-ABBD-4E93-AF3A-510746A7F42F}" destId="{0E212F84-7E44-498C-9BA2-9A97CD663A75}" srcOrd="0" destOrd="0" presId="urn:microsoft.com/office/officeart/2024/layout/HorizontalActionList"/>
+    <dgm:cxn modelId="{F88CB7DD-2C7C-40BF-960D-AAA0016A557B}" srcId="{9E85A773-D9BF-4D40-9E6A-4BF4EFDB69D2}" destId="{D897B666-ABBD-4E93-AF3A-510746A7F42F}" srcOrd="0" destOrd="0" parTransId="{A9AE9D1E-6A40-4FBF-A864-76BF176969E9}" sibTransId="{5DCA0BFB-CF12-4EA2-A484-47D3ACEDCBD9}"/>
+    <dgm:cxn modelId="{5114B513-7225-4E40-B9D2-82F6AB52B0BE}" type="presParOf" srcId="{5CF902B4-BEAD-40BD-94A2-28B436A03C85}" destId="{50344753-7736-4087-8784-B2F368EBEB67}" srcOrd="0" destOrd="0" presId="urn:microsoft.com/office/officeart/2024/layout/HorizontalActionList"/>
+    <dgm:cxn modelId="{8BB9BAF9-3DB2-444B-A50E-FC848CA29E32}" type="presParOf" srcId="{50344753-7736-4087-8784-B2F368EBEB67}" destId="{0E212F84-7E44-498C-9BA2-9A97CD663A75}" srcOrd="0" destOrd="0" presId="urn:microsoft.com/office/officeart/2024/layout/HorizontalActionList"/>
+    <dgm:cxn modelId="{44F2909C-68FB-493E-87F6-86EE40A08BC0}" type="presParOf" srcId="{50344753-7736-4087-8784-B2F368EBEB67}" destId="{4A53E8B5-2823-4717-8317-6CB2437F8960}" srcOrd="1" destOrd="0" presId="urn:microsoft.com/office/officeart/2024/layout/HorizontalActionList"/>
+  </dgm:cxnLst>
+  <dgm:bg/>
+  <dgm:whole/>
+  <dgm:extLst>
+    <a:ext uri="http://schemas.microsoft.com/office/drawing/2008/diagram">
+      <dsp:dataModelExt xmlns:dsp="http://schemas.microsoft.com/office/drawing/2008/diagram" relId="rId6" minVer="http://schemas.openxmlformats.org/drawingml/2006/diagram"/>
+    </a:ext>
+  </dgm:extLst>
+</dgm:dataModel>
+</file>
+
 <file path=ppt/diagrams/drawing1.xml><?xml version="1.0" encoding="utf-8"?>
 <dsp:drawing xmlns:dgm="http://schemas.openxmlformats.org/drawingml/2006/diagram" xmlns:dsp="http://schemas.microsoft.com/office/drawing/2008/diagram" xmlns:a="http://schemas.openxmlformats.org/drawingml/2006/main">
   <dsp:spTree>
@@ -3536,12 +4393,156 @@
 </dsp:drawing>
 </file>
 
+<file path=ppt/diagrams/drawing3.xml><?xml version="1.0" encoding="utf-8"?>
+<dsp:drawing xmlns:dgm="http://schemas.openxmlformats.org/drawingml/2006/diagram" xmlns:dsp="http://schemas.microsoft.com/office/drawing/2008/diagram" xmlns:a="http://schemas.openxmlformats.org/drawingml/2006/main">
+  <dsp:spTree>
+    <dsp:nvGrpSpPr>
+      <dsp:cNvPr id="0" name=""/>
+      <dsp:cNvGrpSpPr/>
+    </dsp:nvGrpSpPr>
+    <dsp:grpSpPr/>
+    <dsp:sp modelId="{4A53E8B5-2823-4717-8317-6CB2437F8960}">
+      <dsp:nvSpPr>
+        <dsp:cNvPr id="0" name=""/>
+        <dsp:cNvSpPr/>
+      </dsp:nvSpPr>
+      <dsp:spPr>
+        <a:xfrm rot="10800000">
+          <a:off x="1414" y="921483"/>
+          <a:ext cx="2894374" cy="2168133"/>
+        </a:xfrm>
+        <a:prstGeom prst="round2SameRect">
+          <a:avLst>
+            <a:gd name="adj1" fmla="val 15000"/>
+            <a:gd name="adj2" fmla="val 0"/>
+          </a:avLst>
+        </a:prstGeom>
+        <a:blipFill rotWithShape="0">
+          <a:blip xmlns:r="http://schemas.openxmlformats.org/officeDocument/2006/relationships" r:embed="rId1"/>
+          <a:srcRect/>
+          <a:stretch>
+            <a:fillRect l="-6000" r="-6000"/>
+          </a:stretch>
+        </a:blipFill>
+        <a:ln w="19050" cap="flat" cmpd="sng" algn="ctr">
+          <a:solidFill>
+            <a:schemeClr val="accent1">
+              <a:hueOff val="0"/>
+              <a:satOff val="0"/>
+              <a:lumOff val="0"/>
+              <a:alphaOff val="0"/>
+            </a:schemeClr>
+          </a:solidFill>
+          <a:prstDash val="solid"/>
+          <a:miter lim="800000"/>
+        </a:ln>
+        <a:effectLst/>
+      </dsp:spPr>
+      <dsp:style>
+        <a:lnRef idx="2">
+          <a:scrgbClr r="0" g="0" b="0"/>
+        </a:lnRef>
+        <a:fillRef idx="1">
+          <a:scrgbClr r="0" g="0" b="0"/>
+        </a:fillRef>
+        <a:effectRef idx="0">
+          <a:scrgbClr r="0" g="0" b="0"/>
+        </a:effectRef>
+        <a:fontRef idx="minor"/>
+      </dsp:style>
+    </dsp:sp>
+    <dsp:sp modelId="{0E212F84-7E44-498C-9BA2-9A97CD663A75}">
+      <dsp:nvSpPr>
+        <dsp:cNvPr id="0" name=""/>
+        <dsp:cNvSpPr/>
+      </dsp:nvSpPr>
+      <dsp:spPr>
+        <a:xfrm>
+          <a:off x="1414" y="79220"/>
+          <a:ext cx="2894374" cy="868312"/>
+        </a:xfrm>
+        <a:prstGeom prst="round2SameRect">
+          <a:avLst>
+            <a:gd name="adj1" fmla="val 45000"/>
+            <a:gd name="adj2" fmla="val 0"/>
+          </a:avLst>
+        </a:prstGeom>
+        <a:solidFill>
+          <a:schemeClr val="accent1">
+            <a:hueOff val="0"/>
+            <a:satOff val="0"/>
+            <a:lumOff val="0"/>
+            <a:alphaOff val="0"/>
+          </a:schemeClr>
+        </a:solidFill>
+        <a:ln w="19050" cap="flat" cmpd="sng" algn="ctr">
+          <a:solidFill>
+            <a:schemeClr val="accent1">
+              <a:hueOff val="0"/>
+              <a:satOff val="0"/>
+              <a:lumOff val="0"/>
+              <a:alphaOff val="0"/>
+            </a:schemeClr>
+          </a:solidFill>
+          <a:prstDash val="solid"/>
+          <a:miter lim="800000"/>
+        </a:ln>
+        <a:effectLst/>
+      </dsp:spPr>
+      <dsp:style>
+        <a:lnRef idx="2">
+          <a:scrgbClr r="0" g="0" b="0"/>
+        </a:lnRef>
+        <a:fillRef idx="1">
+          <a:scrgbClr r="0" g="0" b="0"/>
+        </a:fillRef>
+        <a:effectRef idx="0">
+          <a:scrgbClr r="0" g="0" b="0"/>
+        </a:effectRef>
+        <a:fontRef idx="minor">
+          <a:schemeClr val="lt1"/>
+        </a:fontRef>
+      </dsp:style>
+      <dsp:txBody>
+        <a:bodyPr spcFirstLastPara="0" vert="horz" wrap="square" lIns="228720" tIns="228720" rIns="228720" bIns="228720" numCol="1" spcCol="1270" anchor="ctr" anchorCtr="0">
+          <a:noAutofit/>
+        </a:bodyPr>
+        <a:lstStyle/>
+        <a:p>
+          <a:pPr marL="0" lvl="0" indent="0" algn="l" defTabSz="711200">
+            <a:lnSpc>
+              <a:spcPct val="90000"/>
+            </a:lnSpc>
+            <a:spcBef>
+              <a:spcPct val="0"/>
+            </a:spcBef>
+            <a:spcAft>
+              <a:spcPct val="35000"/>
+            </a:spcAft>
+            <a:buNone/>
+          </a:pPr>
+          <a:r>
+            <a:rPr lang="en-US" sz="1600" kern="1200" dirty="0"/>
+            <a:t>Render segments: far to near</a:t>
+          </a:r>
+          <a:endParaRPr lang="nl-BE" sz="1600" kern="1200" dirty="0"/>
+        </a:p>
+      </dsp:txBody>
+      <dsp:txXfrm>
+        <a:off x="115858" y="193664"/>
+        <a:ext cx="2665486" cy="753868"/>
+      </dsp:txXfrm>
+    </dsp:sp>
+  </dsp:spTree>
+</dsp:drawing>
+</file>
+
 <file path=ppt/diagrams/layout1.xml><?xml version="1.0" encoding="utf-8"?>
 <dgm:layoutDef xmlns:dgm="http://schemas.openxmlformats.org/drawingml/2006/diagram" xmlns:a="http://schemas.openxmlformats.org/drawingml/2006/main" uniqueId="urn:microsoft.com/office/officeart/2024/layout/HorizontalActionList">
   <dgm:title val=""/>
   <dgm:desc val=""/>
   <dgm:catLst>
-    <dgm:cat type="list" pri="8050"/>
+    <dgm:cat type="textcard" pri="200"/>
   </dgm:catLst>
   <dgm:sampData>
     <dgm:dataModel>
@@ -3743,7 +4744,209 @@
   <dgm:title val=""/>
   <dgm:desc val=""/>
   <dgm:catLst>
-    <dgm:cat type="list" pri="8050"/>
+    <dgm:cat type="textcard" pri="200"/>
+  </dgm:catLst>
+  <dgm:sampData>
+    <dgm:dataModel>
+      <dgm:ptLst>
+        <dgm:pt modelId="0" type="doc"/>
+        <dgm:pt modelId="1">
+          <dgm:prSet phldr="1"/>
+        </dgm:pt>
+        <dgm:pt modelId="11">
+          <dgm:prSet phldr="1"/>
+        </dgm:pt>
+        <dgm:pt modelId="2">
+          <dgm:prSet phldr="1"/>
+        </dgm:pt>
+        <dgm:pt modelId="21">
+          <dgm:prSet phldr="1"/>
+        </dgm:pt>
+        <dgm:pt modelId="3">
+          <dgm:prSet phldr="1"/>
+        </dgm:pt>
+        <dgm:pt modelId="31">
+          <dgm:prSet phldr="1"/>
+        </dgm:pt>
+      </dgm:ptLst>
+      <dgm:cxnLst>
+        <dgm:cxn modelId="4" srcId="0" destId="1" srcOrd="0" destOrd="0"/>
+        <dgm:cxn modelId="5" srcId="0" destId="2" srcOrd="1" destOrd="0"/>
+        <dgm:cxn modelId="6" srcId="0" destId="3" srcOrd="2" destOrd="0"/>
+        <dgm:cxn modelId="13" srcId="1" destId="11" srcOrd="0" destOrd="0"/>
+        <dgm:cxn modelId="23" srcId="2" destId="21" srcOrd="0" destOrd="0"/>
+        <dgm:cxn modelId="33" srcId="3" destId="31" srcOrd="0" destOrd="0"/>
+      </dgm:cxnLst>
+      <dgm:bg/>
+      <dgm:whole/>
+    </dgm:dataModel>
+  </dgm:sampData>
+  <dgm:styleData>
+    <dgm:dataModel>
+      <dgm:ptLst>
+        <dgm:pt modelId="0" type="doc"/>
+        <dgm:pt modelId="1"/>
+        <dgm:pt modelId="2"/>
+      </dgm:ptLst>
+      <dgm:cxnLst>
+        <dgm:cxn modelId="3" srcId="0" destId="1" srcOrd="0" destOrd="0"/>
+        <dgm:cxn modelId="4" srcId="0" destId="2" srcOrd="1" destOrd="0"/>
+      </dgm:cxnLst>
+      <dgm:bg/>
+      <dgm:whole/>
+    </dgm:dataModel>
+  </dgm:styleData>
+  <dgm:clrData>
+    <dgm:dataModel>
+      <dgm:ptLst>
+        <dgm:pt modelId="0" type="doc"/>
+        <dgm:pt modelId="1"/>
+        <dgm:pt modelId="2"/>
+        <dgm:pt modelId="3"/>
+        <dgm:pt modelId="4"/>
+      </dgm:ptLst>
+      <dgm:cxnLst>
+        <dgm:cxn modelId="5" srcId="0" destId="1" srcOrd="0" destOrd="0"/>
+        <dgm:cxn modelId="6" srcId="0" destId="2" srcOrd="1" destOrd="0"/>
+        <dgm:cxn modelId="7" srcId="0" destId="3" srcOrd="2" destOrd="0"/>
+        <dgm:cxn modelId="8" srcId="0" destId="4" srcOrd="3" destOrd="0"/>
+      </dgm:cxnLst>
+      <dgm:bg/>
+      <dgm:whole/>
+    </dgm:dataModel>
+  </dgm:clrData>
+  <dgm:layoutNode name="Name0">
+    <dgm:varLst>
+      <dgm:dir/>
+      <dgm:animLvl val="lvl"/>
+      <dgm:resizeHandles val="exact"/>
+    </dgm:varLst>
+    <dgm:choose name="Name1">
+      <dgm:if name="Name2" func="var" arg="dir" op="equ" val="norm">
+        <dgm:alg type="lin"/>
+      </dgm:if>
+      <dgm:else name="Name3">
+        <dgm:alg type="lin">
+          <dgm:param type="linDir" val="fromR"/>
+        </dgm:alg>
+      </dgm:else>
+    </dgm:choose>
+    <dgm:shape xmlns:r="http://schemas.openxmlformats.org/officeDocument/2006/relationships" r:blip="">
+      <dgm:adjLst/>
+    </dgm:shape>
+    <dgm:presOf/>
+    <dgm:constrLst>
+      <dgm:constr type="h" for="ch" forName="composite" refType="h" fact="0.95"/>
+      <dgm:constr type="h" for="des" forName="composite" op="equ"/>
+      <dgm:constr type="w" for="ch" forName="composite" refType="w"/>
+      <dgm:constr type="w" for="des" forName="parTx"/>
+      <dgm:constr type="h" for="des" forName="parTx" op="equ"/>
+      <dgm:constr type="w" for="des" forName="bgOutline"/>
+      <dgm:constr type="primFontSz" for="des" forName="parTx" val="54"/>
+      <dgm:constr type="primFontSz" for="des" forName="bgOutline" refType="primFontSz" refFor="des" refForName="parTx" op="lte" fact="0.75"/>
+      <dgm:constr type="h" for="des" forName="bgOutline" op="equ"/>
+      <dgm:constr type="w" for="ch" forName="space" op="equ" val="3"/>
+    </dgm:constrLst>
+    <dgm:ruleLst>
+      <dgm:rule type="w" for="ch" forName="composite" val="0" fact="NaN" max="NaN"/>
+    </dgm:ruleLst>
+    <dgm:forEach name="Name6" axis="ch" ptType="node">
+      <dgm:layoutNode name="composite">
+        <dgm:alg type="composite"/>
+        <dgm:shape xmlns:r="http://schemas.openxmlformats.org/officeDocument/2006/relationships" r:blip="">
+          <dgm:adjLst/>
+        </dgm:shape>
+        <dgm:presOf/>
+        <dgm:constrLst>
+          <dgm:constr type="l" for="ch" forName="parTx"/>
+          <dgm:constr type="w" for="ch" forName="parTx" refType="w"/>
+          <dgm:constr type="t" for="ch" forName="parTx"/>
+          <dgm:constr type="l" for="ch" forName="bgOutline"/>
+          <dgm:constr type="t" for="ch" forName="bgOutline" refType="h" refFor="ch" refForName="parTx" fact="0.97"/>
+          <dgm:constr type="w" for="ch" forName="bgOutline" refType="w"/>
+          <dgm:constr type="h" for="ch" forName="bgOutline" refType="h" fact="0.75"/>
+        </dgm:constrLst>
+        <dgm:ruleLst/>
+        <dgm:layoutNode name="parTx" styleLbl="alignNode1">
+          <dgm:varLst>
+            <dgm:chMax val="0"/>
+            <dgm:chPref val="0"/>
+          </dgm:varLst>
+          <dgm:alg type="tx">
+            <dgm:param type="parTxLTRAlign" val="l"/>
+            <dgm:param type="parTxRTLAlign" val="r"/>
+          </dgm:alg>
+          <dgm:shape xmlns:r="http://schemas.openxmlformats.org/officeDocument/2006/relationships" type="round2SameRect" r:blip="" zOrderOff="3">
+            <dgm:adjLst>
+              <dgm:adj idx="1" val="0.45"/>
+            </dgm:adjLst>
+          </dgm:shape>
+          <dgm:presOf axis="self" ptType="node"/>
+          <dgm:constrLst>
+            <dgm:constr type="h" refType="w" op="lte" fact="0.3"/>
+            <dgm:constr type="h"/>
+            <dgm:constr type="tMarg" refType="w" fact="0.224"/>
+            <dgm:constr type="bMarg" refType="w" fact="0.224"/>
+            <dgm:constr type="lMarg" refType="w" fact="0.224"/>
+            <dgm:constr type="rMarg" refType="w" fact="0.224"/>
+          </dgm:constrLst>
+          <dgm:ruleLst>
+            <dgm:rule type="primFontSz" val="14" fact="NaN" max="NaN"/>
+          </dgm:ruleLst>
+        </dgm:layoutNode>
+        <dgm:layoutNode name="bgOutline" styleLbl="fgAcc1">
+          <dgm:varLst>
+            <dgm:bulletEnabled/>
+          </dgm:varLst>
+          <dgm:alg type="tx">
+            <dgm:param type="stBulletLvl" val="0"/>
+            <dgm:param type="txAnchorVert" val="t"/>
+            <dgm:param type="parTxLTRAlign" val="l"/>
+            <dgm:param type="shpTxLTRAlignCh" val="l"/>
+            <dgm:param type="parTxRTLAlign" val="r"/>
+            <dgm:param type="shpTxRTLAlignCh" val="r"/>
+          </dgm:alg>
+          <dgm:shape xmlns:r="http://schemas.openxmlformats.org/officeDocument/2006/relationships" rot="180" type="round2SameRect" r:blip="">
+            <dgm:adjLst>
+              <dgm:adj idx="1" val="0.15"/>
+              <dgm:adj idx="2" val="0"/>
+            </dgm:adjLst>
+          </dgm:shape>
+          <dgm:presOf axis="des" ptType="node"/>
+          <dgm:constrLst>
+            <dgm:constr type="primFontSz" val="28"/>
+            <dgm:constr type="tMarg" refType="w" fact="0.12"/>
+            <dgm:constr type="bMarg" refType="w" fact="0.12"/>
+            <dgm:constr type="lMarg" refType="w" fact="0.12"/>
+            <dgm:constr type="rMarg" refType="w" fact="0.12"/>
+          </dgm:constrLst>
+          <dgm:ruleLst>
+            <dgm:rule type="primFontSz" val="11" fact="NaN" max="NaN"/>
+          </dgm:ruleLst>
+        </dgm:layoutNode>
+      </dgm:layoutNode>
+      <dgm:forEach name="Name19" axis="followSib" ptType="sibTrans" cnt="1">
+        <dgm:layoutNode name="space">
+          <dgm:alg type="sp"/>
+          <dgm:shape xmlns:r="http://schemas.openxmlformats.org/officeDocument/2006/relationships" r:blip="">
+            <dgm:adjLst/>
+          </dgm:shape>
+          <dgm:presOf/>
+          <dgm:constrLst/>
+          <dgm:ruleLst/>
+        </dgm:layoutNode>
+      </dgm:forEach>
+    </dgm:forEach>
+  </dgm:layoutNode>
+</dgm:layoutDef>
+</file>
+
+<file path=ppt/diagrams/layout3.xml><?xml version="1.0" encoding="utf-8"?>
+<dgm:layoutDef xmlns:dgm="http://schemas.openxmlformats.org/drawingml/2006/diagram" xmlns:a="http://schemas.openxmlformats.org/drawingml/2006/main" uniqueId="urn:microsoft.com/office/officeart/2024/layout/HorizontalActionList">
+  <dgm:title val=""/>
+  <dgm:desc val=""/>
+  <dgm:catLst>
+    <dgm:cat type="textcard" pri="200"/>
   </dgm:catLst>
   <dgm:sampData>
     <dgm:dataModel>
@@ -6008,6 +7211,1040 @@
 </dgm:styleDef>
 </file>
 
+<file path=ppt/diagrams/quickStyle3.xml><?xml version="1.0" encoding="utf-8"?>
+<dgm:styleDef xmlns:dgm="http://schemas.openxmlformats.org/drawingml/2006/diagram" xmlns:a="http://schemas.openxmlformats.org/drawingml/2006/main" uniqueId="urn:microsoft.com/office/officeart/2005/8/quickstyle/simple1">
+  <dgm:title val=""/>
+  <dgm:desc val=""/>
+  <dgm:catLst>
+    <dgm:cat type="simple" pri="10100"/>
+  </dgm:catLst>
+  <dgm:scene3d>
+    <a:camera prst="orthographicFront"/>
+    <a:lightRig rig="threePt" dir="t"/>
+  </dgm:scene3d>
+  <dgm:styleLbl name="node0">
+    <dgm:scene3d>
+      <a:camera prst="orthographicFront"/>
+      <a:lightRig rig="threePt" dir="t"/>
+    </dgm:scene3d>
+    <dgm:sp3d/>
+    <dgm:txPr/>
+    <dgm:style>
+      <a:lnRef idx="2">
+        <a:scrgbClr r="0" g="0" b="0"/>
+      </a:lnRef>
+      <a:fillRef idx="1">
+        <a:scrgbClr r="0" g="0" b="0"/>
+      </a:fillRef>
+      <a:effectRef idx="0">
+        <a:scrgbClr r="0" g="0" b="0"/>
+      </a:effectRef>
+      <a:fontRef idx="minor">
+        <a:schemeClr val="lt1"/>
+      </a:fontRef>
+    </dgm:style>
+  </dgm:styleLbl>
+  <dgm:styleLbl name="lnNode1">
+    <dgm:scene3d>
+      <a:camera prst="orthographicFront"/>
+      <a:lightRig rig="threePt" dir="t"/>
+    </dgm:scene3d>
+    <dgm:sp3d/>
+    <dgm:txPr/>
+    <dgm:style>
+      <a:lnRef idx="2">
+        <a:scrgbClr r="0" g="0" b="0"/>
+      </a:lnRef>
+      <a:fillRef idx="1">
+        <a:scrgbClr r="0" g="0" b="0"/>
+      </a:fillRef>
+      <a:effectRef idx="0">
+        <a:scrgbClr r="0" g="0" b="0"/>
+      </a:effectRef>
+      <a:fontRef idx="minor">
+        <a:schemeClr val="lt1"/>
+      </a:fontRef>
+    </dgm:style>
+  </dgm:styleLbl>
+  <dgm:styleLbl name="vennNode1">
+    <dgm:scene3d>
+      <a:camera prst="orthographicFront"/>
+      <a:lightRig rig="threePt" dir="t"/>
+    </dgm:scene3d>
+    <dgm:sp3d/>
+    <dgm:txPr/>
+    <dgm:style>
+      <a:lnRef idx="2">
+        <a:scrgbClr r="0" g="0" b="0"/>
+      </a:lnRef>
+      <a:fillRef idx="1">
+        <a:scrgbClr r="0" g="0" b="0"/>
+      </a:fillRef>
+      <a:effectRef idx="0">
+        <a:scrgbClr r="0" g="0" b="0"/>
+      </a:effectRef>
+      <a:fontRef idx="minor">
+        <a:schemeClr val="tx1"/>
+      </a:fontRef>
+    </dgm:style>
+  </dgm:styleLbl>
+  <dgm:styleLbl name="alignNode1">
+    <dgm:scene3d>
+      <a:camera prst="orthographicFront"/>
+      <a:lightRig rig="threePt" dir="t"/>
+    </dgm:scene3d>
+    <dgm:sp3d/>
+    <dgm:txPr/>
+    <dgm:style>
+      <a:lnRef idx="2">
+        <a:scrgbClr r="0" g="0" b="0"/>
+      </a:lnRef>
+      <a:fillRef idx="1">
+        <a:scrgbClr r="0" g="0" b="0"/>
+      </a:fillRef>
+      <a:effectRef idx="0">
+        <a:scrgbClr r="0" g="0" b="0"/>
+      </a:effectRef>
+      <a:fontRef idx="minor">
+        <a:schemeClr val="lt1"/>
+      </a:fontRef>
+    </dgm:style>
+  </dgm:styleLbl>
+  <dgm:styleLbl name="node1">
+    <dgm:scene3d>
+      <a:camera prst="orthographicFront"/>
+      <a:lightRig rig="threePt" dir="t"/>
+    </dgm:scene3d>
+    <dgm:sp3d/>
+    <dgm:txPr/>
+    <dgm:style>
+      <a:lnRef idx="2">
+        <a:scrgbClr r="0" g="0" b="0"/>
+      </a:lnRef>
+      <a:fillRef idx="1">
+        <a:scrgbClr r="0" g="0" b="0"/>
+      </a:fillRef>
+      <a:effectRef idx="0">
+        <a:scrgbClr r="0" g="0" b="0"/>
+      </a:effectRef>
+      <a:fontRef idx="minor">
+        <a:schemeClr val="lt1"/>
+      </a:fontRef>
+    </dgm:style>
+  </dgm:styleLbl>
+  <dgm:styleLbl name="node2">
+    <dgm:scene3d>
+      <a:camera prst="orthographicFront"/>
+      <a:lightRig rig="threePt" dir="t"/>
+    </dgm:scene3d>
+    <dgm:sp3d/>
+    <dgm:txPr/>
+    <dgm:style>
+      <a:lnRef idx="2">
+        <a:scrgbClr r="0" g="0" b="0"/>
+      </a:lnRef>
+      <a:fillRef idx="1">
+        <a:scrgbClr r="0" g="0" b="0"/>
+      </a:fillRef>
+      <a:effectRef idx="0">
+        <a:scrgbClr r="0" g="0" b="0"/>
+      </a:effectRef>
+      <a:fontRef idx="minor">
+        <a:schemeClr val="lt1"/>
+      </a:fontRef>
+    </dgm:style>
+  </dgm:styleLbl>
+  <dgm:styleLbl name="node3">
+    <dgm:scene3d>
+      <a:camera prst="orthographicFront"/>
+      <a:lightRig rig="threePt" dir="t"/>
+    </dgm:scene3d>
+    <dgm:sp3d/>
+    <dgm:txPr/>
+    <dgm:style>
+      <a:lnRef idx="2">
+        <a:scrgbClr r="0" g="0" b="0"/>
+      </a:lnRef>
+      <a:fillRef idx="1">
+        <a:scrgbClr r="0" g="0" b="0"/>
+      </a:fillRef>
+      <a:effectRef idx="0">
+        <a:scrgbClr r="0" g="0" b="0"/>
+      </a:effectRef>
+      <a:fontRef idx="minor">
+        <a:schemeClr val="lt1"/>
+      </a:fontRef>
+    </dgm:style>
+  </dgm:styleLbl>
+  <dgm:styleLbl name="node4">
+    <dgm:scene3d>
+      <a:camera prst="orthographicFront"/>
+      <a:lightRig rig="threePt" dir="t"/>
+    </dgm:scene3d>
+    <dgm:sp3d/>
+    <dgm:txPr/>
+    <dgm:style>
+      <a:lnRef idx="2">
+        <a:scrgbClr r="0" g="0" b="0"/>
+      </a:lnRef>
+      <a:fillRef idx="1">
+        <a:scrgbClr r="0" g="0" b="0"/>
+      </a:fillRef>
+      <a:effectRef idx="0">
+        <a:scrgbClr r="0" g="0" b="0"/>
+      </a:effectRef>
+      <a:fontRef idx="minor">
+        <a:schemeClr val="lt1"/>
+      </a:fontRef>
+    </dgm:style>
+  </dgm:styleLbl>
+  <dgm:styleLbl name="fgImgPlace1">
+    <dgm:scene3d>
+      <a:camera prst="orthographicFront"/>
+      <a:lightRig rig="threePt" dir="t"/>
+    </dgm:scene3d>
+    <dgm:sp3d/>
+    <dgm:txPr/>
+    <dgm:style>
+      <a:lnRef idx="2">
+        <a:scrgbClr r="0" g="0" b="0"/>
+      </a:lnRef>
+      <a:fillRef idx="1">
+        <a:scrgbClr r="0" g="0" b="0"/>
+      </a:fillRef>
+      <a:effectRef idx="0">
+        <a:scrgbClr r="0" g="0" b="0"/>
+      </a:effectRef>
+      <a:fontRef idx="minor"/>
+    </dgm:style>
+  </dgm:styleLbl>
+  <dgm:styleLbl name="alignImgPlace1">
+    <dgm:scene3d>
+      <a:camera prst="orthographicFront"/>
+      <a:lightRig rig="threePt" dir="t"/>
+    </dgm:scene3d>
+    <dgm:sp3d/>
+    <dgm:txPr/>
+    <dgm:style>
+      <a:lnRef idx="2">
+        <a:scrgbClr r="0" g="0" b="0"/>
+      </a:lnRef>
+      <a:fillRef idx="1">
+        <a:scrgbClr r="0" g="0" b="0"/>
+      </a:fillRef>
+      <a:effectRef idx="0">
+        <a:scrgbClr r="0" g="0" b="0"/>
+      </a:effectRef>
+      <a:fontRef idx="minor"/>
+    </dgm:style>
+  </dgm:styleLbl>
+  <dgm:styleLbl name="bgImgPlace1">
+    <dgm:scene3d>
+      <a:camera prst="orthographicFront"/>
+      <a:lightRig rig="threePt" dir="t"/>
+    </dgm:scene3d>
+    <dgm:sp3d/>
+    <dgm:txPr/>
+    <dgm:style>
+      <a:lnRef idx="2">
+        <a:scrgbClr r="0" g="0" b="0"/>
+      </a:lnRef>
+      <a:fillRef idx="1">
+        <a:scrgbClr r="0" g="0" b="0"/>
+      </a:fillRef>
+      <a:effectRef idx="0">
+        <a:scrgbClr r="0" g="0" b="0"/>
+      </a:effectRef>
+      <a:fontRef idx="minor"/>
+    </dgm:style>
+  </dgm:styleLbl>
+  <dgm:styleLbl name="sibTrans2D1">
+    <dgm:scene3d>
+      <a:camera prst="orthographicFront"/>
+      <a:lightRig rig="threePt" dir="t"/>
+    </dgm:scene3d>
+    <dgm:sp3d/>
+    <dgm:txPr/>
+    <dgm:style>
+      <a:lnRef idx="0">
+        <a:scrgbClr r="0" g="0" b="0"/>
+      </a:lnRef>
+      <a:fillRef idx="1">
+        <a:scrgbClr r="0" g="0" b="0"/>
+      </a:fillRef>
+      <a:effectRef idx="0">
+        <a:scrgbClr r="0" g="0" b="0"/>
+      </a:effectRef>
+      <a:fontRef idx="minor">
+        <a:schemeClr val="lt1"/>
+      </a:fontRef>
+    </dgm:style>
+  </dgm:styleLbl>
+  <dgm:styleLbl name="fgSibTrans2D1">
+    <dgm:scene3d>
+      <a:camera prst="orthographicFront"/>
+      <a:lightRig rig="threePt" dir="t"/>
+    </dgm:scene3d>
+    <dgm:sp3d/>
+    <dgm:txPr/>
+    <dgm:style>
+      <a:lnRef idx="0">
+        <a:scrgbClr r="0" g="0" b="0"/>
+      </a:lnRef>
+      <a:fillRef idx="1">
+        <a:scrgbClr r="0" g="0" b="0"/>
+      </a:fillRef>
+      <a:effectRef idx="0">
+        <a:scrgbClr r="0" g="0" b="0"/>
+      </a:effectRef>
+      <a:fontRef idx="minor">
+        <a:schemeClr val="lt1"/>
+      </a:fontRef>
+    </dgm:style>
+  </dgm:styleLbl>
+  <dgm:styleLbl name="bgSibTrans2D1">
+    <dgm:scene3d>
+      <a:camera prst="orthographicFront"/>
+      <a:lightRig rig="threePt" dir="t"/>
+    </dgm:scene3d>
+    <dgm:sp3d/>
+    <dgm:txPr/>
+    <dgm:style>
+      <a:lnRef idx="0">
+        <a:scrgbClr r="0" g="0" b="0"/>
+      </a:lnRef>
+      <a:fillRef idx="1">
+        <a:scrgbClr r="0" g="0" b="0"/>
+      </a:fillRef>
+      <a:effectRef idx="0">
+        <a:scrgbClr r="0" g="0" b="0"/>
+      </a:effectRef>
+      <a:fontRef idx="minor">
+        <a:schemeClr val="lt1"/>
+      </a:fontRef>
+    </dgm:style>
+  </dgm:styleLbl>
+  <dgm:styleLbl name="sibTrans1D1">
+    <dgm:scene3d>
+      <a:camera prst="orthographicFront"/>
+      <a:lightRig rig="threePt" dir="t"/>
+    </dgm:scene3d>
+    <dgm:sp3d/>
+    <dgm:txPr/>
+    <dgm:style>
+      <a:lnRef idx="1">
+        <a:scrgbClr r="0" g="0" b="0"/>
+      </a:lnRef>
+      <a:fillRef idx="0">
+        <a:scrgbClr r="0" g="0" b="0"/>
+      </a:fillRef>
+      <a:effectRef idx="0">
+        <a:scrgbClr r="0" g="0" b="0"/>
+      </a:effectRef>
+      <a:fontRef idx="minor"/>
+    </dgm:style>
+  </dgm:styleLbl>
+  <dgm:styleLbl name="callout">
+    <dgm:scene3d>
+      <a:camera prst="orthographicFront"/>
+      <a:lightRig rig="threePt" dir="t"/>
+    </dgm:scene3d>
+    <dgm:sp3d/>
+    <dgm:txPr/>
+    <dgm:style>
+      <a:lnRef idx="2">
+        <a:scrgbClr r="0" g="0" b="0"/>
+      </a:lnRef>
+      <a:fillRef idx="1">
+        <a:scrgbClr r="0" g="0" b="0"/>
+      </a:fillRef>
+      <a:effectRef idx="0">
+        <a:scrgbClr r="0" g="0" b="0"/>
+      </a:effectRef>
+      <a:fontRef idx="minor"/>
+    </dgm:style>
+  </dgm:styleLbl>
+  <dgm:styleLbl name="asst0">
+    <dgm:scene3d>
+      <a:camera prst="orthographicFront"/>
+      <a:lightRig rig="threePt" dir="t"/>
+    </dgm:scene3d>
+    <dgm:sp3d/>
+    <dgm:txPr/>
+    <dgm:style>
+      <a:lnRef idx="2">
+        <a:scrgbClr r="0" g="0" b="0"/>
+      </a:lnRef>
+      <a:fillRef idx="1">
+        <a:scrgbClr r="0" g="0" b="0"/>
+      </a:fillRef>
+      <a:effectRef idx="0">
+        <a:scrgbClr r="0" g="0" b="0"/>
+      </a:effectRef>
+      <a:fontRef idx="minor">
+        <a:schemeClr val="lt1"/>
+      </a:fontRef>
+    </dgm:style>
+  </dgm:styleLbl>
+  <dgm:styleLbl name="asst1">
+    <dgm:scene3d>
+      <a:camera prst="orthographicFront"/>
+      <a:lightRig rig="threePt" dir="t"/>
+    </dgm:scene3d>
+    <dgm:sp3d/>
+    <dgm:txPr/>
+    <dgm:style>
+      <a:lnRef idx="2">
+        <a:scrgbClr r="0" g="0" b="0"/>
+      </a:lnRef>
+      <a:fillRef idx="1">
+        <a:scrgbClr r="0" g="0" b="0"/>
+      </a:fillRef>
+      <a:effectRef idx="0">
+        <a:scrgbClr r="0" g="0" b="0"/>
+      </a:effectRef>
+      <a:fontRef idx="minor">
+        <a:schemeClr val="lt1"/>
+      </a:fontRef>
+    </dgm:style>
+  </dgm:styleLbl>
+  <dgm:styleLbl name="asst2">
+    <dgm:scene3d>
+      <a:camera prst="orthographicFront"/>
+      <a:lightRig rig="threePt" dir="t"/>
+    </dgm:scene3d>
+    <dgm:sp3d/>
+    <dgm:txPr/>
+    <dgm:style>
+      <a:lnRef idx="2">
+        <a:scrgbClr r="0" g="0" b="0"/>
+      </a:lnRef>
+      <a:fillRef idx="1">
+        <a:scrgbClr r="0" g="0" b="0"/>
+      </a:fillRef>
+      <a:effectRef idx="0">
+        <a:scrgbClr r="0" g="0" b="0"/>
+      </a:effectRef>
+      <a:fontRef idx="minor">
+        <a:schemeClr val="lt1"/>
+      </a:fontRef>
+    </dgm:style>
+  </dgm:styleLbl>
+  <dgm:styleLbl name="asst3">
+    <dgm:scene3d>
+      <a:camera prst="orthographicFront"/>
+      <a:lightRig rig="threePt" dir="t"/>
+    </dgm:scene3d>
+    <dgm:sp3d/>
+    <dgm:txPr/>
+    <dgm:style>
+      <a:lnRef idx="2">
+        <a:scrgbClr r="0" g="0" b="0"/>
+      </a:lnRef>
+      <a:fillRef idx="1">
+        <a:scrgbClr r="0" g="0" b="0"/>
+      </a:fillRef>
+      <a:effectRef idx="0">
+        <a:scrgbClr r="0" g="0" b="0"/>
+      </a:effectRef>
+      <a:fontRef idx="minor">
+        <a:schemeClr val="lt1"/>
+      </a:fontRef>
+    </dgm:style>
+  </dgm:styleLbl>
+  <dgm:styleLbl name="asst4">
+    <dgm:scene3d>
+      <a:camera prst="orthographicFront"/>
+      <a:lightRig rig="threePt" dir="t"/>
+    </dgm:scene3d>
+    <dgm:sp3d/>
+    <dgm:txPr/>
+    <dgm:style>
+      <a:lnRef idx="2">
+        <a:scrgbClr r="0" g="0" b="0"/>
+      </a:lnRef>
+      <a:fillRef idx="1">
+        <a:scrgbClr r="0" g="0" b="0"/>
+      </a:fillRef>
+      <a:effectRef idx="0">
+        <a:scrgbClr r="0" g="0" b="0"/>
+      </a:effectRef>
+      <a:fontRef idx="minor">
+        <a:schemeClr val="lt1"/>
+      </a:fontRef>
+    </dgm:style>
+  </dgm:styleLbl>
+  <dgm:styleLbl name="parChTrans2D1">
+    <dgm:scene3d>
+      <a:camera prst="orthographicFront"/>
+      <a:lightRig rig="threePt" dir="t"/>
+    </dgm:scene3d>
+    <dgm:sp3d/>
+    <dgm:txPr/>
+    <dgm:style>
+      <a:lnRef idx="2">
+        <a:scrgbClr r="0" g="0" b="0"/>
+      </a:lnRef>
+      <a:fillRef idx="1">
+        <a:scrgbClr r="0" g="0" b="0"/>
+      </a:fillRef>
+      <a:effectRef idx="0">
+        <a:scrgbClr r="0" g="0" b="0"/>
+      </a:effectRef>
+      <a:fontRef idx="minor">
+        <a:schemeClr val="lt1"/>
+      </a:fontRef>
+    </dgm:style>
+  </dgm:styleLbl>
+  <dgm:styleLbl name="parChTrans2D2">
+    <dgm:scene3d>
+      <a:camera prst="orthographicFront"/>
+      <a:lightRig rig="threePt" dir="t"/>
+    </dgm:scene3d>
+    <dgm:sp3d/>
+    <dgm:txPr/>
+    <dgm:style>
+      <a:lnRef idx="2">
+        <a:scrgbClr r="0" g="0" b="0"/>
+      </a:lnRef>
+      <a:fillRef idx="1">
+        <a:scrgbClr r="0" g="0" b="0"/>
+      </a:fillRef>
+      <a:effectRef idx="0">
+        <a:scrgbClr r="0" g="0" b="0"/>
+      </a:effectRef>
+      <a:fontRef idx="minor">
+        <a:schemeClr val="lt1"/>
+      </a:fontRef>
+    </dgm:style>
+  </dgm:styleLbl>
+  <dgm:styleLbl name="parChTrans2D3">
+    <dgm:scene3d>
+      <a:camera prst="orthographicFront"/>
+      <a:lightRig rig="threePt" dir="t"/>
+    </dgm:scene3d>
+    <dgm:sp3d/>
+    <dgm:txPr/>
+    <dgm:style>
+      <a:lnRef idx="2">
+        <a:scrgbClr r="0" g="0" b="0"/>
+      </a:lnRef>
+      <a:fillRef idx="1">
+        <a:scrgbClr r="0" g="0" b="0"/>
+      </a:fillRef>
+      <a:effectRef idx="0">
+        <a:scrgbClr r="0" g="0" b="0"/>
+      </a:effectRef>
+      <a:fontRef idx="minor">
+        <a:schemeClr val="lt1"/>
+      </a:fontRef>
+    </dgm:style>
+  </dgm:styleLbl>
+  <dgm:styleLbl name="parChTrans2D4">
+    <dgm:scene3d>
+      <a:camera prst="orthographicFront"/>
+      <a:lightRig rig="threePt" dir="t"/>
+    </dgm:scene3d>
+    <dgm:sp3d/>
+    <dgm:txPr/>
+    <dgm:style>
+      <a:lnRef idx="2">
+        <a:scrgbClr r="0" g="0" b="0"/>
+      </a:lnRef>
+      <a:fillRef idx="1">
+        <a:scrgbClr r="0" g="0" b="0"/>
+      </a:fillRef>
+      <a:effectRef idx="0">
+        <a:scrgbClr r="0" g="0" b="0"/>
+      </a:effectRef>
+      <a:fontRef idx="minor">
+        <a:schemeClr val="lt1"/>
+      </a:fontRef>
+    </dgm:style>
+  </dgm:styleLbl>
+  <dgm:styleLbl name="parChTrans1D1">
+    <dgm:scene3d>
+      <a:camera prst="orthographicFront"/>
+      <a:lightRig rig="threePt" dir="t"/>
+    </dgm:scene3d>
+    <dgm:sp3d/>
+    <dgm:txPr/>
+    <dgm:style>
+      <a:lnRef idx="2">
+        <a:scrgbClr r="0" g="0" b="0"/>
+      </a:lnRef>
+      <a:fillRef idx="0">
+        <a:scrgbClr r="0" g="0" b="0"/>
+      </a:fillRef>
+      <a:effectRef idx="0">
+        <a:scrgbClr r="0" g="0" b="0"/>
+      </a:effectRef>
+      <a:fontRef idx="minor"/>
+    </dgm:style>
+  </dgm:styleLbl>
+  <dgm:styleLbl name="parChTrans1D2">
+    <dgm:scene3d>
+      <a:camera prst="orthographicFront"/>
+      <a:lightRig rig="threePt" dir="t"/>
+    </dgm:scene3d>
+    <dgm:sp3d/>
+    <dgm:txPr/>
+    <dgm:style>
+      <a:lnRef idx="2">
+        <a:scrgbClr r="0" g="0" b="0"/>
+      </a:lnRef>
+      <a:fillRef idx="0">
+        <a:scrgbClr r="0" g="0" b="0"/>
+      </a:fillRef>
+      <a:effectRef idx="0">
+        <a:scrgbClr r="0" g="0" b="0"/>
+      </a:effectRef>
+      <a:fontRef idx="minor"/>
+    </dgm:style>
+  </dgm:styleLbl>
+  <dgm:styleLbl name="parChTrans1D3">
+    <dgm:scene3d>
+      <a:camera prst="orthographicFront"/>
+      <a:lightRig rig="threePt" dir="t"/>
+    </dgm:scene3d>
+    <dgm:sp3d/>
+    <dgm:txPr/>
+    <dgm:style>
+      <a:lnRef idx="2">
+        <a:scrgbClr r="0" g="0" b="0"/>
+      </a:lnRef>
+      <a:fillRef idx="0">
+        <a:scrgbClr r="0" g="0" b="0"/>
+      </a:fillRef>
+      <a:effectRef idx="0">
+        <a:scrgbClr r="0" g="0" b="0"/>
+      </a:effectRef>
+      <a:fontRef idx="minor"/>
+    </dgm:style>
+  </dgm:styleLbl>
+  <dgm:styleLbl name="parChTrans1D4">
+    <dgm:scene3d>
+      <a:camera prst="orthographicFront"/>
+      <a:lightRig rig="threePt" dir="t"/>
+    </dgm:scene3d>
+    <dgm:sp3d/>
+    <dgm:txPr/>
+    <dgm:style>
+      <a:lnRef idx="2">
+        <a:scrgbClr r="0" g="0" b="0"/>
+      </a:lnRef>
+      <a:fillRef idx="0">
+        <a:scrgbClr r="0" g="0" b="0"/>
+      </a:fillRef>
+      <a:effectRef idx="0">
+        <a:scrgbClr r="0" g="0" b="0"/>
+      </a:effectRef>
+      <a:fontRef idx="minor"/>
+    </dgm:style>
+  </dgm:styleLbl>
+  <dgm:styleLbl name="fgAcc1">
+    <dgm:scene3d>
+      <a:camera prst="orthographicFront"/>
+      <a:lightRig rig="threePt" dir="t"/>
+    </dgm:scene3d>
+    <dgm:sp3d/>
+    <dgm:txPr/>
+    <dgm:style>
+      <a:lnRef idx="2">
+        <a:scrgbClr r="0" g="0" b="0"/>
+      </a:lnRef>
+      <a:fillRef idx="1">
+        <a:scrgbClr r="0" g="0" b="0"/>
+      </a:fillRef>
+      <a:effectRef idx="0">
+        <a:scrgbClr r="0" g="0" b="0"/>
+      </a:effectRef>
+      <a:fontRef idx="minor"/>
+    </dgm:style>
+  </dgm:styleLbl>
+  <dgm:styleLbl name="conFgAcc1">
+    <dgm:scene3d>
+      <a:camera prst="orthographicFront"/>
+      <a:lightRig rig="threePt" dir="t"/>
+    </dgm:scene3d>
+    <dgm:sp3d/>
+    <dgm:txPr/>
+    <dgm:style>
+      <a:lnRef idx="2">
+        <a:scrgbClr r="0" g="0" b="0"/>
+      </a:lnRef>
+      <a:fillRef idx="1">
+        <a:scrgbClr r="0" g="0" b="0"/>
+      </a:fillRef>
+      <a:effectRef idx="0">
+        <a:scrgbClr r="0" g="0" b="0"/>
+      </a:effectRef>
+      <a:fontRef idx="minor"/>
+    </dgm:style>
+  </dgm:styleLbl>
+  <dgm:styleLbl name="alignAcc1">
+    <dgm:scene3d>
+      <a:camera prst="orthographicFront"/>
+      <a:lightRig rig="threePt" dir="t"/>
+    </dgm:scene3d>
+    <dgm:sp3d/>
+    <dgm:txPr/>
+    <dgm:style>
+      <a:lnRef idx="2">
+        <a:scrgbClr r="0" g="0" b="0"/>
+      </a:lnRef>
+      <a:fillRef idx="1">
+        <a:scrgbClr r="0" g="0" b="0"/>
+      </a:fillRef>
+      <a:effectRef idx="0">
+        <a:scrgbClr r="0" g="0" b="0"/>
+      </a:effectRef>
+      <a:fontRef idx="minor"/>
+    </dgm:style>
+  </dgm:styleLbl>
+  <dgm:styleLbl name="trAlignAcc1">
+    <dgm:scene3d>
+      <a:camera prst="orthographicFront"/>
+      <a:lightRig rig="threePt" dir="t"/>
+    </dgm:scene3d>
+    <dgm:sp3d/>
+    <dgm:txPr/>
+    <dgm:style>
+      <a:lnRef idx="1">
+        <a:scrgbClr r="0" g="0" b="0"/>
+      </a:lnRef>
+      <a:fillRef idx="1">
+        <a:scrgbClr r="0" g="0" b="0"/>
+      </a:fillRef>
+      <a:effectRef idx="0">
+        <a:scrgbClr r="0" g="0" b="0"/>
+      </a:effectRef>
+      <a:fontRef idx="minor"/>
+    </dgm:style>
+  </dgm:styleLbl>
+  <dgm:styleLbl name="bgAcc1">
+    <dgm:scene3d>
+      <a:camera prst="orthographicFront"/>
+      <a:lightRig rig="threePt" dir="t"/>
+    </dgm:scene3d>
+    <dgm:sp3d/>
+    <dgm:txPr/>
+    <dgm:style>
+      <a:lnRef idx="2">
+        <a:scrgbClr r="0" g="0" b="0"/>
+      </a:lnRef>
+      <a:fillRef idx="1">
+        <a:scrgbClr r="0" g="0" b="0"/>
+      </a:fillRef>
+      <a:effectRef idx="0">
+        <a:scrgbClr r="0" g="0" b="0"/>
+      </a:effectRef>
+      <a:fontRef idx="minor"/>
+    </dgm:style>
+  </dgm:styleLbl>
+  <dgm:styleLbl name="solidFgAcc1">
+    <dgm:scene3d>
+      <a:camera prst="orthographicFront"/>
+      <a:lightRig rig="threePt" dir="t"/>
+    </dgm:scene3d>
+    <dgm:sp3d/>
+    <dgm:txPr/>
+    <dgm:style>
+      <a:lnRef idx="2">
+        <a:scrgbClr r="0" g="0" b="0"/>
+      </a:lnRef>
+      <a:fillRef idx="1">
+        <a:scrgbClr r="0" g="0" b="0"/>
+      </a:fillRef>
+      <a:effectRef idx="0">
+        <a:scrgbClr r="0" g="0" b="0"/>
+      </a:effectRef>
+      <a:fontRef idx="minor"/>
+    </dgm:style>
+  </dgm:styleLbl>
+  <dgm:styleLbl name="solidAlignAcc1">
+    <dgm:scene3d>
+      <a:camera prst="orthographicFront"/>
+      <a:lightRig rig="threePt" dir="t"/>
+    </dgm:scene3d>
+    <dgm:sp3d/>
+    <dgm:txPr/>
+    <dgm:style>
+      <a:lnRef idx="2">
+        <a:scrgbClr r="0" g="0" b="0"/>
+      </a:lnRef>
+      <a:fillRef idx="1">
+        <a:scrgbClr r="0" g="0" b="0"/>
+      </a:fillRef>
+      <a:effectRef idx="0">
+        <a:scrgbClr r="0" g="0" b="0"/>
+      </a:effectRef>
+      <a:fontRef idx="minor"/>
+    </dgm:style>
+  </dgm:styleLbl>
+  <dgm:styleLbl name="solidBgAcc1">
+    <dgm:scene3d>
+      <a:camera prst="orthographicFront"/>
+      <a:lightRig rig="threePt" dir="t"/>
+    </dgm:scene3d>
+    <dgm:sp3d/>
+    <dgm:txPr/>
+    <dgm:style>
+      <a:lnRef idx="2">
+        <a:scrgbClr r="0" g="0" b="0"/>
+      </a:lnRef>
+      <a:fillRef idx="1">
+        <a:scrgbClr r="0" g="0" b="0"/>
+      </a:fillRef>
+      <a:effectRef idx="0">
+        <a:scrgbClr r="0" g="0" b="0"/>
+      </a:effectRef>
+      <a:fontRef idx="minor"/>
+    </dgm:style>
+  </dgm:styleLbl>
+  <dgm:styleLbl name="fgAccFollowNode1">
+    <dgm:scene3d>
+      <a:camera prst="orthographicFront"/>
+      <a:lightRig rig="threePt" dir="t"/>
+    </dgm:scene3d>
+    <dgm:sp3d/>
+    <dgm:txPr/>
+    <dgm:style>
+      <a:lnRef idx="2">
+        <a:scrgbClr r="0" g="0" b="0"/>
+      </a:lnRef>
+      <a:fillRef idx="1">
+        <a:scrgbClr r="0" g="0" b="0"/>
+      </a:fillRef>
+      <a:effectRef idx="0">
+        <a:scrgbClr r="0" g="0" b="0"/>
+      </a:effectRef>
+      <a:fontRef idx="minor"/>
+    </dgm:style>
+  </dgm:styleLbl>
+  <dgm:styleLbl name="alignAccFollowNode1">
+    <dgm:scene3d>
+      <a:camera prst="orthographicFront"/>
+      <a:lightRig rig="threePt" dir="t"/>
+    </dgm:scene3d>
+    <dgm:sp3d/>
+    <dgm:txPr/>
+    <dgm:style>
+      <a:lnRef idx="2">
+        <a:scrgbClr r="0" g="0" b="0"/>
+      </a:lnRef>
+      <a:fillRef idx="1">
+        <a:scrgbClr r="0" g="0" b="0"/>
+      </a:fillRef>
+      <a:effectRef idx="0">
+        <a:scrgbClr r="0" g="0" b="0"/>
+      </a:effectRef>
+      <a:fontRef idx="minor"/>
+    </dgm:style>
+  </dgm:styleLbl>
+  <dgm:styleLbl name="bgAccFollowNode1">
+    <dgm:scene3d>
+      <a:camera prst="orthographicFront"/>
+      <a:lightRig rig="threePt" dir="t"/>
+    </dgm:scene3d>
+    <dgm:sp3d/>
+    <dgm:txPr/>
+    <dgm:style>
+      <a:lnRef idx="2">
+        <a:scrgbClr r="0" g="0" b="0"/>
+      </a:lnRef>
+      <a:fillRef idx="1">
+        <a:scrgbClr r="0" g="0" b="0"/>
+      </a:fillRef>
+      <a:effectRef idx="0">
+        <a:scrgbClr r="0" g="0" b="0"/>
+      </a:effectRef>
+      <a:fontRef idx="minor"/>
+    </dgm:style>
+  </dgm:styleLbl>
+  <dgm:styleLbl name="fgAcc0">
+    <dgm:scene3d>
+      <a:camera prst="orthographicFront"/>
+      <a:lightRig rig="threePt" dir="t"/>
+    </dgm:scene3d>
+    <dgm:sp3d/>
+    <dgm:txPr/>
+    <dgm:style>
+      <a:lnRef idx="2">
+        <a:scrgbClr r="0" g="0" b="0"/>
+      </a:lnRef>
+      <a:fillRef idx="1">
+        <a:scrgbClr r="0" g="0" b="0"/>
+      </a:fillRef>
+      <a:effectRef idx="0">
+        <a:scrgbClr r="0" g="0" b="0"/>
+      </a:effectRef>
+      <a:fontRef idx="minor"/>
+    </dgm:style>
+  </dgm:styleLbl>
+  <dgm:styleLbl name="fgAcc2">
+    <dgm:scene3d>
+      <a:camera prst="orthographicFront"/>
+      <a:lightRig rig="threePt" dir="t"/>
+    </dgm:scene3d>
+    <dgm:sp3d/>
+    <dgm:txPr/>
+    <dgm:style>
+      <a:lnRef idx="2">
+        <a:scrgbClr r="0" g="0" b="0"/>
+      </a:lnRef>
+      <a:fillRef idx="1">
+        <a:scrgbClr r="0" g="0" b="0"/>
+      </a:fillRef>
+      <a:effectRef idx="0">
+        <a:scrgbClr r="0" g="0" b="0"/>
+      </a:effectRef>
+      <a:fontRef idx="minor"/>
+    </dgm:style>
+  </dgm:styleLbl>
+  <dgm:styleLbl name="fgAcc3">
+    <dgm:scene3d>
+      <a:camera prst="orthographicFront"/>
+      <a:lightRig rig="threePt" dir="t"/>
+    </dgm:scene3d>
+    <dgm:sp3d/>
+    <dgm:txPr/>
+    <dgm:style>
+      <a:lnRef idx="2">
+        <a:scrgbClr r="0" g="0" b="0"/>
+      </a:lnRef>
+      <a:fillRef idx="1">
+        <a:scrgbClr r="0" g="0" b="0"/>
+      </a:fillRef>
+      <a:effectRef idx="0">
+        <a:scrgbClr r="0" g="0" b="0"/>
+      </a:effectRef>
+      <a:fontRef idx="minor"/>
+    </dgm:style>
+  </dgm:styleLbl>
+  <dgm:styleLbl name="fgAcc4">
+    <dgm:scene3d>
+      <a:camera prst="orthographicFront"/>
+      <a:lightRig rig="threePt" dir="t"/>
+    </dgm:scene3d>
+    <dgm:sp3d/>
+    <dgm:txPr/>
+    <dgm:style>
+      <a:lnRef idx="2">
+        <a:scrgbClr r="0" g="0" b="0"/>
+      </a:lnRef>
+      <a:fillRef idx="1">
+        <a:scrgbClr r="0" g="0" b="0"/>
+      </a:fillRef>
+      <a:effectRef idx="0">
+        <a:scrgbClr r="0" g="0" b="0"/>
+      </a:effectRef>
+      <a:fontRef idx="minor"/>
+    </dgm:style>
+  </dgm:styleLbl>
+  <dgm:styleLbl name="bgShp">
+    <dgm:scene3d>
+      <a:camera prst="orthographicFront"/>
+      <a:lightRig rig="threePt" dir="t"/>
+    </dgm:scene3d>
+    <dgm:sp3d/>
+    <dgm:txPr/>
+    <dgm:style>
+      <a:lnRef idx="0">
+        <a:scrgbClr r="0" g="0" b="0"/>
+      </a:lnRef>
+      <a:fillRef idx="1">
+        <a:scrgbClr r="0" g="0" b="0"/>
+      </a:fillRef>
+      <a:effectRef idx="0">
+        <a:scrgbClr r="0" g="0" b="0"/>
+      </a:effectRef>
+      <a:fontRef idx="minor"/>
+    </dgm:style>
+  </dgm:styleLbl>
+  <dgm:styleLbl name="dkBgShp">
+    <dgm:scene3d>
+      <a:camera prst="orthographicFront"/>
+      <a:lightRig rig="threePt" dir="t"/>
+    </dgm:scene3d>
+    <dgm:sp3d/>
+    <dgm:txPr/>
+    <dgm:style>
+      <a:lnRef idx="0">
+        <a:scrgbClr r="0" g="0" b="0"/>
+      </a:lnRef>
+      <a:fillRef idx="1">
+        <a:scrgbClr r="0" g="0" b="0"/>
+      </a:fillRef>
+      <a:effectRef idx="0">
+        <a:scrgbClr r="0" g="0" b="0"/>
+      </a:effectRef>
+      <a:fontRef idx="minor"/>
+    </dgm:style>
+  </dgm:styleLbl>
+  <dgm:styleLbl name="trBgShp">
+    <dgm:scene3d>
+      <a:camera prst="orthographicFront"/>
+      <a:lightRig rig="threePt" dir="t"/>
+    </dgm:scene3d>
+    <dgm:sp3d/>
+    <dgm:txPr/>
+    <dgm:style>
+      <a:lnRef idx="0">
+        <a:scrgbClr r="0" g="0" b="0"/>
+      </a:lnRef>
+      <a:fillRef idx="1">
+        <a:scrgbClr r="0" g="0" b="0"/>
+      </a:fillRef>
+      <a:effectRef idx="0">
+        <a:scrgbClr r="0" g="0" b="0"/>
+      </a:effectRef>
+      <a:fontRef idx="minor"/>
+    </dgm:style>
+  </dgm:styleLbl>
+  <dgm:styleLbl name="fgShp">
+    <dgm:scene3d>
+      <a:camera prst="orthographicFront"/>
+      <a:lightRig rig="threePt" dir="t"/>
+    </dgm:scene3d>
+    <dgm:sp3d/>
+    <dgm:txPr/>
+    <dgm:style>
+      <a:lnRef idx="2">
+        <a:scrgbClr r="0" g="0" b="0"/>
+      </a:lnRef>
+      <a:fillRef idx="1">
+        <a:scrgbClr r="0" g="0" b="0"/>
+      </a:fillRef>
+      <a:effectRef idx="0">
+        <a:scrgbClr r="0" g="0" b="0"/>
+      </a:effectRef>
+      <a:fontRef idx="minor"/>
+    </dgm:style>
+  </dgm:styleLbl>
+  <dgm:styleLbl name="revTx">
+    <dgm:scene3d>
+      <a:camera prst="orthographicFront"/>
+      <a:lightRig rig="threePt" dir="t"/>
+    </dgm:scene3d>
+    <dgm:sp3d/>
+    <dgm:txPr/>
+    <dgm:style>
+      <a:lnRef idx="0">
+        <a:scrgbClr r="0" g="0" b="0"/>
+      </a:lnRef>
+      <a:fillRef idx="0">
+        <a:scrgbClr r="0" g="0" b="0"/>
+      </a:fillRef>
+      <a:effectRef idx="0">
+        <a:scrgbClr r="0" g="0" b="0"/>
+      </a:effectRef>
+      <a:fontRef idx="minor"/>
+    </dgm:style>
+  </dgm:styleLbl>
+</dgm:styleDef>
+</file>
+
 <file path=ppt/notesMasters/notesMaster1.xml><?xml version="1.0" encoding="utf-8"?>
 <p:notesMaster xmlns:a="http://schemas.openxmlformats.org/drawingml/2006/main" xmlns:r="http://schemas.openxmlformats.org/officeDocument/2006/relationships" xmlns:p="http://schemas.openxmlformats.org/presentationml/2006/main">
   <p:cSld>
@@ -6090,7 +8327,7 @@
           <a:p>
             <a:fld id="{00B92C5A-80A0-4C6E-9437-3D460B84558E}" type="datetimeFigureOut">
               <a:rPr lang="nl-BE" smtClean="0"/>
-              <a:t>26/06/2026</a:t>
+              <a:t>4/07/2026</a:t>
             </a:fld>
             <a:endParaRPr lang="nl-BE"/>
           </a:p>
@@ -6507,7 +8744,7 @@
           <a:p>
             <a:fld id="{00E43CE8-0ECF-46D5-95BF-B0947A229023}" type="datetimeFigureOut">
               <a:rPr lang="nl-BE" smtClean="0"/>
-              <a:t>26/06/2026</a:t>
+              <a:t>4/07/2026</a:t>
             </a:fld>
             <a:endParaRPr lang="nl-BE"/>
           </a:p>
@@ -6707,7 +8944,7 @@
           <a:p>
             <a:fld id="{00E43CE8-0ECF-46D5-95BF-B0947A229023}" type="datetimeFigureOut">
               <a:rPr lang="nl-BE" smtClean="0"/>
-              <a:t>26/06/2026</a:t>
+              <a:t>4/07/2026</a:t>
             </a:fld>
             <a:endParaRPr lang="nl-BE"/>
           </a:p>
@@ -6917,7 +9154,7 @@
           <a:p>
             <a:fld id="{00E43CE8-0ECF-46D5-95BF-B0947A229023}" type="datetimeFigureOut">
               <a:rPr lang="nl-BE" smtClean="0"/>
-              <a:t>26/06/2026</a:t>
+              <a:t>4/07/2026</a:t>
             </a:fld>
             <a:endParaRPr lang="nl-BE"/>
           </a:p>
@@ -7117,7 +9354,7 @@
           <a:p>
             <a:fld id="{00E43CE8-0ECF-46D5-95BF-B0947A229023}" type="datetimeFigureOut">
               <a:rPr lang="nl-BE" smtClean="0"/>
-              <a:t>26/06/2026</a:t>
+              <a:t>4/07/2026</a:t>
             </a:fld>
             <a:endParaRPr lang="nl-BE"/>
           </a:p>
@@ -7393,7 +9630,7 @@
           <a:p>
             <a:fld id="{00E43CE8-0ECF-46D5-95BF-B0947A229023}" type="datetimeFigureOut">
               <a:rPr lang="nl-BE" smtClean="0"/>
-              <a:t>26/06/2026</a:t>
+              <a:t>4/07/2026</a:t>
             </a:fld>
             <a:endParaRPr lang="nl-BE"/>
           </a:p>
@@ -7661,7 +9898,7 @@
           <a:p>
             <a:fld id="{00E43CE8-0ECF-46D5-95BF-B0947A229023}" type="datetimeFigureOut">
               <a:rPr lang="nl-BE" smtClean="0"/>
-              <a:t>26/06/2026</a:t>
+              <a:t>4/07/2026</a:t>
             </a:fld>
             <a:endParaRPr lang="nl-BE"/>
           </a:p>
@@ -8076,7 +10313,7 @@
           <a:p>
             <a:fld id="{00E43CE8-0ECF-46D5-95BF-B0947A229023}" type="datetimeFigureOut">
               <a:rPr lang="nl-BE" smtClean="0"/>
-              <a:t>26/06/2026</a:t>
+              <a:t>4/07/2026</a:t>
             </a:fld>
             <a:endParaRPr lang="nl-BE"/>
           </a:p>
@@ -8218,7 +10455,7 @@
           <a:p>
             <a:fld id="{00E43CE8-0ECF-46D5-95BF-B0947A229023}" type="datetimeFigureOut">
               <a:rPr lang="nl-BE" smtClean="0"/>
-              <a:t>26/06/2026</a:t>
+              <a:t>4/07/2026</a:t>
             </a:fld>
             <a:endParaRPr lang="nl-BE"/>
           </a:p>
@@ -8331,7 +10568,7 @@
           <a:p>
             <a:fld id="{00E43CE8-0ECF-46D5-95BF-B0947A229023}" type="datetimeFigureOut">
               <a:rPr lang="nl-BE" smtClean="0"/>
-              <a:t>26/06/2026</a:t>
+              <a:t>4/07/2026</a:t>
             </a:fld>
             <a:endParaRPr lang="nl-BE"/>
           </a:p>
@@ -8644,7 +10881,7 @@
           <a:p>
             <a:fld id="{00E43CE8-0ECF-46D5-95BF-B0947A229023}" type="datetimeFigureOut">
               <a:rPr lang="nl-BE" smtClean="0"/>
-              <a:t>26/06/2026</a:t>
+              <a:t>4/07/2026</a:t>
             </a:fld>
             <a:endParaRPr lang="nl-BE"/>
           </a:p>
@@ -8933,7 +11170,7 @@
           <a:p>
             <a:fld id="{00E43CE8-0ECF-46D5-95BF-B0947A229023}" type="datetimeFigureOut">
               <a:rPr lang="nl-BE" smtClean="0"/>
-              <a:t>26/06/2026</a:t>
+              <a:t>4/07/2026</a:t>
             </a:fld>
             <a:endParaRPr lang="nl-BE"/>
           </a:p>
@@ -9176,7 +11413,7 @@
           <a:p>
             <a:fld id="{00E43CE8-0ECF-46D5-95BF-B0947A229023}" type="datetimeFigureOut">
               <a:rPr lang="nl-BE" smtClean="0"/>
-              <a:t>26/06/2026</a:t>
+              <a:t>4/07/2026</a:t>
             </a:fld>
             <a:endParaRPr lang="nl-BE"/>
           </a:p>
@@ -10957,6 +13194,994 @@
 </p:sld>
 </file>
 
+<file path=ppt/slides/slide4.xml><?xml version="1.0" encoding="utf-8"?>
+<p:sld xmlns:a="http://schemas.openxmlformats.org/drawingml/2006/main" xmlns:r="http://schemas.openxmlformats.org/officeDocument/2006/relationships" xmlns:p="http://schemas.openxmlformats.org/presentationml/2006/main">
+  <p:cSld>
+    <p:spTree>
+      <p:nvGrpSpPr>
+        <p:cNvPr id="1" name=""/>
+        <p:cNvGrpSpPr/>
+        <p:nvPr/>
+      </p:nvGrpSpPr>
+      <p:grpSpPr>
+        <a:xfrm>
+          <a:off x="0" y="0"/>
+          <a:ext cx="0" cy="0"/>
+          <a:chOff x="0" y="0"/>
+          <a:chExt cx="0" cy="0"/>
+        </a:xfrm>
+      </p:grpSpPr>
+      <p:graphicFrame>
+        <p:nvGraphicFramePr>
+          <p:cNvPr id="7" name="Tijdelijke aanduiding voor inhoud 3">
+            <a:extLst>
+              <a:ext uri="{FF2B5EF4-FFF2-40B4-BE49-F238E27FC236}">
+                <a16:creationId xmlns:a16="http://schemas.microsoft.com/office/drawing/2014/main" id="{9D945912-F800-6DE0-EEF2-1A24620A7116}"/>
+              </a:ext>
+            </a:extLst>
+          </p:cNvPr>
+          <p:cNvGraphicFramePr>
+            <a:graphicFrameLocks noGrp="1"/>
+          </p:cNvGraphicFramePr>
+          <p:nvPr>
+            <p:ph idx="1"/>
+            <p:extLst>
+              <p:ext uri="{D42A27DB-BD31-4B8C-83A1-F6EECF244321}">
+                <p14:modId xmlns:p14="http://schemas.microsoft.com/office/powerpoint/2010/main" val="666099895"/>
+              </p:ext>
+            </p:extLst>
+          </p:nvPr>
+        </p:nvGraphicFramePr>
+        <p:xfrm>
+          <a:off x="935657" y="1844581"/>
+          <a:ext cx="2897204" cy="3168838"/>
+        </p:xfrm>
+        <a:graphic>
+          <a:graphicData uri="http://schemas.openxmlformats.org/drawingml/2006/diagram">
+            <dgm:relIds xmlns:dgm="http://schemas.openxmlformats.org/drawingml/2006/diagram" xmlns:r="http://schemas.openxmlformats.org/officeDocument/2006/relationships" r:dm="rId2" r:lo="rId3" r:qs="rId4" r:cs="rId5"/>
+          </a:graphicData>
+        </a:graphic>
+      </p:graphicFrame>
+      <p:sp>
+        <p:nvSpPr>
+          <p:cNvPr id="10" name="Pijl: rechts 9">
+            <a:extLst>
+              <a:ext uri="{FF2B5EF4-FFF2-40B4-BE49-F238E27FC236}">
+                <a16:creationId xmlns:a16="http://schemas.microsoft.com/office/drawing/2014/main" id="{72650312-4A6A-64E8-7DA1-C0D49F2CCEA9}"/>
+              </a:ext>
+            </a:extLst>
+          </p:cNvPr>
+          <p:cNvSpPr/>
+          <p:nvPr/>
+        </p:nvSpPr>
+        <p:spPr>
+          <a:xfrm>
+            <a:off x="4056895" y="3226648"/>
+            <a:ext cx="1028914" cy="404704"/>
+          </a:xfrm>
+          <a:prstGeom prst="rightArrow">
+            <a:avLst/>
+          </a:prstGeom>
+          <a:solidFill>
+            <a:srgbClr val="2980B9"/>
+          </a:solidFill>
+          <a:ln>
+            <a:solidFill>
+              <a:srgbClr val="2980B9"/>
+            </a:solidFill>
+          </a:ln>
+        </p:spPr>
+        <p:style>
+          <a:lnRef idx="2">
+            <a:schemeClr val="accent1">
+              <a:shade val="15000"/>
+            </a:schemeClr>
+          </a:lnRef>
+          <a:fillRef idx="1">
+            <a:schemeClr val="accent1"/>
+          </a:fillRef>
+          <a:effectRef idx="0">
+            <a:schemeClr val="accent1"/>
+          </a:effectRef>
+          <a:fontRef idx="minor">
+            <a:schemeClr val="lt1"/>
+          </a:fontRef>
+        </p:style>
+        <p:txBody>
+          <a:bodyPr rtlCol="0" anchor="ctr"/>
+          <a:lstStyle/>
+          <a:p>
+            <a:pPr algn="ctr"/>
+            <a:endParaRPr lang="nl-BE" dirty="0"/>
+          </a:p>
+        </p:txBody>
+      </p:sp>
+      <p:sp>
+        <p:nvSpPr>
+          <p:cNvPr id="11" name="Rechthoek 10">
+            <a:extLst>
+              <a:ext uri="{FF2B5EF4-FFF2-40B4-BE49-F238E27FC236}">
+                <a16:creationId xmlns:a16="http://schemas.microsoft.com/office/drawing/2014/main" id="{1C80F10E-CD9A-A582-9CD3-7B12CD39A5B5}"/>
+              </a:ext>
+            </a:extLst>
+          </p:cNvPr>
+          <p:cNvSpPr/>
+          <p:nvPr/>
+        </p:nvSpPr>
+        <p:spPr>
+          <a:xfrm rot="1063658">
+            <a:off x="5497588" y="2743200"/>
+            <a:ext cx="399066" cy="1371600"/>
+          </a:xfrm>
+          <a:prstGeom prst="rect">
+            <a:avLst/>
+          </a:prstGeom>
+          <a:ln>
+            <a:noFill/>
+          </a:ln>
+        </p:spPr>
+        <p:style>
+          <a:lnRef idx="2">
+            <a:schemeClr val="accent1">
+              <a:shade val="15000"/>
+            </a:schemeClr>
+          </a:lnRef>
+          <a:fillRef idx="1">
+            <a:schemeClr val="accent1"/>
+          </a:fillRef>
+          <a:effectRef idx="0">
+            <a:schemeClr val="accent1"/>
+          </a:effectRef>
+          <a:fontRef idx="minor">
+            <a:schemeClr val="lt1"/>
+          </a:fontRef>
+        </p:style>
+        <p:txBody>
+          <a:bodyPr rtlCol="0" anchor="ctr"/>
+          <a:lstStyle/>
+          <a:p>
+            <a:pPr algn="ctr"/>
+            <a:endParaRPr lang="nl-BE"/>
+          </a:p>
+        </p:txBody>
+      </p:sp>
+      <p:sp>
+        <p:nvSpPr>
+          <p:cNvPr id="12" name="Rechthoek: afgeronde hoeken 11">
+            <a:extLst>
+              <a:ext uri="{FF2B5EF4-FFF2-40B4-BE49-F238E27FC236}">
+                <a16:creationId xmlns:a16="http://schemas.microsoft.com/office/drawing/2014/main" id="{A4A4B49E-090A-74AD-5DD9-1B5C58374CD8}"/>
+              </a:ext>
+            </a:extLst>
+          </p:cNvPr>
+          <p:cNvSpPr/>
+          <p:nvPr/>
+        </p:nvSpPr>
+        <p:spPr>
+          <a:xfrm>
+            <a:off x="5107524" y="2244631"/>
+            <a:ext cx="6503234" cy="2603594"/>
+          </a:xfrm>
+          <a:prstGeom prst="roundRect">
+            <a:avLst>
+              <a:gd name="adj" fmla="val 13309"/>
+            </a:avLst>
+          </a:prstGeom>
+          <a:noFill/>
+          <a:ln w="57150">
+            <a:solidFill>
+              <a:srgbClr val="2980B9"/>
+            </a:solidFill>
+          </a:ln>
+        </p:spPr>
+        <p:style>
+          <a:lnRef idx="2">
+            <a:schemeClr val="accent1">
+              <a:shade val="15000"/>
+            </a:schemeClr>
+          </a:lnRef>
+          <a:fillRef idx="1">
+            <a:schemeClr val="accent1"/>
+          </a:fillRef>
+          <a:effectRef idx="0">
+            <a:schemeClr val="accent1"/>
+          </a:effectRef>
+          <a:fontRef idx="minor">
+            <a:schemeClr val="lt1"/>
+          </a:fontRef>
+        </p:style>
+        <p:txBody>
+          <a:bodyPr rtlCol="0" anchor="ctr"/>
+          <a:lstStyle/>
+          <a:p>
+            <a:pPr algn="ctr"/>
+            <a:endParaRPr lang="nl-BE" dirty="0"/>
+          </a:p>
+        </p:txBody>
+      </p:sp>
+      <p:sp>
+        <p:nvSpPr>
+          <p:cNvPr id="14" name="Tekstvak 13">
+            <a:extLst>
+              <a:ext uri="{FF2B5EF4-FFF2-40B4-BE49-F238E27FC236}">
+                <a16:creationId xmlns:a16="http://schemas.microsoft.com/office/drawing/2014/main" id="{08D0DEE9-C6BD-A3B6-CDD4-934A37F4F207}"/>
+              </a:ext>
+            </a:extLst>
+          </p:cNvPr>
+          <p:cNvSpPr txBox="1"/>
+          <p:nvPr/>
+        </p:nvSpPr>
+        <p:spPr>
+          <a:xfrm>
+            <a:off x="6831332" y="1663868"/>
+            <a:ext cx="3055618" cy="338554"/>
+          </a:xfrm>
+          <a:prstGeom prst="rect">
+            <a:avLst/>
+          </a:prstGeom>
+          <a:noFill/>
+        </p:spPr>
+        <p:txBody>
+          <a:bodyPr wrap="square" rtlCol="0">
+            <a:spAutoFit/>
+          </a:bodyPr>
+          <a:lstStyle/>
+          <a:p>
+            <a:pPr algn="ctr"/>
+            <a:r>
+              <a:rPr lang="en-US" sz="1600" b="1" dirty="0"/>
+              <a:t>Reorder strokes in queues</a:t>
+            </a:r>
+            <a:endParaRPr lang="nl-BE" sz="1600" b="1" dirty="0"/>
+          </a:p>
+        </p:txBody>
+      </p:sp>
+      <p:sp>
+        <p:nvSpPr>
+          <p:cNvPr id="16" name="Rechthoek 15">
+            <a:extLst>
+              <a:ext uri="{FF2B5EF4-FFF2-40B4-BE49-F238E27FC236}">
+                <a16:creationId xmlns:a16="http://schemas.microsoft.com/office/drawing/2014/main" id="{AC26EEB8-B38B-140A-8E84-E4507A7831E0}"/>
+              </a:ext>
+            </a:extLst>
+          </p:cNvPr>
+          <p:cNvSpPr/>
+          <p:nvPr/>
+        </p:nvSpPr>
+        <p:spPr>
+          <a:xfrm rot="20533397">
+            <a:off x="6390707" y="2743200"/>
+            <a:ext cx="399066" cy="1371600"/>
+          </a:xfrm>
+          <a:prstGeom prst="rect">
+            <a:avLst/>
+          </a:prstGeom>
+          <a:solidFill>
+            <a:srgbClr val="FF0000"/>
+          </a:solidFill>
+          <a:ln>
+            <a:noFill/>
+          </a:ln>
+        </p:spPr>
+        <p:style>
+          <a:lnRef idx="2">
+            <a:schemeClr val="accent1">
+              <a:shade val="15000"/>
+            </a:schemeClr>
+          </a:lnRef>
+          <a:fillRef idx="1">
+            <a:schemeClr val="accent1"/>
+          </a:fillRef>
+          <a:effectRef idx="0">
+            <a:schemeClr val="accent1"/>
+          </a:effectRef>
+          <a:fontRef idx="minor">
+            <a:schemeClr val="lt1"/>
+          </a:fontRef>
+        </p:style>
+        <p:txBody>
+          <a:bodyPr rtlCol="0" anchor="ctr"/>
+          <a:lstStyle/>
+          <a:p>
+            <a:pPr algn="ctr"/>
+            <a:endParaRPr lang="nl-BE"/>
+          </a:p>
+        </p:txBody>
+      </p:sp>
+      <p:sp>
+        <p:nvSpPr>
+          <p:cNvPr id="18" name="Rechthoek 17">
+            <a:extLst>
+              <a:ext uri="{FF2B5EF4-FFF2-40B4-BE49-F238E27FC236}">
+                <a16:creationId xmlns:a16="http://schemas.microsoft.com/office/drawing/2014/main" id="{4BB7C64C-DF6A-419D-54E6-B1C72497F3E9}"/>
+              </a:ext>
+            </a:extLst>
+          </p:cNvPr>
+          <p:cNvSpPr/>
+          <p:nvPr/>
+        </p:nvSpPr>
+        <p:spPr>
+          <a:xfrm rot="15296541">
+            <a:off x="7436772" y="2643353"/>
+            <a:ext cx="399066" cy="1371600"/>
+          </a:xfrm>
+          <a:prstGeom prst="rect">
+            <a:avLst/>
+          </a:prstGeom>
+          <a:solidFill>
+            <a:schemeClr val="accent6"/>
+          </a:solidFill>
+          <a:ln>
+            <a:noFill/>
+          </a:ln>
+        </p:spPr>
+        <p:style>
+          <a:lnRef idx="2">
+            <a:schemeClr val="accent1">
+              <a:shade val="15000"/>
+            </a:schemeClr>
+          </a:lnRef>
+          <a:fillRef idx="1">
+            <a:schemeClr val="accent1"/>
+          </a:fillRef>
+          <a:effectRef idx="0">
+            <a:schemeClr val="accent1"/>
+          </a:effectRef>
+          <a:fontRef idx="minor">
+            <a:schemeClr val="lt1"/>
+          </a:fontRef>
+        </p:style>
+        <p:txBody>
+          <a:bodyPr rtlCol="0" anchor="ctr"/>
+          <a:lstStyle/>
+          <a:p>
+            <a:pPr algn="ctr"/>
+            <a:endParaRPr lang="nl-BE"/>
+          </a:p>
+        </p:txBody>
+      </p:sp>
+      <p:sp>
+        <p:nvSpPr>
+          <p:cNvPr id="20" name="Rechthoek 19">
+            <a:extLst>
+              <a:ext uri="{FF2B5EF4-FFF2-40B4-BE49-F238E27FC236}">
+                <a16:creationId xmlns:a16="http://schemas.microsoft.com/office/drawing/2014/main" id="{42687509-B792-7B1C-4599-BB2AD384047A}"/>
+              </a:ext>
+            </a:extLst>
+          </p:cNvPr>
+          <p:cNvSpPr/>
+          <p:nvPr/>
+        </p:nvSpPr>
+        <p:spPr>
+          <a:xfrm rot="12733012">
+            <a:off x="8791057" y="2643352"/>
+            <a:ext cx="399066" cy="1371600"/>
+          </a:xfrm>
+          <a:prstGeom prst="rect">
+            <a:avLst/>
+          </a:prstGeom>
+          <a:ln>
+            <a:noFill/>
+          </a:ln>
+        </p:spPr>
+        <p:style>
+          <a:lnRef idx="2">
+            <a:schemeClr val="accent1">
+              <a:shade val="15000"/>
+            </a:schemeClr>
+          </a:lnRef>
+          <a:fillRef idx="1">
+            <a:schemeClr val="accent1"/>
+          </a:fillRef>
+          <a:effectRef idx="0">
+            <a:schemeClr val="accent1"/>
+          </a:effectRef>
+          <a:fontRef idx="minor">
+            <a:schemeClr val="lt1"/>
+          </a:fontRef>
+        </p:style>
+        <p:txBody>
+          <a:bodyPr rtlCol="0" anchor="ctr"/>
+          <a:lstStyle/>
+          <a:p>
+            <a:pPr algn="ctr"/>
+            <a:endParaRPr lang="nl-BE"/>
+          </a:p>
+        </p:txBody>
+      </p:sp>
+      <p:sp>
+        <p:nvSpPr>
+          <p:cNvPr id="22" name="Rechthoek 21">
+            <a:extLst>
+              <a:ext uri="{FF2B5EF4-FFF2-40B4-BE49-F238E27FC236}">
+                <a16:creationId xmlns:a16="http://schemas.microsoft.com/office/drawing/2014/main" id="{FC3C3456-F5BB-AEAC-4ABE-48CFBC206B92}"/>
+              </a:ext>
+            </a:extLst>
+          </p:cNvPr>
+          <p:cNvSpPr/>
+          <p:nvPr/>
+        </p:nvSpPr>
+        <p:spPr>
+          <a:xfrm rot="19848144">
+            <a:off x="10151826" y="2643352"/>
+            <a:ext cx="399066" cy="1371600"/>
+          </a:xfrm>
+          <a:prstGeom prst="rect">
+            <a:avLst/>
+          </a:prstGeom>
+          <a:solidFill>
+            <a:schemeClr val="accent6"/>
+          </a:solidFill>
+          <a:ln>
+            <a:noFill/>
+          </a:ln>
+        </p:spPr>
+        <p:style>
+          <a:lnRef idx="2">
+            <a:schemeClr val="accent1">
+              <a:shade val="15000"/>
+            </a:schemeClr>
+          </a:lnRef>
+          <a:fillRef idx="1">
+            <a:schemeClr val="accent1"/>
+          </a:fillRef>
+          <a:effectRef idx="0">
+            <a:schemeClr val="accent1"/>
+          </a:effectRef>
+          <a:fontRef idx="minor">
+            <a:schemeClr val="lt1"/>
+          </a:fontRef>
+        </p:style>
+        <p:txBody>
+          <a:bodyPr rtlCol="0" anchor="ctr"/>
+          <a:lstStyle/>
+          <a:p>
+            <a:pPr algn="ctr"/>
+            <a:endParaRPr lang="nl-BE"/>
+          </a:p>
+        </p:txBody>
+      </p:sp>
+      <p:grpSp>
+        <p:nvGrpSpPr>
+          <p:cNvPr id="29" name="Groep 28">
+            <a:extLst>
+              <a:ext uri="{FF2B5EF4-FFF2-40B4-BE49-F238E27FC236}">
+                <a16:creationId xmlns:a16="http://schemas.microsoft.com/office/drawing/2014/main" id="{B94E1660-7897-2BDA-AD54-CC60E88F6F31}"/>
+              </a:ext>
+            </a:extLst>
+          </p:cNvPr>
+          <p:cNvGrpSpPr/>
+          <p:nvPr/>
+        </p:nvGrpSpPr>
+        <p:grpSpPr>
+          <a:xfrm>
+            <a:off x="5075744" y="4982165"/>
+            <a:ext cx="1020256" cy="720324"/>
+            <a:chOff x="5075744" y="4958080"/>
+            <a:chExt cx="1020256" cy="720324"/>
+          </a:xfrm>
+        </p:grpSpPr>
+        <p:sp>
+          <p:nvSpPr>
+            <p:cNvPr id="25" name="Vierkante haak links 24">
+              <a:extLst>
+                <a:ext uri="{FF2B5EF4-FFF2-40B4-BE49-F238E27FC236}">
+                  <a16:creationId xmlns:a16="http://schemas.microsoft.com/office/drawing/2014/main" id="{84BB0CFB-8C5B-74E3-F7AE-3577BF10A954}"/>
+                </a:ext>
+              </a:extLst>
+            </p:cNvPr>
+            <p:cNvSpPr/>
+            <p:nvPr/>
+          </p:nvSpPr>
+          <p:spPr>
+            <a:xfrm rot="5400000">
+              <a:off x="5390609" y="4973014"/>
+              <a:ext cx="390525" cy="1020256"/>
+            </a:xfrm>
+            <a:prstGeom prst="leftBracket">
+              <a:avLst/>
+            </a:prstGeom>
+            <a:ln w="38100"/>
+          </p:spPr>
+          <p:style>
+            <a:lnRef idx="2">
+              <a:schemeClr val="accent1"/>
+            </a:lnRef>
+            <a:fillRef idx="0">
+              <a:schemeClr val="accent1"/>
+            </a:fillRef>
+            <a:effectRef idx="1">
+              <a:schemeClr val="accent1"/>
+            </a:effectRef>
+            <a:fontRef idx="minor">
+              <a:schemeClr val="tx1"/>
+            </a:fontRef>
+          </p:style>
+          <p:txBody>
+            <a:bodyPr rtlCol="0" anchor="ctr"/>
+            <a:lstStyle/>
+            <a:p>
+              <a:pPr algn="ctr"/>
+              <a:endParaRPr lang="nl-BE" dirty="0"/>
+            </a:p>
+          </p:txBody>
+        </p:sp>
+        <p:sp>
+          <p:nvSpPr>
+            <p:cNvPr id="28" name="Tekstvak 27">
+              <a:extLst>
+                <a:ext uri="{FF2B5EF4-FFF2-40B4-BE49-F238E27FC236}">
+                  <a16:creationId xmlns:a16="http://schemas.microsoft.com/office/drawing/2014/main" id="{8B017447-BC37-4CF9-E8AA-42BAC8970BAA}"/>
+                </a:ext>
+              </a:extLst>
+            </p:cNvPr>
+            <p:cNvSpPr txBox="1"/>
+            <p:nvPr/>
+          </p:nvSpPr>
+          <p:spPr>
+            <a:xfrm>
+              <a:off x="5085809" y="4958080"/>
+              <a:ext cx="1010191" cy="369332"/>
+            </a:xfrm>
+            <a:prstGeom prst="rect">
+              <a:avLst/>
+            </a:prstGeom>
+            <a:noFill/>
+          </p:spPr>
+          <p:txBody>
+            <a:bodyPr wrap="square" rtlCol="0">
+              <a:spAutoFit/>
+            </a:bodyPr>
+            <a:lstStyle/>
+            <a:p>
+              <a:pPr algn="ctr"/>
+              <a:r>
+                <a:rPr lang="en-US" dirty="0"/>
+                <a:t>1</a:t>
+              </a:r>
+              <a:endParaRPr lang="nl-BE" dirty="0"/>
+            </a:p>
+          </p:txBody>
+        </p:sp>
+      </p:grpSp>
+      <p:grpSp>
+        <p:nvGrpSpPr>
+          <p:cNvPr id="30" name="Groep 29">
+            <a:extLst>
+              <a:ext uri="{FF2B5EF4-FFF2-40B4-BE49-F238E27FC236}">
+                <a16:creationId xmlns:a16="http://schemas.microsoft.com/office/drawing/2014/main" id="{B0EEFAC2-652A-939B-D092-1B291D1724DD}"/>
+              </a:ext>
+            </a:extLst>
+          </p:cNvPr>
+          <p:cNvGrpSpPr/>
+          <p:nvPr/>
+        </p:nvGrpSpPr>
+        <p:grpSpPr>
+          <a:xfrm>
+            <a:off x="7779855" y="4982165"/>
+            <a:ext cx="1020256" cy="720324"/>
+            <a:chOff x="5075744" y="4958080"/>
+            <a:chExt cx="1020256" cy="720324"/>
+          </a:xfrm>
+        </p:grpSpPr>
+        <p:sp>
+          <p:nvSpPr>
+            <p:cNvPr id="31" name="Vierkante haak links 30">
+              <a:extLst>
+                <a:ext uri="{FF2B5EF4-FFF2-40B4-BE49-F238E27FC236}">
+                  <a16:creationId xmlns:a16="http://schemas.microsoft.com/office/drawing/2014/main" id="{D5882D11-F42C-17FA-1116-DA7FF909A572}"/>
+                </a:ext>
+              </a:extLst>
+            </p:cNvPr>
+            <p:cNvSpPr/>
+            <p:nvPr/>
+          </p:nvSpPr>
+          <p:spPr>
+            <a:xfrm rot="5400000">
+              <a:off x="5390609" y="4973014"/>
+              <a:ext cx="390525" cy="1020256"/>
+            </a:xfrm>
+            <a:prstGeom prst="leftBracket">
+              <a:avLst/>
+            </a:prstGeom>
+            <a:ln w="38100">
+              <a:solidFill>
+                <a:srgbClr val="FF0000"/>
+              </a:solidFill>
+            </a:ln>
+          </p:spPr>
+          <p:style>
+            <a:lnRef idx="2">
+              <a:schemeClr val="accent1"/>
+            </a:lnRef>
+            <a:fillRef idx="0">
+              <a:schemeClr val="accent1"/>
+            </a:fillRef>
+            <a:effectRef idx="1">
+              <a:schemeClr val="accent1"/>
+            </a:effectRef>
+            <a:fontRef idx="minor">
+              <a:schemeClr val="tx1"/>
+            </a:fontRef>
+          </p:style>
+          <p:txBody>
+            <a:bodyPr rtlCol="0" anchor="ctr"/>
+            <a:lstStyle/>
+            <a:p>
+              <a:pPr algn="ctr"/>
+              <a:endParaRPr lang="nl-BE"/>
+            </a:p>
+          </p:txBody>
+        </p:sp>
+        <p:sp>
+          <p:nvSpPr>
+            <p:cNvPr id="32" name="Tekstvak 31">
+              <a:extLst>
+                <a:ext uri="{FF2B5EF4-FFF2-40B4-BE49-F238E27FC236}">
+                  <a16:creationId xmlns:a16="http://schemas.microsoft.com/office/drawing/2014/main" id="{82567BE4-EA7E-E4FF-D6F4-95C4C54E4B12}"/>
+                </a:ext>
+              </a:extLst>
+            </p:cNvPr>
+            <p:cNvSpPr txBox="1"/>
+            <p:nvPr/>
+          </p:nvSpPr>
+          <p:spPr>
+            <a:xfrm>
+              <a:off x="5085809" y="4958080"/>
+              <a:ext cx="1010191" cy="369332"/>
+            </a:xfrm>
+            <a:prstGeom prst="rect">
+              <a:avLst/>
+            </a:prstGeom>
+            <a:noFill/>
+          </p:spPr>
+          <p:txBody>
+            <a:bodyPr wrap="square" rtlCol="0">
+              <a:spAutoFit/>
+            </a:bodyPr>
+            <a:lstStyle/>
+            <a:p>
+              <a:pPr algn="ctr"/>
+              <a:r>
+                <a:rPr lang="en-US" dirty="0"/>
+                <a:t>2</a:t>
+              </a:r>
+              <a:endParaRPr lang="nl-BE" dirty="0"/>
+            </a:p>
+          </p:txBody>
+        </p:sp>
+      </p:grpSp>
+      <p:grpSp>
+        <p:nvGrpSpPr>
+          <p:cNvPr id="33" name="Groep 32">
+            <a:extLst>
+              <a:ext uri="{FF2B5EF4-FFF2-40B4-BE49-F238E27FC236}">
+                <a16:creationId xmlns:a16="http://schemas.microsoft.com/office/drawing/2014/main" id="{D3ADB382-D1EE-6538-9D5C-778F045DE14E}"/>
+              </a:ext>
+            </a:extLst>
+          </p:cNvPr>
+          <p:cNvGrpSpPr/>
+          <p:nvPr/>
+        </p:nvGrpSpPr>
+        <p:grpSpPr>
+          <a:xfrm>
+            <a:off x="10483965" y="4982165"/>
+            <a:ext cx="1020256" cy="720324"/>
+            <a:chOff x="5075744" y="4958080"/>
+            <a:chExt cx="1020256" cy="720324"/>
+          </a:xfrm>
+        </p:grpSpPr>
+        <p:sp>
+          <p:nvSpPr>
+            <p:cNvPr id="34" name="Vierkante haak links 33">
+              <a:extLst>
+                <a:ext uri="{FF2B5EF4-FFF2-40B4-BE49-F238E27FC236}">
+                  <a16:creationId xmlns:a16="http://schemas.microsoft.com/office/drawing/2014/main" id="{179489B8-927B-8838-D89F-C3F344E1CC45}"/>
+                </a:ext>
+              </a:extLst>
+            </p:cNvPr>
+            <p:cNvSpPr/>
+            <p:nvPr/>
+          </p:nvSpPr>
+          <p:spPr>
+            <a:xfrm rot="5400000">
+              <a:off x="5390609" y="4973014"/>
+              <a:ext cx="390525" cy="1020256"/>
+            </a:xfrm>
+            <a:prstGeom prst="leftBracket">
+              <a:avLst/>
+            </a:prstGeom>
+            <a:ln w="38100">
+              <a:solidFill>
+                <a:schemeClr val="accent6"/>
+              </a:solidFill>
+            </a:ln>
+          </p:spPr>
+          <p:style>
+            <a:lnRef idx="2">
+              <a:schemeClr val="accent1"/>
+            </a:lnRef>
+            <a:fillRef idx="0">
+              <a:schemeClr val="accent1"/>
+            </a:fillRef>
+            <a:effectRef idx="1">
+              <a:schemeClr val="accent1"/>
+            </a:effectRef>
+            <a:fontRef idx="minor">
+              <a:schemeClr val="tx1"/>
+            </a:fontRef>
+          </p:style>
+          <p:txBody>
+            <a:bodyPr rtlCol="0" anchor="ctr"/>
+            <a:lstStyle/>
+            <a:p>
+              <a:pPr algn="ctr"/>
+              <a:endParaRPr lang="nl-BE" dirty="0"/>
+            </a:p>
+          </p:txBody>
+        </p:sp>
+        <p:sp>
+          <p:nvSpPr>
+            <p:cNvPr id="35" name="Tekstvak 34">
+              <a:extLst>
+                <a:ext uri="{FF2B5EF4-FFF2-40B4-BE49-F238E27FC236}">
+                  <a16:creationId xmlns:a16="http://schemas.microsoft.com/office/drawing/2014/main" id="{1655254B-DB20-02D2-DFDD-C020D7B49FFA}"/>
+                </a:ext>
+              </a:extLst>
+            </p:cNvPr>
+            <p:cNvSpPr txBox="1"/>
+            <p:nvPr/>
+          </p:nvSpPr>
+          <p:spPr>
+            <a:xfrm>
+              <a:off x="5085809" y="4958080"/>
+              <a:ext cx="1010191" cy="369332"/>
+            </a:xfrm>
+            <a:prstGeom prst="rect">
+              <a:avLst/>
+            </a:prstGeom>
+            <a:noFill/>
+          </p:spPr>
+          <p:txBody>
+            <a:bodyPr wrap="square" rtlCol="0">
+              <a:spAutoFit/>
+            </a:bodyPr>
+            <a:lstStyle/>
+            <a:p>
+              <a:pPr algn="ctr"/>
+              <a:r>
+                <a:rPr lang="en-US" dirty="0"/>
+                <a:t>3</a:t>
+              </a:r>
+            </a:p>
+          </p:txBody>
+        </p:sp>
+      </p:grpSp>
+      <p:cxnSp>
+        <p:nvCxnSpPr>
+          <p:cNvPr id="40" name="Rechte verbindingslijn met pijl 39">
+            <a:extLst>
+              <a:ext uri="{FF2B5EF4-FFF2-40B4-BE49-F238E27FC236}">
+                <a16:creationId xmlns:a16="http://schemas.microsoft.com/office/drawing/2014/main" id="{6F0F928C-0FF6-B0D1-643C-E1E643E9CC1F}"/>
+              </a:ext>
+            </a:extLst>
+          </p:cNvPr>
+          <p:cNvCxnSpPr/>
+          <p:nvPr/>
+        </p:nvCxnSpPr>
+        <p:spPr>
+          <a:xfrm>
+            <a:off x="5510893" y="4425043"/>
+            <a:ext cx="0" cy="1277447"/>
+          </a:xfrm>
+          <a:prstGeom prst="straightConnector1">
+            <a:avLst/>
+          </a:prstGeom>
+          <a:ln w="28575">
+            <a:tailEnd type="triangle"/>
+          </a:ln>
+        </p:spPr>
+        <p:style>
+          <a:lnRef idx="2">
+            <a:schemeClr val="accent1"/>
+          </a:lnRef>
+          <a:fillRef idx="0">
+            <a:schemeClr val="accent1"/>
+          </a:fillRef>
+          <a:effectRef idx="1">
+            <a:schemeClr val="accent1"/>
+          </a:effectRef>
+          <a:fontRef idx="minor">
+            <a:schemeClr val="tx1"/>
+          </a:fontRef>
+        </p:style>
+      </p:cxnSp>
+      <p:cxnSp>
+        <p:nvCxnSpPr>
+          <p:cNvPr id="41" name="Rechte verbindingslijn met pijl 40">
+            <a:extLst>
+              <a:ext uri="{FF2B5EF4-FFF2-40B4-BE49-F238E27FC236}">
+                <a16:creationId xmlns:a16="http://schemas.microsoft.com/office/drawing/2014/main" id="{4A81BB15-40B5-9DB0-A587-9A2340766DD5}"/>
+              </a:ext>
+            </a:extLst>
+          </p:cNvPr>
+          <p:cNvCxnSpPr>
+            <a:cxnSpLocks/>
+          </p:cNvCxnSpPr>
+          <p:nvPr/>
+        </p:nvCxnSpPr>
+        <p:spPr>
+          <a:xfrm>
+            <a:off x="6831332" y="4343441"/>
+            <a:ext cx="1300297" cy="1163786"/>
+          </a:xfrm>
+          <a:prstGeom prst="straightConnector1">
+            <a:avLst/>
+          </a:prstGeom>
+          <a:ln w="28575">
+            <a:solidFill>
+              <a:srgbClr val="FF0000"/>
+            </a:solidFill>
+            <a:tailEnd type="triangle"/>
+          </a:ln>
+        </p:spPr>
+        <p:style>
+          <a:lnRef idx="2">
+            <a:schemeClr val="accent1"/>
+          </a:lnRef>
+          <a:fillRef idx="0">
+            <a:schemeClr val="accent1"/>
+          </a:fillRef>
+          <a:effectRef idx="1">
+            <a:schemeClr val="accent1"/>
+          </a:effectRef>
+          <a:fontRef idx="minor">
+            <a:schemeClr val="tx1"/>
+          </a:fontRef>
+        </p:style>
+      </p:cxnSp>
+      <p:cxnSp>
+        <p:nvCxnSpPr>
+          <p:cNvPr id="43" name="Rechte verbindingslijn met pijl 42">
+            <a:extLst>
+              <a:ext uri="{FF2B5EF4-FFF2-40B4-BE49-F238E27FC236}">
+                <a16:creationId xmlns:a16="http://schemas.microsoft.com/office/drawing/2014/main" id="{ED083A61-60E7-B9AB-75AD-E85268F9EFE0}"/>
+              </a:ext>
+            </a:extLst>
+          </p:cNvPr>
+          <p:cNvCxnSpPr>
+            <a:cxnSpLocks/>
+          </p:cNvCxnSpPr>
+          <p:nvPr/>
+        </p:nvCxnSpPr>
+        <p:spPr>
+          <a:xfrm>
+            <a:off x="7920748" y="4258552"/>
+            <a:ext cx="3011231" cy="1303348"/>
+          </a:xfrm>
+          <a:prstGeom prst="straightConnector1">
+            <a:avLst/>
+          </a:prstGeom>
+          <a:ln w="28575">
+            <a:solidFill>
+              <a:schemeClr val="accent6"/>
+            </a:solidFill>
+            <a:tailEnd type="triangle"/>
+          </a:ln>
+        </p:spPr>
+        <p:style>
+          <a:lnRef idx="2">
+            <a:schemeClr val="accent1"/>
+          </a:lnRef>
+          <a:fillRef idx="0">
+            <a:schemeClr val="accent1"/>
+          </a:fillRef>
+          <a:effectRef idx="1">
+            <a:schemeClr val="accent1"/>
+          </a:effectRef>
+          <a:fontRef idx="minor">
+            <a:schemeClr val="tx1"/>
+          </a:fontRef>
+        </p:style>
+      </p:cxnSp>
+      <p:cxnSp>
+        <p:nvCxnSpPr>
+          <p:cNvPr id="45" name="Rechte verbindingslijn met pijl 44">
+            <a:extLst>
+              <a:ext uri="{FF2B5EF4-FFF2-40B4-BE49-F238E27FC236}">
+                <a16:creationId xmlns:a16="http://schemas.microsoft.com/office/drawing/2014/main" id="{B83AAEF0-EA20-DFCB-EF87-D317D92006F4}"/>
+              </a:ext>
+            </a:extLst>
+          </p:cNvPr>
+          <p:cNvCxnSpPr>
+            <a:cxnSpLocks/>
+          </p:cNvCxnSpPr>
+          <p:nvPr/>
+        </p:nvCxnSpPr>
+        <p:spPr>
+          <a:xfrm flipH="1">
+            <a:off x="5585871" y="4065002"/>
+            <a:ext cx="2870289" cy="2164348"/>
+          </a:xfrm>
+          <a:prstGeom prst="straightConnector1">
+            <a:avLst/>
+          </a:prstGeom>
+          <a:ln w="28575">
+            <a:tailEnd type="triangle"/>
+          </a:ln>
+        </p:spPr>
+        <p:style>
+          <a:lnRef idx="2">
+            <a:schemeClr val="accent1"/>
+          </a:lnRef>
+          <a:fillRef idx="0">
+            <a:schemeClr val="accent1"/>
+          </a:fillRef>
+          <a:effectRef idx="1">
+            <a:schemeClr val="accent1"/>
+          </a:effectRef>
+          <a:fontRef idx="minor">
+            <a:schemeClr val="tx1"/>
+          </a:fontRef>
+        </p:style>
+      </p:cxnSp>
+      <p:cxnSp>
+        <p:nvCxnSpPr>
+          <p:cNvPr id="47" name="Rechte verbindingslijn met pijl 46">
+            <a:extLst>
+              <a:ext uri="{FF2B5EF4-FFF2-40B4-BE49-F238E27FC236}">
+                <a16:creationId xmlns:a16="http://schemas.microsoft.com/office/drawing/2014/main" id="{A52B7A48-8F40-DEE4-B6CE-F7A471B63151}"/>
+              </a:ext>
+            </a:extLst>
+          </p:cNvPr>
+          <p:cNvCxnSpPr>
+            <a:cxnSpLocks/>
+          </p:cNvCxnSpPr>
+          <p:nvPr/>
+        </p:nvCxnSpPr>
+        <p:spPr>
+          <a:xfrm>
+            <a:off x="10337879" y="4008260"/>
+            <a:ext cx="663104" cy="2351719"/>
+          </a:xfrm>
+          <a:prstGeom prst="straightConnector1">
+            <a:avLst/>
+          </a:prstGeom>
+          <a:ln w="28575">
+            <a:solidFill>
+              <a:schemeClr val="accent6"/>
+            </a:solidFill>
+            <a:tailEnd type="triangle"/>
+          </a:ln>
+        </p:spPr>
+        <p:style>
+          <a:lnRef idx="2">
+            <a:schemeClr val="accent1"/>
+          </a:lnRef>
+          <a:fillRef idx="0">
+            <a:schemeClr val="accent1"/>
+          </a:fillRef>
+          <a:effectRef idx="1">
+            <a:schemeClr val="accent1"/>
+          </a:effectRef>
+          <a:fontRef idx="minor">
+            <a:schemeClr val="tx1"/>
+          </a:fontRef>
+        </p:style>
+      </p:cxnSp>
+    </p:spTree>
+    <p:extLst>
+      <p:ext uri="{BB962C8B-B14F-4D97-AF65-F5344CB8AC3E}">
+        <p14:creationId xmlns:p14="http://schemas.microsoft.com/office/powerpoint/2010/main" val="1996057303"/>
+      </p:ext>
+    </p:extLst>
+  </p:cSld>
+  <p:clrMapOvr>
+    <a:masterClrMapping/>
+  </p:clrMapOvr>
+</p:sld>
+</file>
+
 <file path=ppt/theme/theme1.xml><?xml version="1.0" encoding="utf-8"?>
 <a:theme xmlns:a="http://schemas.openxmlformats.org/drawingml/2006/main" name="Kantoorthema">
   <a:themeElements>

</xml_diff>

<commit_message>
Updated stroke ordering docs
</commit_message>
<xml_diff>
--- a/docs/stroke_algorithm/figures.pptx
+++ b/docs/stroke_algorithm/figures.pptx
@@ -5,13 +5,15 @@
     <p:sldMasterId id="2147483648" r:id="rId1"/>
   </p:sldMasterIdLst>
   <p:notesMasterIdLst>
-    <p:notesMasterId r:id="rId6"/>
+    <p:notesMasterId r:id="rId8"/>
   </p:notesMasterIdLst>
   <p:sldIdLst>
     <p:sldId id="258" r:id="rId2"/>
     <p:sldId id="260" r:id="rId3"/>
     <p:sldId id="259" r:id="rId4"/>
-    <p:sldId id="261" r:id="rId5"/>
+    <p:sldId id="263" r:id="rId5"/>
+    <p:sldId id="261" r:id="rId6"/>
+    <p:sldId id="262" r:id="rId7"/>
   </p:sldIdLst>
   <p:sldSz cx="12192000" cy="6858000"/>
   <p:notesSz cx="6858000" cy="9144000"/>
@@ -1613,6 +1615,753 @@
 </file>
 
 <file path=ppt/diagrams/colors3.xml><?xml version="1.0" encoding="utf-8"?>
+<dgm:colorsDef xmlns:dgm="http://schemas.openxmlformats.org/drawingml/2006/diagram" xmlns:a="http://schemas.openxmlformats.org/drawingml/2006/main" uniqueId="urn:microsoft.com/office/officeart/2005/8/colors/accent1_2">
+  <dgm:title val=""/>
+  <dgm:desc val=""/>
+  <dgm:catLst>
+    <dgm:cat type="accent1" pri="11200"/>
+  </dgm:catLst>
+  <dgm:styleLbl name="node0">
+    <dgm:fillClrLst meth="repeat">
+      <a:schemeClr val="accent1"/>
+    </dgm:fillClrLst>
+    <dgm:linClrLst meth="repeat">
+      <a:schemeClr val="lt1"/>
+    </dgm:linClrLst>
+    <dgm:effectClrLst/>
+    <dgm:txLinClrLst/>
+    <dgm:txFillClrLst/>
+    <dgm:txEffectClrLst/>
+  </dgm:styleLbl>
+  <dgm:styleLbl name="alignNode1">
+    <dgm:fillClrLst meth="repeat">
+      <a:schemeClr val="accent1"/>
+    </dgm:fillClrLst>
+    <dgm:linClrLst meth="repeat">
+      <a:schemeClr val="accent1"/>
+    </dgm:linClrLst>
+    <dgm:effectClrLst/>
+    <dgm:txLinClrLst/>
+    <dgm:txFillClrLst/>
+    <dgm:txEffectClrLst/>
+  </dgm:styleLbl>
+  <dgm:styleLbl name="node1">
+    <dgm:fillClrLst meth="repeat">
+      <a:schemeClr val="accent1"/>
+    </dgm:fillClrLst>
+    <dgm:linClrLst meth="repeat">
+      <a:schemeClr val="lt1"/>
+    </dgm:linClrLst>
+    <dgm:effectClrLst/>
+    <dgm:txLinClrLst/>
+    <dgm:txFillClrLst/>
+    <dgm:txEffectClrLst/>
+  </dgm:styleLbl>
+  <dgm:styleLbl name="lnNode1">
+    <dgm:fillClrLst meth="repeat">
+      <a:schemeClr val="accent1"/>
+    </dgm:fillClrLst>
+    <dgm:linClrLst meth="repeat">
+      <a:schemeClr val="lt1"/>
+    </dgm:linClrLst>
+    <dgm:effectClrLst/>
+    <dgm:txLinClrLst/>
+    <dgm:txFillClrLst/>
+    <dgm:txEffectClrLst/>
+  </dgm:styleLbl>
+  <dgm:styleLbl name="vennNode1">
+    <dgm:fillClrLst meth="repeat">
+      <a:schemeClr val="accent1">
+        <a:alpha val="50000"/>
+      </a:schemeClr>
+    </dgm:fillClrLst>
+    <dgm:linClrLst meth="repeat">
+      <a:schemeClr val="lt1"/>
+    </dgm:linClrLst>
+    <dgm:effectClrLst/>
+    <dgm:txLinClrLst/>
+    <dgm:txFillClrLst/>
+    <dgm:txEffectClrLst/>
+  </dgm:styleLbl>
+  <dgm:styleLbl name="node2">
+    <dgm:fillClrLst meth="repeat">
+      <a:schemeClr val="accent1"/>
+    </dgm:fillClrLst>
+    <dgm:linClrLst meth="repeat">
+      <a:schemeClr val="lt1"/>
+    </dgm:linClrLst>
+    <dgm:effectClrLst/>
+    <dgm:txLinClrLst/>
+    <dgm:txFillClrLst/>
+    <dgm:txEffectClrLst/>
+  </dgm:styleLbl>
+  <dgm:styleLbl name="node3">
+    <dgm:fillClrLst meth="repeat">
+      <a:schemeClr val="accent1"/>
+    </dgm:fillClrLst>
+    <dgm:linClrLst meth="repeat">
+      <a:schemeClr val="lt1"/>
+    </dgm:linClrLst>
+    <dgm:effectClrLst/>
+    <dgm:txLinClrLst/>
+    <dgm:txFillClrLst/>
+    <dgm:txEffectClrLst/>
+  </dgm:styleLbl>
+  <dgm:styleLbl name="node4">
+    <dgm:fillClrLst meth="repeat">
+      <a:schemeClr val="accent1"/>
+    </dgm:fillClrLst>
+    <dgm:linClrLst meth="repeat">
+      <a:schemeClr val="lt1"/>
+    </dgm:linClrLst>
+    <dgm:effectClrLst/>
+    <dgm:txLinClrLst/>
+    <dgm:txFillClrLst/>
+    <dgm:txEffectClrLst/>
+  </dgm:styleLbl>
+  <dgm:styleLbl name="fgImgPlace1">
+    <dgm:fillClrLst meth="repeat">
+      <a:schemeClr val="accent1">
+        <a:tint val="50000"/>
+      </a:schemeClr>
+    </dgm:fillClrLst>
+    <dgm:linClrLst meth="repeat">
+      <a:schemeClr val="lt1"/>
+    </dgm:linClrLst>
+    <dgm:effectClrLst/>
+    <dgm:txLinClrLst/>
+    <dgm:txFillClrLst meth="repeat">
+      <a:schemeClr val="lt1"/>
+    </dgm:txFillClrLst>
+    <dgm:txEffectClrLst/>
+  </dgm:styleLbl>
+  <dgm:styleLbl name="alignImgPlace1">
+    <dgm:fillClrLst meth="repeat">
+      <a:schemeClr val="accent1">
+        <a:tint val="50000"/>
+      </a:schemeClr>
+    </dgm:fillClrLst>
+    <dgm:linClrLst meth="repeat">
+      <a:schemeClr val="lt1"/>
+    </dgm:linClrLst>
+    <dgm:effectClrLst/>
+    <dgm:txLinClrLst/>
+    <dgm:txFillClrLst meth="repeat">
+      <a:schemeClr val="lt1"/>
+    </dgm:txFillClrLst>
+    <dgm:txEffectClrLst/>
+  </dgm:styleLbl>
+  <dgm:styleLbl name="bgImgPlace1">
+    <dgm:fillClrLst meth="repeat">
+      <a:schemeClr val="accent1">
+        <a:tint val="50000"/>
+      </a:schemeClr>
+    </dgm:fillClrLst>
+    <dgm:linClrLst meth="repeat">
+      <a:schemeClr val="lt1"/>
+    </dgm:linClrLst>
+    <dgm:effectClrLst/>
+    <dgm:txLinClrLst/>
+    <dgm:txFillClrLst meth="repeat">
+      <a:schemeClr val="lt1"/>
+    </dgm:txFillClrLst>
+    <dgm:txEffectClrLst/>
+  </dgm:styleLbl>
+  <dgm:styleLbl name="sibTrans2D1">
+    <dgm:fillClrLst meth="repeat">
+      <a:schemeClr val="accent1">
+        <a:tint val="60000"/>
+      </a:schemeClr>
+    </dgm:fillClrLst>
+    <dgm:linClrLst meth="repeat">
+      <a:schemeClr val="accent1">
+        <a:tint val="60000"/>
+      </a:schemeClr>
+    </dgm:linClrLst>
+    <dgm:effectClrLst/>
+    <dgm:txLinClrLst/>
+    <dgm:txFillClrLst/>
+    <dgm:txEffectClrLst/>
+  </dgm:styleLbl>
+  <dgm:styleLbl name="fgSibTrans2D1">
+    <dgm:fillClrLst meth="repeat">
+      <a:schemeClr val="accent1">
+        <a:tint val="60000"/>
+      </a:schemeClr>
+    </dgm:fillClrLst>
+    <dgm:linClrLst meth="repeat">
+      <a:schemeClr val="accent1">
+        <a:tint val="60000"/>
+      </a:schemeClr>
+    </dgm:linClrLst>
+    <dgm:effectClrLst/>
+    <dgm:txLinClrLst/>
+    <dgm:txFillClrLst/>
+    <dgm:txEffectClrLst/>
+  </dgm:styleLbl>
+  <dgm:styleLbl name="bgSibTrans2D1">
+    <dgm:fillClrLst meth="repeat">
+      <a:schemeClr val="accent1">
+        <a:tint val="60000"/>
+      </a:schemeClr>
+    </dgm:fillClrLst>
+    <dgm:linClrLst meth="repeat">
+      <a:schemeClr val="accent1">
+        <a:tint val="60000"/>
+      </a:schemeClr>
+    </dgm:linClrLst>
+    <dgm:effectClrLst/>
+    <dgm:txLinClrLst/>
+    <dgm:txFillClrLst/>
+    <dgm:txEffectClrLst/>
+  </dgm:styleLbl>
+  <dgm:styleLbl name="sibTrans1D1">
+    <dgm:fillClrLst meth="repeat">
+      <a:schemeClr val="accent1"/>
+    </dgm:fillClrLst>
+    <dgm:linClrLst meth="repeat">
+      <a:schemeClr val="accent1"/>
+    </dgm:linClrLst>
+    <dgm:effectClrLst/>
+    <dgm:txLinClrLst/>
+    <dgm:txFillClrLst meth="repeat">
+      <a:schemeClr val="tx1"/>
+    </dgm:txFillClrLst>
+    <dgm:txEffectClrLst/>
+  </dgm:styleLbl>
+  <dgm:styleLbl name="callout">
+    <dgm:fillClrLst meth="repeat">
+      <a:schemeClr val="accent1"/>
+    </dgm:fillClrLst>
+    <dgm:linClrLst meth="repeat">
+      <a:schemeClr val="accent1">
+        <a:tint val="50000"/>
+      </a:schemeClr>
+    </dgm:linClrLst>
+    <dgm:effectClrLst/>
+    <dgm:txLinClrLst/>
+    <dgm:txFillClrLst meth="repeat">
+      <a:schemeClr val="tx1"/>
+    </dgm:txFillClrLst>
+    <dgm:txEffectClrLst/>
+  </dgm:styleLbl>
+  <dgm:styleLbl name="asst0">
+    <dgm:fillClrLst meth="repeat">
+      <a:schemeClr val="accent1"/>
+    </dgm:fillClrLst>
+    <dgm:linClrLst meth="repeat">
+      <a:schemeClr val="lt1"/>
+    </dgm:linClrLst>
+    <dgm:effectClrLst/>
+    <dgm:txLinClrLst/>
+    <dgm:txFillClrLst/>
+    <dgm:txEffectClrLst/>
+  </dgm:styleLbl>
+  <dgm:styleLbl name="asst1">
+    <dgm:fillClrLst meth="repeat">
+      <a:schemeClr val="accent1"/>
+    </dgm:fillClrLst>
+    <dgm:linClrLst meth="repeat">
+      <a:schemeClr val="lt1"/>
+    </dgm:linClrLst>
+    <dgm:effectClrLst/>
+    <dgm:txLinClrLst/>
+    <dgm:txFillClrLst/>
+    <dgm:txEffectClrLst/>
+  </dgm:styleLbl>
+  <dgm:styleLbl name="asst2">
+    <dgm:fillClrLst meth="repeat">
+      <a:schemeClr val="accent1"/>
+    </dgm:fillClrLst>
+    <dgm:linClrLst meth="repeat">
+      <a:schemeClr val="lt1"/>
+    </dgm:linClrLst>
+    <dgm:effectClrLst/>
+    <dgm:txLinClrLst/>
+    <dgm:txFillClrLst/>
+    <dgm:txEffectClrLst/>
+  </dgm:styleLbl>
+  <dgm:styleLbl name="asst3">
+    <dgm:fillClrLst meth="repeat">
+      <a:schemeClr val="accent1"/>
+    </dgm:fillClrLst>
+    <dgm:linClrLst meth="repeat">
+      <a:schemeClr val="lt1"/>
+    </dgm:linClrLst>
+    <dgm:effectClrLst/>
+    <dgm:txLinClrLst/>
+    <dgm:txFillClrLst/>
+    <dgm:txEffectClrLst/>
+  </dgm:styleLbl>
+  <dgm:styleLbl name="asst4">
+    <dgm:fillClrLst meth="repeat">
+      <a:schemeClr val="accent1"/>
+    </dgm:fillClrLst>
+    <dgm:linClrLst meth="repeat">
+      <a:schemeClr val="lt1"/>
+    </dgm:linClrLst>
+    <dgm:effectClrLst/>
+    <dgm:txLinClrLst/>
+    <dgm:txFillClrLst/>
+    <dgm:txEffectClrLst/>
+  </dgm:styleLbl>
+  <dgm:styleLbl name="parChTrans2D1">
+    <dgm:fillClrLst meth="repeat">
+      <a:schemeClr val="accent1">
+        <a:tint val="60000"/>
+      </a:schemeClr>
+    </dgm:fillClrLst>
+    <dgm:linClrLst meth="repeat">
+      <a:schemeClr val="accent1">
+        <a:tint val="60000"/>
+      </a:schemeClr>
+    </dgm:linClrLst>
+    <dgm:effectClrLst/>
+    <dgm:txLinClrLst/>
+    <dgm:txFillClrLst meth="repeat">
+      <a:schemeClr val="lt1"/>
+    </dgm:txFillClrLst>
+    <dgm:txEffectClrLst/>
+  </dgm:styleLbl>
+  <dgm:styleLbl name="parChTrans2D2">
+    <dgm:fillClrLst meth="repeat">
+      <a:schemeClr val="accent1"/>
+    </dgm:fillClrLst>
+    <dgm:linClrLst meth="repeat">
+      <a:schemeClr val="accent1"/>
+    </dgm:linClrLst>
+    <dgm:effectClrLst/>
+    <dgm:txLinClrLst/>
+    <dgm:txFillClrLst meth="repeat">
+      <a:schemeClr val="lt1"/>
+    </dgm:txFillClrLst>
+    <dgm:txEffectClrLst/>
+  </dgm:styleLbl>
+  <dgm:styleLbl name="parChTrans2D3">
+    <dgm:fillClrLst meth="repeat">
+      <a:schemeClr val="accent1"/>
+    </dgm:fillClrLst>
+    <dgm:linClrLst meth="repeat">
+      <a:schemeClr val="accent1"/>
+    </dgm:linClrLst>
+    <dgm:effectClrLst/>
+    <dgm:txLinClrLst/>
+    <dgm:txFillClrLst meth="repeat">
+      <a:schemeClr val="lt1"/>
+    </dgm:txFillClrLst>
+    <dgm:txEffectClrLst/>
+  </dgm:styleLbl>
+  <dgm:styleLbl name="parChTrans2D4">
+    <dgm:fillClrLst meth="repeat">
+      <a:schemeClr val="accent1"/>
+    </dgm:fillClrLst>
+    <dgm:linClrLst meth="repeat">
+      <a:schemeClr val="accent1"/>
+    </dgm:linClrLst>
+    <dgm:effectClrLst/>
+    <dgm:txLinClrLst/>
+    <dgm:txFillClrLst meth="repeat">
+      <a:schemeClr val="lt1"/>
+    </dgm:txFillClrLst>
+    <dgm:txEffectClrLst/>
+  </dgm:styleLbl>
+  <dgm:styleLbl name="parChTrans1D1">
+    <dgm:fillClrLst meth="repeat">
+      <a:schemeClr val="accent1"/>
+    </dgm:fillClrLst>
+    <dgm:linClrLst meth="repeat">
+      <a:schemeClr val="accent1">
+        <a:shade val="60000"/>
+      </a:schemeClr>
+    </dgm:linClrLst>
+    <dgm:effectClrLst/>
+    <dgm:txLinClrLst/>
+    <dgm:txFillClrLst meth="repeat">
+      <a:schemeClr val="tx1"/>
+    </dgm:txFillClrLst>
+    <dgm:txEffectClrLst/>
+  </dgm:styleLbl>
+  <dgm:styleLbl name="parChTrans1D2">
+    <dgm:fillClrLst meth="repeat">
+      <a:schemeClr val="accent1"/>
+    </dgm:fillClrLst>
+    <dgm:linClrLst meth="repeat">
+      <a:schemeClr val="accent1">
+        <a:shade val="60000"/>
+      </a:schemeClr>
+    </dgm:linClrLst>
+    <dgm:effectClrLst/>
+    <dgm:txLinClrLst/>
+    <dgm:txFillClrLst meth="repeat">
+      <a:schemeClr val="tx1"/>
+    </dgm:txFillClrLst>
+    <dgm:txEffectClrLst/>
+  </dgm:styleLbl>
+  <dgm:styleLbl name="parChTrans1D3">
+    <dgm:fillClrLst meth="repeat">
+      <a:schemeClr val="accent1"/>
+    </dgm:fillClrLst>
+    <dgm:linClrLst meth="repeat">
+      <a:schemeClr val="accent1">
+        <a:shade val="80000"/>
+      </a:schemeClr>
+    </dgm:linClrLst>
+    <dgm:effectClrLst/>
+    <dgm:txLinClrLst/>
+    <dgm:txFillClrLst meth="repeat">
+      <a:schemeClr val="tx1"/>
+    </dgm:txFillClrLst>
+    <dgm:txEffectClrLst/>
+  </dgm:styleLbl>
+  <dgm:styleLbl name="parChTrans1D4">
+    <dgm:fillClrLst meth="repeat">
+      <a:schemeClr val="accent1"/>
+    </dgm:fillClrLst>
+    <dgm:linClrLst meth="repeat">
+      <a:schemeClr val="accent1">
+        <a:shade val="80000"/>
+      </a:schemeClr>
+    </dgm:linClrLst>
+    <dgm:effectClrLst/>
+    <dgm:txLinClrLst/>
+    <dgm:txFillClrLst meth="repeat">
+      <a:schemeClr val="tx1"/>
+    </dgm:txFillClrLst>
+    <dgm:txEffectClrLst/>
+  </dgm:styleLbl>
+  <dgm:styleLbl name="fgAcc1">
+    <dgm:fillClrLst meth="repeat">
+      <a:schemeClr val="lt1">
+        <a:alpha val="90000"/>
+      </a:schemeClr>
+    </dgm:fillClrLst>
+    <dgm:linClrLst meth="repeat">
+      <a:schemeClr val="accent1"/>
+    </dgm:linClrLst>
+    <dgm:effectClrLst/>
+    <dgm:txLinClrLst/>
+    <dgm:txFillClrLst meth="repeat">
+      <a:schemeClr val="dk1"/>
+    </dgm:txFillClrLst>
+    <dgm:txEffectClrLst/>
+  </dgm:styleLbl>
+  <dgm:styleLbl name="conFgAcc1">
+    <dgm:fillClrLst meth="repeat">
+      <a:schemeClr val="lt1">
+        <a:alpha val="90000"/>
+      </a:schemeClr>
+    </dgm:fillClrLst>
+    <dgm:linClrLst meth="repeat">
+      <a:schemeClr val="accent1"/>
+    </dgm:linClrLst>
+    <dgm:effectClrLst/>
+    <dgm:txLinClrLst/>
+    <dgm:txFillClrLst meth="repeat">
+      <a:schemeClr val="dk1"/>
+    </dgm:txFillClrLst>
+    <dgm:txEffectClrLst/>
+  </dgm:styleLbl>
+  <dgm:styleLbl name="alignAcc1">
+    <dgm:fillClrLst meth="repeat">
+      <a:schemeClr val="lt1">
+        <a:alpha val="90000"/>
+      </a:schemeClr>
+    </dgm:fillClrLst>
+    <dgm:linClrLst meth="repeat">
+      <a:schemeClr val="accent1"/>
+    </dgm:linClrLst>
+    <dgm:effectClrLst/>
+    <dgm:txLinClrLst/>
+    <dgm:txFillClrLst meth="repeat">
+      <a:schemeClr val="dk1"/>
+    </dgm:txFillClrLst>
+    <dgm:txEffectClrLst/>
+  </dgm:styleLbl>
+  <dgm:styleLbl name="trAlignAcc1">
+    <dgm:fillClrLst meth="repeat">
+      <a:schemeClr val="lt1">
+        <a:alpha val="40000"/>
+      </a:schemeClr>
+    </dgm:fillClrLst>
+    <dgm:linClrLst meth="repeat">
+      <a:schemeClr val="accent1"/>
+    </dgm:linClrLst>
+    <dgm:effectClrLst/>
+    <dgm:txLinClrLst/>
+    <dgm:txFillClrLst meth="repeat">
+      <a:schemeClr val="dk1"/>
+    </dgm:txFillClrLst>
+    <dgm:txEffectClrLst/>
+  </dgm:styleLbl>
+  <dgm:styleLbl name="bgAcc1">
+    <dgm:fillClrLst meth="repeat">
+      <a:schemeClr val="lt1">
+        <a:alpha val="90000"/>
+      </a:schemeClr>
+    </dgm:fillClrLst>
+    <dgm:linClrLst meth="repeat">
+      <a:schemeClr val="accent1"/>
+    </dgm:linClrLst>
+    <dgm:effectClrLst/>
+    <dgm:txLinClrLst/>
+    <dgm:txFillClrLst meth="repeat">
+      <a:schemeClr val="dk1"/>
+    </dgm:txFillClrLst>
+    <dgm:txEffectClrLst/>
+  </dgm:styleLbl>
+  <dgm:styleLbl name="solidFgAcc1">
+    <dgm:fillClrLst meth="repeat">
+      <a:schemeClr val="lt1"/>
+    </dgm:fillClrLst>
+    <dgm:linClrLst meth="repeat">
+      <a:schemeClr val="accent1"/>
+    </dgm:linClrLst>
+    <dgm:effectClrLst/>
+    <dgm:txLinClrLst/>
+    <dgm:txFillClrLst meth="repeat">
+      <a:schemeClr val="dk1"/>
+    </dgm:txFillClrLst>
+    <dgm:txEffectClrLst/>
+  </dgm:styleLbl>
+  <dgm:styleLbl name="solidAlignAcc1">
+    <dgm:fillClrLst meth="repeat">
+      <a:schemeClr val="lt1"/>
+    </dgm:fillClrLst>
+    <dgm:linClrLst meth="repeat">
+      <a:schemeClr val="accent1"/>
+    </dgm:linClrLst>
+    <dgm:effectClrLst/>
+    <dgm:txLinClrLst/>
+    <dgm:txFillClrLst meth="repeat">
+      <a:schemeClr val="dk1"/>
+    </dgm:txFillClrLst>
+    <dgm:txEffectClrLst/>
+  </dgm:styleLbl>
+  <dgm:styleLbl name="solidBgAcc1">
+    <dgm:fillClrLst meth="repeat">
+      <a:schemeClr val="lt1"/>
+    </dgm:fillClrLst>
+    <dgm:linClrLst meth="repeat">
+      <a:schemeClr val="accent1"/>
+    </dgm:linClrLst>
+    <dgm:effectClrLst/>
+    <dgm:txLinClrLst/>
+    <dgm:txFillClrLst meth="repeat">
+      <a:schemeClr val="dk1"/>
+    </dgm:txFillClrLst>
+    <dgm:txEffectClrLst/>
+  </dgm:styleLbl>
+  <dgm:styleLbl name="fgAccFollowNode1">
+    <dgm:fillClrLst meth="repeat">
+      <a:schemeClr val="accent1">
+        <a:alpha val="90000"/>
+        <a:tint val="40000"/>
+      </a:schemeClr>
+    </dgm:fillClrLst>
+    <dgm:linClrLst meth="repeat">
+      <a:schemeClr val="accent1">
+        <a:alpha val="90000"/>
+        <a:tint val="40000"/>
+      </a:schemeClr>
+    </dgm:linClrLst>
+    <dgm:effectClrLst/>
+    <dgm:txLinClrLst/>
+    <dgm:txFillClrLst meth="repeat">
+      <a:schemeClr val="dk1"/>
+    </dgm:txFillClrLst>
+    <dgm:txEffectClrLst/>
+  </dgm:styleLbl>
+  <dgm:styleLbl name="alignAccFollowNode1">
+    <dgm:fillClrLst meth="repeat">
+      <a:schemeClr val="accent1">
+        <a:alpha val="90000"/>
+        <a:tint val="40000"/>
+      </a:schemeClr>
+    </dgm:fillClrLst>
+    <dgm:linClrLst meth="repeat">
+      <a:schemeClr val="accent1">
+        <a:alpha val="90000"/>
+        <a:tint val="40000"/>
+      </a:schemeClr>
+    </dgm:linClrLst>
+    <dgm:effectClrLst/>
+    <dgm:txLinClrLst/>
+    <dgm:txFillClrLst meth="repeat">
+      <a:schemeClr val="dk1"/>
+    </dgm:txFillClrLst>
+    <dgm:txEffectClrLst/>
+  </dgm:styleLbl>
+  <dgm:styleLbl name="bgAccFollowNode1">
+    <dgm:fillClrLst meth="repeat">
+      <a:schemeClr val="accent1">
+        <a:alpha val="90000"/>
+        <a:tint val="40000"/>
+      </a:schemeClr>
+    </dgm:fillClrLst>
+    <dgm:linClrLst meth="repeat">
+      <a:schemeClr val="accent1">
+        <a:alpha val="90000"/>
+        <a:tint val="40000"/>
+      </a:schemeClr>
+    </dgm:linClrLst>
+    <dgm:effectClrLst/>
+    <dgm:txLinClrLst/>
+    <dgm:txFillClrLst meth="repeat">
+      <a:schemeClr val="dk1"/>
+    </dgm:txFillClrLst>
+    <dgm:txEffectClrLst/>
+  </dgm:styleLbl>
+  <dgm:styleLbl name="fgAcc0">
+    <dgm:fillClrLst meth="repeat">
+      <a:schemeClr val="lt1">
+        <a:alpha val="90000"/>
+      </a:schemeClr>
+    </dgm:fillClrLst>
+    <dgm:linClrLst meth="repeat">
+      <a:schemeClr val="accent1"/>
+    </dgm:linClrLst>
+    <dgm:effectClrLst/>
+    <dgm:txLinClrLst/>
+    <dgm:txFillClrLst meth="repeat">
+      <a:schemeClr val="dk1"/>
+    </dgm:txFillClrLst>
+    <dgm:txEffectClrLst/>
+  </dgm:styleLbl>
+  <dgm:styleLbl name="fgAcc2">
+    <dgm:fillClrLst meth="repeat">
+      <a:schemeClr val="lt1">
+        <a:alpha val="90000"/>
+      </a:schemeClr>
+    </dgm:fillClrLst>
+    <dgm:linClrLst meth="repeat">
+      <a:schemeClr val="accent1"/>
+    </dgm:linClrLst>
+    <dgm:effectClrLst/>
+    <dgm:txLinClrLst/>
+    <dgm:txFillClrLst meth="repeat">
+      <a:schemeClr val="dk1"/>
+    </dgm:txFillClrLst>
+    <dgm:txEffectClrLst/>
+  </dgm:styleLbl>
+  <dgm:styleLbl name="fgAcc3">
+    <dgm:fillClrLst meth="repeat">
+      <a:schemeClr val="lt1">
+        <a:alpha val="90000"/>
+      </a:schemeClr>
+    </dgm:fillClrLst>
+    <dgm:linClrLst meth="repeat">
+      <a:schemeClr val="accent1"/>
+    </dgm:linClrLst>
+    <dgm:effectClrLst/>
+    <dgm:txLinClrLst/>
+    <dgm:txFillClrLst meth="repeat">
+      <a:schemeClr val="dk1"/>
+    </dgm:txFillClrLst>
+    <dgm:txEffectClrLst/>
+  </dgm:styleLbl>
+  <dgm:styleLbl name="fgAcc4">
+    <dgm:fillClrLst meth="repeat">
+      <a:schemeClr val="lt1">
+        <a:alpha val="90000"/>
+      </a:schemeClr>
+    </dgm:fillClrLst>
+    <dgm:linClrLst meth="repeat">
+      <a:schemeClr val="accent1"/>
+    </dgm:linClrLst>
+    <dgm:effectClrLst/>
+    <dgm:txLinClrLst/>
+    <dgm:txFillClrLst meth="repeat">
+      <a:schemeClr val="dk1"/>
+    </dgm:txFillClrLst>
+    <dgm:txEffectClrLst/>
+  </dgm:styleLbl>
+  <dgm:styleLbl name="bgShp">
+    <dgm:fillClrLst meth="repeat">
+      <a:schemeClr val="accent1">
+        <a:tint val="40000"/>
+      </a:schemeClr>
+    </dgm:fillClrLst>
+    <dgm:linClrLst meth="repeat">
+      <a:schemeClr val="accent1"/>
+    </dgm:linClrLst>
+    <dgm:effectClrLst/>
+    <dgm:txLinClrLst/>
+    <dgm:txFillClrLst meth="repeat">
+      <a:schemeClr val="dk1"/>
+    </dgm:txFillClrLst>
+    <dgm:txEffectClrLst/>
+  </dgm:styleLbl>
+  <dgm:styleLbl name="dkBgShp">
+    <dgm:fillClrLst meth="repeat">
+      <a:schemeClr val="accent1">
+        <a:shade val="80000"/>
+      </a:schemeClr>
+    </dgm:fillClrLst>
+    <dgm:linClrLst meth="repeat">
+      <a:schemeClr val="accent1"/>
+    </dgm:linClrLst>
+    <dgm:effectClrLst/>
+    <dgm:txLinClrLst/>
+    <dgm:txFillClrLst meth="repeat">
+      <a:schemeClr val="lt1"/>
+    </dgm:txFillClrLst>
+    <dgm:txEffectClrLst/>
+  </dgm:styleLbl>
+  <dgm:styleLbl name="trBgShp">
+    <dgm:fillClrLst meth="repeat">
+      <a:schemeClr val="accent1">
+        <a:tint val="50000"/>
+        <a:alpha val="40000"/>
+      </a:schemeClr>
+    </dgm:fillClrLst>
+    <dgm:linClrLst meth="repeat">
+      <a:schemeClr val="accent1"/>
+    </dgm:linClrLst>
+    <dgm:effectClrLst/>
+    <dgm:txLinClrLst/>
+    <dgm:txFillClrLst meth="repeat">
+      <a:schemeClr val="lt1"/>
+    </dgm:txFillClrLst>
+    <dgm:txEffectClrLst/>
+  </dgm:styleLbl>
+  <dgm:styleLbl name="fgShp">
+    <dgm:fillClrLst meth="repeat">
+      <a:schemeClr val="accent1">
+        <a:tint val="60000"/>
+      </a:schemeClr>
+    </dgm:fillClrLst>
+    <dgm:linClrLst meth="repeat">
+      <a:schemeClr val="lt1"/>
+    </dgm:linClrLst>
+    <dgm:effectClrLst/>
+    <dgm:txLinClrLst/>
+    <dgm:txFillClrLst meth="repeat">
+      <a:schemeClr val="dk1"/>
+    </dgm:txFillClrLst>
+    <dgm:txEffectClrLst/>
+  </dgm:styleLbl>
+  <dgm:styleLbl name="revTx">
+    <dgm:fillClrLst meth="repeat">
+      <a:schemeClr val="lt1">
+        <a:alpha val="0"/>
+      </a:schemeClr>
+    </dgm:fillClrLst>
+    <dgm:linClrLst meth="repeat">
+      <a:schemeClr val="dk1">
+        <a:alpha val="0"/>
+      </a:schemeClr>
+    </dgm:linClrLst>
+    <dgm:effectClrLst/>
+    <dgm:txLinClrLst/>
+    <dgm:txFillClrLst meth="repeat">
+      <a:schemeClr val="tx1"/>
+    </dgm:txFillClrLst>
+    <dgm:txEffectClrLst/>
+  </dgm:styleLbl>
+</dgm:colorsDef>
+</file>
+
+<file path=ppt/diagrams/colors4.xml><?xml version="1.0" encoding="utf-8"?>
 <dgm:colorsDef xmlns:dgm="http://schemas.openxmlformats.org/drawingml/2006/diagram" xmlns:a="http://schemas.openxmlformats.org/drawingml/2006/main" uniqueId="urn:microsoft.com/office/officeart/2005/8/colors/accent1_2">
   <dgm:title val=""/>
   <dgm:desc val=""/>
@@ -3369,6 +4118,191 @@
         </a:p>
       </dgm:t>
     </dgm:pt>
+    <dgm:pt modelId="{BB0C5181-F609-4193-A0B4-CB96045EFC4B}">
+      <dgm:prSet phldrT="[Tekst]" phldr="0"/>
+      <dgm:spPr/>
+      <dgm:t>
+        <a:bodyPr/>
+        <a:lstStyle/>
+        <a:p>
+          <a:r>
+            <a:rPr lang="en-US" dirty="0"/>
+            <a:t>Order buckets by pigment</a:t>
+          </a:r>
+          <a:endParaRPr lang="nl-BE" dirty="0"/>
+        </a:p>
+      </dgm:t>
+    </dgm:pt>
+    <dgm:pt modelId="{A48913C2-398B-4CEE-993A-F1C4702A3FD3}" type="parTrans" cxnId="{E1A7673E-A6B3-4F4A-9771-2464AC19346D}">
+      <dgm:prSet/>
+      <dgm:spPr/>
+      <dgm:t>
+        <a:bodyPr/>
+        <a:lstStyle/>
+        <a:p>
+          <a:endParaRPr lang="nl-BE"/>
+        </a:p>
+      </dgm:t>
+    </dgm:pt>
+    <dgm:pt modelId="{659F72C8-8693-45BB-880A-F1EFBFAE9226}" type="sibTrans" cxnId="{E1A7673E-A6B3-4F4A-9771-2464AC19346D}">
+      <dgm:prSet/>
+      <dgm:spPr/>
+      <dgm:t>
+        <a:bodyPr/>
+        <a:lstStyle/>
+        <a:p>
+          <a:endParaRPr lang="nl-BE"/>
+        </a:p>
+      </dgm:t>
+    </dgm:pt>
+    <dgm:pt modelId="{5175613F-6E27-4B35-9CE7-43C8CE437575}">
+      <dgm:prSet phldrT="[Tekst]" phldr="0"/>
+      <dgm:spPr/>
+      <dgm:t>
+        <a:bodyPr/>
+        <a:lstStyle/>
+        <a:p>
+          <a:r>
+            <a:rPr lang="en-US" dirty="0"/>
+            <a:t>Partition in Buckets</a:t>
+          </a:r>
+          <a:endParaRPr lang="nl-BE" dirty="0"/>
+        </a:p>
+      </dgm:t>
+    </dgm:pt>
+    <dgm:pt modelId="{73222318-DE57-4683-A33C-597AA0451C9D}" type="parTrans" cxnId="{F6E194C5-AE64-4DF3-8828-880AF2A3E81E}">
+      <dgm:prSet/>
+      <dgm:spPr/>
+      <dgm:t>
+        <a:bodyPr/>
+        <a:lstStyle/>
+        <a:p>
+          <a:endParaRPr lang="nl-BE"/>
+        </a:p>
+      </dgm:t>
+    </dgm:pt>
+    <dgm:pt modelId="{B67DD0B7-B75A-401E-9EB9-763039FA93C6}" type="sibTrans" cxnId="{F6E194C5-AE64-4DF3-8828-880AF2A3E81E}">
+      <dgm:prSet/>
+      <dgm:spPr/>
+      <dgm:t>
+        <a:bodyPr/>
+        <a:lstStyle/>
+        <a:p>
+          <a:endParaRPr lang="nl-BE"/>
+        </a:p>
+      </dgm:t>
+    </dgm:pt>
+    <dgm:pt modelId="{5CF902B4-BEAD-40BD-94A2-28B436A03C85}" type="pres">
+      <dgm:prSet presAssocID="{9E85A773-D9BF-4D40-9E6A-4BF4EFDB69D2}" presName="Name0" presStyleCnt="0">
+        <dgm:presLayoutVars>
+          <dgm:dir/>
+          <dgm:animLvl val="lvl"/>
+          <dgm:resizeHandles val="exact"/>
+        </dgm:presLayoutVars>
+      </dgm:prSet>
+      <dgm:spPr/>
+    </dgm:pt>
+    <dgm:pt modelId="{BDCD547A-D046-4ACB-9D02-6F812DE52928}" type="pres">
+      <dgm:prSet presAssocID="{5175613F-6E27-4B35-9CE7-43C8CE437575}" presName="composite" presStyleCnt="0"/>
+      <dgm:spPr/>
+    </dgm:pt>
+    <dgm:pt modelId="{18A4206D-1D1C-4942-90B5-9298047B7813}" type="pres">
+      <dgm:prSet presAssocID="{5175613F-6E27-4B35-9CE7-43C8CE437575}" presName="parTx" presStyleLbl="alignNode1" presStyleIdx="0" presStyleCnt="2">
+        <dgm:presLayoutVars>
+          <dgm:chMax val="0"/>
+          <dgm:chPref val="0"/>
+        </dgm:presLayoutVars>
+      </dgm:prSet>
+      <dgm:spPr/>
+    </dgm:pt>
+    <dgm:pt modelId="{D61F6978-7931-48EE-91ED-C88DEA760C15}" type="pres">
+      <dgm:prSet presAssocID="{5175613F-6E27-4B35-9CE7-43C8CE437575}" presName="bgOutline" presStyleLbl="fgAcc1" presStyleIdx="0" presStyleCnt="2">
+        <dgm:presLayoutVars>
+          <dgm:bulletEnabled/>
+        </dgm:presLayoutVars>
+      </dgm:prSet>
+      <dgm:spPr>
+        <a:blipFill rotWithShape="0">
+          <a:blip xmlns:r="http://schemas.openxmlformats.org/officeDocument/2006/relationships" r:embed="rId1"/>
+          <a:srcRect/>
+          <a:stretch>
+            <a:fillRect l="-1000" r="-1000"/>
+          </a:stretch>
+        </a:blipFill>
+      </dgm:spPr>
+    </dgm:pt>
+    <dgm:pt modelId="{3C06A50C-1587-436A-8F91-29B640711298}" type="pres">
+      <dgm:prSet presAssocID="{B67DD0B7-B75A-401E-9EB9-763039FA93C6}" presName="space" presStyleCnt="0"/>
+      <dgm:spPr/>
+    </dgm:pt>
+    <dgm:pt modelId="{612940FE-7CA4-461E-BBBE-93829F8E9814}" type="pres">
+      <dgm:prSet presAssocID="{BB0C5181-F609-4193-A0B4-CB96045EFC4B}" presName="composite" presStyleCnt="0"/>
+      <dgm:spPr/>
+    </dgm:pt>
+    <dgm:pt modelId="{98832B47-8879-47C5-BE09-12E11B47A3F0}" type="pres">
+      <dgm:prSet presAssocID="{BB0C5181-F609-4193-A0B4-CB96045EFC4B}" presName="parTx" presStyleLbl="alignNode1" presStyleIdx="1" presStyleCnt="2">
+        <dgm:presLayoutVars>
+          <dgm:chMax val="0"/>
+          <dgm:chPref val="0"/>
+        </dgm:presLayoutVars>
+      </dgm:prSet>
+      <dgm:spPr/>
+    </dgm:pt>
+    <dgm:pt modelId="{EF38416B-AF94-4F99-A99D-18CDB11FC8B5}" type="pres">
+      <dgm:prSet presAssocID="{BB0C5181-F609-4193-A0B4-CB96045EFC4B}" presName="bgOutline" presStyleLbl="fgAcc1" presStyleIdx="1" presStyleCnt="2">
+        <dgm:presLayoutVars>
+          <dgm:bulletEnabled/>
+        </dgm:presLayoutVars>
+      </dgm:prSet>
+      <dgm:spPr>
+        <a:blipFill rotWithShape="0">
+          <a:blip xmlns:r="http://schemas.openxmlformats.org/officeDocument/2006/relationships" r:embed="rId2"/>
+          <a:srcRect/>
+          <a:stretch>
+            <a:fillRect t="-13000" b="-13000"/>
+          </a:stretch>
+        </a:blipFill>
+      </dgm:spPr>
+    </dgm:pt>
+  </dgm:ptLst>
+  <dgm:cxnLst>
+    <dgm:cxn modelId="{E1A7673E-A6B3-4F4A-9771-2464AC19346D}" srcId="{9E85A773-D9BF-4D40-9E6A-4BF4EFDB69D2}" destId="{BB0C5181-F609-4193-A0B4-CB96045EFC4B}" srcOrd="1" destOrd="0" parTransId="{A48913C2-398B-4CEE-993A-F1C4702A3FD3}" sibTransId="{659F72C8-8693-45BB-880A-F1EFBFAE9226}"/>
+    <dgm:cxn modelId="{8AFAD287-2F4B-4DF4-8295-A5E8ED1A8E41}" type="presOf" srcId="{BB0C5181-F609-4193-A0B4-CB96045EFC4B}" destId="{98832B47-8879-47C5-BE09-12E11B47A3F0}" srcOrd="0" destOrd="0" presId="urn:microsoft.com/office/officeart/2024/layout/HorizontalActionList"/>
+    <dgm:cxn modelId="{74F3EBB4-BE09-4FAD-AA09-EADA69846853}" type="presOf" srcId="{9E85A773-D9BF-4D40-9E6A-4BF4EFDB69D2}" destId="{5CF902B4-BEAD-40BD-94A2-28B436A03C85}" srcOrd="0" destOrd="0" presId="urn:microsoft.com/office/officeart/2024/layout/HorizontalActionList"/>
+    <dgm:cxn modelId="{F6E194C5-AE64-4DF3-8828-880AF2A3E81E}" srcId="{9E85A773-D9BF-4D40-9E6A-4BF4EFDB69D2}" destId="{5175613F-6E27-4B35-9CE7-43C8CE437575}" srcOrd="0" destOrd="0" parTransId="{73222318-DE57-4683-A33C-597AA0451C9D}" sibTransId="{B67DD0B7-B75A-401E-9EB9-763039FA93C6}"/>
+    <dgm:cxn modelId="{503E76FF-189C-4DA0-9AAF-F31743E5012A}" type="presOf" srcId="{5175613F-6E27-4B35-9CE7-43C8CE437575}" destId="{18A4206D-1D1C-4942-90B5-9298047B7813}" srcOrd="0" destOrd="0" presId="urn:microsoft.com/office/officeart/2024/layout/HorizontalActionList"/>
+    <dgm:cxn modelId="{C878B33D-0DB6-48D6-9F61-AB42CC4DE330}" type="presParOf" srcId="{5CF902B4-BEAD-40BD-94A2-28B436A03C85}" destId="{BDCD547A-D046-4ACB-9D02-6F812DE52928}" srcOrd="0" destOrd="0" presId="urn:microsoft.com/office/officeart/2024/layout/HorizontalActionList"/>
+    <dgm:cxn modelId="{F06C2888-1C0B-4FF9-9327-AFC8D05C66A0}" type="presParOf" srcId="{BDCD547A-D046-4ACB-9D02-6F812DE52928}" destId="{18A4206D-1D1C-4942-90B5-9298047B7813}" srcOrd="0" destOrd="0" presId="urn:microsoft.com/office/officeart/2024/layout/HorizontalActionList"/>
+    <dgm:cxn modelId="{0038C116-3F1E-4B09-9EAC-355F944DE18B}" type="presParOf" srcId="{BDCD547A-D046-4ACB-9D02-6F812DE52928}" destId="{D61F6978-7931-48EE-91ED-C88DEA760C15}" srcOrd="1" destOrd="0" presId="urn:microsoft.com/office/officeart/2024/layout/HorizontalActionList"/>
+    <dgm:cxn modelId="{66BA9DC0-7EEA-47A7-95B4-0F5BAEE14C64}" type="presParOf" srcId="{5CF902B4-BEAD-40BD-94A2-28B436A03C85}" destId="{3C06A50C-1587-436A-8F91-29B640711298}" srcOrd="1" destOrd="0" presId="urn:microsoft.com/office/officeart/2024/layout/HorizontalActionList"/>
+    <dgm:cxn modelId="{286A63F1-FF35-418D-93BA-A45E1A12DD2A}" type="presParOf" srcId="{5CF902B4-BEAD-40BD-94A2-28B436A03C85}" destId="{612940FE-7CA4-461E-BBBE-93829F8E9814}" srcOrd="2" destOrd="0" presId="urn:microsoft.com/office/officeart/2024/layout/HorizontalActionList"/>
+    <dgm:cxn modelId="{7C57CFDF-9700-4270-9734-AF012A495208}" type="presParOf" srcId="{612940FE-7CA4-461E-BBBE-93829F8E9814}" destId="{98832B47-8879-47C5-BE09-12E11B47A3F0}" srcOrd="0" destOrd="0" presId="urn:microsoft.com/office/officeart/2024/layout/HorizontalActionList"/>
+    <dgm:cxn modelId="{53189C16-2AE9-4F06-8C08-36070BF88482}" type="presParOf" srcId="{612940FE-7CA4-461E-BBBE-93829F8E9814}" destId="{EF38416B-AF94-4F99-A99D-18CDB11FC8B5}" srcOrd="1" destOrd="0" presId="urn:microsoft.com/office/officeart/2024/layout/HorizontalActionList"/>
+  </dgm:cxnLst>
+  <dgm:bg/>
+  <dgm:whole/>
+  <dgm:extLst>
+    <a:ext uri="http://schemas.microsoft.com/office/drawing/2008/diagram">
+      <dsp:dataModelExt xmlns:dsp="http://schemas.microsoft.com/office/drawing/2008/diagram" relId="rId6" minVer="http://schemas.openxmlformats.org/drawingml/2006/diagram"/>
+    </a:ext>
+  </dgm:extLst>
+</dgm:dataModel>
+</file>
+
+<file path=ppt/diagrams/data5.xml><?xml version="1.0" encoding="utf-8"?>
+<dgm:dataModel xmlns:dgm="http://schemas.openxmlformats.org/drawingml/2006/diagram" xmlns:a="http://schemas.openxmlformats.org/drawingml/2006/main">
+  <dgm:ptLst>
+    <dgm:pt modelId="{9E85A773-D9BF-4D40-9E6A-4BF4EFDB69D2}" type="doc">
+      <dgm:prSet loTypeId="urn:microsoft.com/office/officeart/2024/layout/HorizontalActionList" loCatId="list" qsTypeId="urn:microsoft.com/office/officeart/2005/8/quickstyle/simple1" qsCatId="simple" csTypeId="urn:microsoft.com/office/officeart/2005/8/colors/accent1_2" csCatId="accent1" phldr="1"/>
+      <dgm:spPr/>
+      <dgm:t>
+        <a:bodyPr/>
+        <a:lstStyle/>
+        <a:p>
+          <a:endParaRPr lang="nl-BE"/>
+        </a:p>
+      </dgm:t>
+    </dgm:pt>
     <dgm:pt modelId="{D897B666-ABBD-4E93-AF3A-510746A7F42F}">
       <dgm:prSet phldrT="[Tekst]" phldr="0" custT="1"/>
       <dgm:spPr/>
@@ -3378,7 +4312,7 @@
         <a:p>
           <a:r>
             <a:rPr lang="en-US" sz="1600" dirty="0"/>
-            <a:t>Render segments: far to near</a:t>
+            <a:t>Render strokes per segment</a:t>
           </a:r>
           <a:endParaRPr lang="nl-BE" sz="1600" dirty="0"/>
         </a:p>
@@ -3440,7 +4374,7 @@
           <a:blip xmlns:r="http://schemas.openxmlformats.org/officeDocument/2006/relationships" r:embed="rId1"/>
           <a:srcRect/>
           <a:stretch>
-            <a:fillRect l="-6000" r="-6000"/>
+            <a:fillRect l="-8000" r="-8000"/>
           </a:stretch>
         </a:blipFill>
       </dgm:spPr>
@@ -4401,6 +5335,282 @@
       <dsp:cNvGrpSpPr/>
     </dsp:nvGrpSpPr>
     <dsp:grpSpPr/>
+    <dsp:sp modelId="{D61F6978-7931-48EE-91ED-C88DEA760C15}">
+      <dsp:nvSpPr>
+        <dsp:cNvPr id="0" name=""/>
+        <dsp:cNvSpPr/>
+      </dsp:nvSpPr>
+      <dsp:spPr>
+        <a:xfrm rot="10800000">
+          <a:off x="2750" y="1605275"/>
+          <a:ext cx="3575280" cy="2455873"/>
+        </a:xfrm>
+        <a:prstGeom prst="round2SameRect">
+          <a:avLst>
+            <a:gd name="adj1" fmla="val 15000"/>
+            <a:gd name="adj2" fmla="val 0"/>
+          </a:avLst>
+        </a:prstGeom>
+        <a:blipFill rotWithShape="0">
+          <a:blip xmlns:r="http://schemas.openxmlformats.org/officeDocument/2006/relationships" r:embed="rId1"/>
+          <a:srcRect/>
+          <a:stretch>
+            <a:fillRect l="-1000" r="-1000"/>
+          </a:stretch>
+        </a:blipFill>
+        <a:ln w="19050" cap="flat" cmpd="sng" algn="ctr">
+          <a:solidFill>
+            <a:schemeClr val="accent1">
+              <a:hueOff val="0"/>
+              <a:satOff val="0"/>
+              <a:lumOff val="0"/>
+              <a:alphaOff val="0"/>
+            </a:schemeClr>
+          </a:solidFill>
+          <a:prstDash val="solid"/>
+          <a:miter lim="800000"/>
+        </a:ln>
+        <a:effectLst/>
+      </dsp:spPr>
+      <dsp:style>
+        <a:lnRef idx="2">
+          <a:scrgbClr r="0" g="0" b="0"/>
+        </a:lnRef>
+        <a:fillRef idx="1">
+          <a:scrgbClr r="0" g="0" b="0"/>
+        </a:fillRef>
+        <a:effectRef idx="0">
+          <a:scrgbClr r="0" g="0" b="0"/>
+        </a:effectRef>
+        <a:fontRef idx="minor"/>
+      </dsp:style>
+    </dsp:sp>
+    <dsp:sp modelId="{18A4206D-1D1C-4942-90B5-9298047B7813}">
+      <dsp:nvSpPr>
+        <dsp:cNvPr id="0" name=""/>
+        <dsp:cNvSpPr/>
+      </dsp:nvSpPr>
+      <dsp:spPr>
+        <a:xfrm>
+          <a:off x="2750" y="564869"/>
+          <a:ext cx="3575280" cy="1072584"/>
+        </a:xfrm>
+        <a:prstGeom prst="round2SameRect">
+          <a:avLst>
+            <a:gd name="adj1" fmla="val 45000"/>
+            <a:gd name="adj2" fmla="val 0"/>
+          </a:avLst>
+        </a:prstGeom>
+        <a:solidFill>
+          <a:schemeClr val="accent1">
+            <a:hueOff val="0"/>
+            <a:satOff val="0"/>
+            <a:lumOff val="0"/>
+            <a:alphaOff val="0"/>
+          </a:schemeClr>
+        </a:solidFill>
+        <a:ln w="19050" cap="flat" cmpd="sng" algn="ctr">
+          <a:solidFill>
+            <a:schemeClr val="accent1">
+              <a:hueOff val="0"/>
+              <a:satOff val="0"/>
+              <a:lumOff val="0"/>
+              <a:alphaOff val="0"/>
+            </a:schemeClr>
+          </a:solidFill>
+          <a:prstDash val="solid"/>
+          <a:miter lim="800000"/>
+        </a:ln>
+        <a:effectLst/>
+      </dsp:spPr>
+      <dsp:style>
+        <a:lnRef idx="2">
+          <a:scrgbClr r="0" g="0" b="0"/>
+        </a:lnRef>
+        <a:fillRef idx="1">
+          <a:scrgbClr r="0" g="0" b="0"/>
+        </a:fillRef>
+        <a:effectRef idx="0">
+          <a:scrgbClr r="0" g="0" b="0"/>
+        </a:effectRef>
+        <a:fontRef idx="minor">
+          <a:schemeClr val="lt1"/>
+        </a:fontRef>
+      </dsp:style>
+      <dsp:txBody>
+        <a:bodyPr spcFirstLastPara="0" vert="horz" wrap="square" lIns="282527" tIns="282527" rIns="282527" bIns="282527" numCol="1" spcCol="1270" anchor="ctr" anchorCtr="0">
+          <a:noAutofit/>
+        </a:bodyPr>
+        <a:lstStyle/>
+        <a:p>
+          <a:pPr marL="0" lvl="0" indent="0" algn="l" defTabSz="844550">
+            <a:lnSpc>
+              <a:spcPct val="90000"/>
+            </a:lnSpc>
+            <a:spcBef>
+              <a:spcPct val="0"/>
+            </a:spcBef>
+            <a:spcAft>
+              <a:spcPct val="35000"/>
+            </a:spcAft>
+            <a:buNone/>
+          </a:pPr>
+          <a:r>
+            <a:rPr lang="en-US" sz="1900" kern="1200" dirty="0"/>
+            <a:t>Partition in Buckets</a:t>
+          </a:r>
+          <a:endParaRPr lang="nl-BE" sz="1900" kern="1200" dirty="0"/>
+        </a:p>
+      </dsp:txBody>
+      <dsp:txXfrm>
+        <a:off x="144117" y="706236"/>
+        <a:ext cx="3292546" cy="931217"/>
+      </dsp:txXfrm>
+    </dsp:sp>
+    <dsp:sp modelId="{EF38416B-AF94-4F99-A99D-18CDB11FC8B5}">
+      <dsp:nvSpPr>
+        <dsp:cNvPr id="0" name=""/>
+        <dsp:cNvSpPr/>
+      </dsp:nvSpPr>
+      <dsp:spPr>
+        <a:xfrm rot="10800000">
+          <a:off x="3686031" y="1605275"/>
+          <a:ext cx="3575280" cy="2455873"/>
+        </a:xfrm>
+        <a:prstGeom prst="round2SameRect">
+          <a:avLst>
+            <a:gd name="adj1" fmla="val 15000"/>
+            <a:gd name="adj2" fmla="val 0"/>
+          </a:avLst>
+        </a:prstGeom>
+        <a:blipFill rotWithShape="0">
+          <a:blip xmlns:r="http://schemas.openxmlformats.org/officeDocument/2006/relationships" r:embed="rId2"/>
+          <a:srcRect/>
+          <a:stretch>
+            <a:fillRect t="-13000" b="-13000"/>
+          </a:stretch>
+        </a:blipFill>
+        <a:ln w="19050" cap="flat" cmpd="sng" algn="ctr">
+          <a:solidFill>
+            <a:schemeClr val="accent1">
+              <a:hueOff val="0"/>
+              <a:satOff val="0"/>
+              <a:lumOff val="0"/>
+              <a:alphaOff val="0"/>
+            </a:schemeClr>
+          </a:solidFill>
+          <a:prstDash val="solid"/>
+          <a:miter lim="800000"/>
+        </a:ln>
+        <a:effectLst/>
+      </dsp:spPr>
+      <dsp:style>
+        <a:lnRef idx="2">
+          <a:scrgbClr r="0" g="0" b="0"/>
+        </a:lnRef>
+        <a:fillRef idx="1">
+          <a:scrgbClr r="0" g="0" b="0"/>
+        </a:fillRef>
+        <a:effectRef idx="0">
+          <a:scrgbClr r="0" g="0" b="0"/>
+        </a:effectRef>
+        <a:fontRef idx="minor"/>
+      </dsp:style>
+    </dsp:sp>
+    <dsp:sp modelId="{98832B47-8879-47C5-BE09-12E11B47A3F0}">
+      <dsp:nvSpPr>
+        <dsp:cNvPr id="0" name=""/>
+        <dsp:cNvSpPr/>
+      </dsp:nvSpPr>
+      <dsp:spPr>
+        <a:xfrm>
+          <a:off x="3686031" y="564869"/>
+          <a:ext cx="3575280" cy="1072584"/>
+        </a:xfrm>
+        <a:prstGeom prst="round2SameRect">
+          <a:avLst>
+            <a:gd name="adj1" fmla="val 45000"/>
+            <a:gd name="adj2" fmla="val 0"/>
+          </a:avLst>
+        </a:prstGeom>
+        <a:solidFill>
+          <a:schemeClr val="accent1">
+            <a:hueOff val="0"/>
+            <a:satOff val="0"/>
+            <a:lumOff val="0"/>
+            <a:alphaOff val="0"/>
+          </a:schemeClr>
+        </a:solidFill>
+        <a:ln w="19050" cap="flat" cmpd="sng" algn="ctr">
+          <a:solidFill>
+            <a:schemeClr val="accent1">
+              <a:hueOff val="0"/>
+              <a:satOff val="0"/>
+              <a:lumOff val="0"/>
+              <a:alphaOff val="0"/>
+            </a:schemeClr>
+          </a:solidFill>
+          <a:prstDash val="solid"/>
+          <a:miter lim="800000"/>
+        </a:ln>
+        <a:effectLst/>
+      </dsp:spPr>
+      <dsp:style>
+        <a:lnRef idx="2">
+          <a:scrgbClr r="0" g="0" b="0"/>
+        </a:lnRef>
+        <a:fillRef idx="1">
+          <a:scrgbClr r="0" g="0" b="0"/>
+        </a:fillRef>
+        <a:effectRef idx="0">
+          <a:scrgbClr r="0" g="0" b="0"/>
+        </a:effectRef>
+        <a:fontRef idx="minor">
+          <a:schemeClr val="lt1"/>
+        </a:fontRef>
+      </dsp:style>
+      <dsp:txBody>
+        <a:bodyPr spcFirstLastPara="0" vert="horz" wrap="square" lIns="282527" tIns="282527" rIns="282527" bIns="282527" numCol="1" spcCol="1270" anchor="ctr" anchorCtr="0">
+          <a:noAutofit/>
+        </a:bodyPr>
+        <a:lstStyle/>
+        <a:p>
+          <a:pPr marL="0" lvl="0" indent="0" algn="l" defTabSz="844550">
+            <a:lnSpc>
+              <a:spcPct val="90000"/>
+            </a:lnSpc>
+            <a:spcBef>
+              <a:spcPct val="0"/>
+            </a:spcBef>
+            <a:spcAft>
+              <a:spcPct val="35000"/>
+            </a:spcAft>
+            <a:buNone/>
+          </a:pPr>
+          <a:r>
+            <a:rPr lang="en-US" sz="1900" kern="1200" dirty="0"/>
+            <a:t>Order buckets by pigment</a:t>
+          </a:r>
+          <a:endParaRPr lang="nl-BE" sz="1900" kern="1200" dirty="0"/>
+        </a:p>
+      </dsp:txBody>
+      <dsp:txXfrm>
+        <a:off x="3827398" y="706236"/>
+        <a:ext cx="3292546" cy="931217"/>
+      </dsp:txXfrm>
+    </dsp:sp>
+  </dsp:spTree>
+</dsp:drawing>
+</file>
+
+<file path=ppt/diagrams/drawing4.xml><?xml version="1.0" encoding="utf-8"?>
+<dsp:drawing xmlns:dgm="http://schemas.openxmlformats.org/drawingml/2006/diagram" xmlns:dsp="http://schemas.microsoft.com/office/drawing/2008/diagram" xmlns:a="http://schemas.openxmlformats.org/drawingml/2006/main">
+  <dsp:spTree>
+    <dsp:nvGrpSpPr>
+      <dsp:cNvPr id="0" name=""/>
+      <dsp:cNvGrpSpPr/>
+    </dsp:nvGrpSpPr>
+    <dsp:grpSpPr/>
     <dsp:sp modelId="{4A53E8B5-2823-4717-8317-6CB2437F8960}">
       <dsp:nvSpPr>
         <dsp:cNvPr id="0" name=""/>
@@ -4421,7 +5631,7 @@
           <a:blip xmlns:r="http://schemas.openxmlformats.org/officeDocument/2006/relationships" r:embed="rId1"/>
           <a:srcRect/>
           <a:stretch>
-            <a:fillRect l="-6000" r="-6000"/>
+            <a:fillRect l="-8000" r="-8000"/>
           </a:stretch>
         </a:blipFill>
         <a:ln w="19050" cap="flat" cmpd="sng" algn="ctr">
@@ -4523,7 +5733,7 @@
           </a:pPr>
           <a:r>
             <a:rPr lang="en-US" sz="1600" kern="1200" dirty="0"/>
-            <a:t>Render segments: far to near</a:t>
+            <a:t>Render strokes per segment</a:t>
           </a:r>
           <a:endParaRPr lang="nl-BE" sz="1600" kern="1200" dirty="0"/>
         </a:p>
@@ -5143,6 +6353,208 @@
 </dgm:layoutDef>
 </file>
 
+<file path=ppt/diagrams/layout4.xml><?xml version="1.0" encoding="utf-8"?>
+<dgm:layoutDef xmlns:dgm="http://schemas.openxmlformats.org/drawingml/2006/diagram" xmlns:a="http://schemas.openxmlformats.org/drawingml/2006/main" uniqueId="urn:microsoft.com/office/officeart/2024/layout/HorizontalActionList">
+  <dgm:title val=""/>
+  <dgm:desc val=""/>
+  <dgm:catLst>
+    <dgm:cat type="textcard" pri="200"/>
+  </dgm:catLst>
+  <dgm:sampData>
+    <dgm:dataModel>
+      <dgm:ptLst>
+        <dgm:pt modelId="0" type="doc"/>
+        <dgm:pt modelId="1">
+          <dgm:prSet phldr="1"/>
+        </dgm:pt>
+        <dgm:pt modelId="11">
+          <dgm:prSet phldr="1"/>
+        </dgm:pt>
+        <dgm:pt modelId="2">
+          <dgm:prSet phldr="1"/>
+        </dgm:pt>
+        <dgm:pt modelId="21">
+          <dgm:prSet phldr="1"/>
+        </dgm:pt>
+        <dgm:pt modelId="3">
+          <dgm:prSet phldr="1"/>
+        </dgm:pt>
+        <dgm:pt modelId="31">
+          <dgm:prSet phldr="1"/>
+        </dgm:pt>
+      </dgm:ptLst>
+      <dgm:cxnLst>
+        <dgm:cxn modelId="4" srcId="0" destId="1" srcOrd="0" destOrd="0"/>
+        <dgm:cxn modelId="5" srcId="0" destId="2" srcOrd="1" destOrd="0"/>
+        <dgm:cxn modelId="6" srcId="0" destId="3" srcOrd="2" destOrd="0"/>
+        <dgm:cxn modelId="13" srcId="1" destId="11" srcOrd="0" destOrd="0"/>
+        <dgm:cxn modelId="23" srcId="2" destId="21" srcOrd="0" destOrd="0"/>
+        <dgm:cxn modelId="33" srcId="3" destId="31" srcOrd="0" destOrd="0"/>
+      </dgm:cxnLst>
+      <dgm:bg/>
+      <dgm:whole/>
+    </dgm:dataModel>
+  </dgm:sampData>
+  <dgm:styleData>
+    <dgm:dataModel>
+      <dgm:ptLst>
+        <dgm:pt modelId="0" type="doc"/>
+        <dgm:pt modelId="1"/>
+        <dgm:pt modelId="2"/>
+      </dgm:ptLst>
+      <dgm:cxnLst>
+        <dgm:cxn modelId="3" srcId="0" destId="1" srcOrd="0" destOrd="0"/>
+        <dgm:cxn modelId="4" srcId="0" destId="2" srcOrd="1" destOrd="0"/>
+      </dgm:cxnLst>
+      <dgm:bg/>
+      <dgm:whole/>
+    </dgm:dataModel>
+  </dgm:styleData>
+  <dgm:clrData>
+    <dgm:dataModel>
+      <dgm:ptLst>
+        <dgm:pt modelId="0" type="doc"/>
+        <dgm:pt modelId="1"/>
+        <dgm:pt modelId="2"/>
+        <dgm:pt modelId="3"/>
+        <dgm:pt modelId="4"/>
+      </dgm:ptLst>
+      <dgm:cxnLst>
+        <dgm:cxn modelId="5" srcId="0" destId="1" srcOrd="0" destOrd="0"/>
+        <dgm:cxn modelId="6" srcId="0" destId="2" srcOrd="1" destOrd="0"/>
+        <dgm:cxn modelId="7" srcId="0" destId="3" srcOrd="2" destOrd="0"/>
+        <dgm:cxn modelId="8" srcId="0" destId="4" srcOrd="3" destOrd="0"/>
+      </dgm:cxnLst>
+      <dgm:bg/>
+      <dgm:whole/>
+    </dgm:dataModel>
+  </dgm:clrData>
+  <dgm:layoutNode name="Name0">
+    <dgm:varLst>
+      <dgm:dir/>
+      <dgm:animLvl val="lvl"/>
+      <dgm:resizeHandles val="exact"/>
+    </dgm:varLst>
+    <dgm:choose name="Name1">
+      <dgm:if name="Name2" func="var" arg="dir" op="equ" val="norm">
+        <dgm:alg type="lin"/>
+      </dgm:if>
+      <dgm:else name="Name3">
+        <dgm:alg type="lin">
+          <dgm:param type="linDir" val="fromR"/>
+        </dgm:alg>
+      </dgm:else>
+    </dgm:choose>
+    <dgm:shape xmlns:r="http://schemas.openxmlformats.org/officeDocument/2006/relationships" r:blip="">
+      <dgm:adjLst/>
+    </dgm:shape>
+    <dgm:presOf/>
+    <dgm:constrLst>
+      <dgm:constr type="h" for="ch" forName="composite" refType="h" fact="0.95"/>
+      <dgm:constr type="h" for="des" forName="composite" op="equ"/>
+      <dgm:constr type="w" for="ch" forName="composite" refType="w"/>
+      <dgm:constr type="w" for="des" forName="parTx"/>
+      <dgm:constr type="h" for="des" forName="parTx" op="equ"/>
+      <dgm:constr type="w" for="des" forName="bgOutline"/>
+      <dgm:constr type="primFontSz" for="des" forName="parTx" val="54"/>
+      <dgm:constr type="primFontSz" for="des" forName="bgOutline" refType="primFontSz" refFor="des" refForName="parTx" op="lte" fact="0.75"/>
+      <dgm:constr type="h" for="des" forName="bgOutline" op="equ"/>
+      <dgm:constr type="w" for="ch" forName="space" op="equ" val="3"/>
+    </dgm:constrLst>
+    <dgm:ruleLst>
+      <dgm:rule type="w" for="ch" forName="composite" val="0" fact="NaN" max="NaN"/>
+    </dgm:ruleLst>
+    <dgm:forEach name="Name6" axis="ch" ptType="node">
+      <dgm:layoutNode name="composite">
+        <dgm:alg type="composite"/>
+        <dgm:shape xmlns:r="http://schemas.openxmlformats.org/officeDocument/2006/relationships" r:blip="">
+          <dgm:adjLst/>
+        </dgm:shape>
+        <dgm:presOf/>
+        <dgm:constrLst>
+          <dgm:constr type="l" for="ch" forName="parTx"/>
+          <dgm:constr type="w" for="ch" forName="parTx" refType="w"/>
+          <dgm:constr type="t" for="ch" forName="parTx"/>
+          <dgm:constr type="l" for="ch" forName="bgOutline"/>
+          <dgm:constr type="t" for="ch" forName="bgOutline" refType="h" refFor="ch" refForName="parTx" fact="0.97"/>
+          <dgm:constr type="w" for="ch" forName="bgOutline" refType="w"/>
+          <dgm:constr type="h" for="ch" forName="bgOutline" refType="h" fact="0.75"/>
+        </dgm:constrLst>
+        <dgm:ruleLst/>
+        <dgm:layoutNode name="parTx" styleLbl="alignNode1">
+          <dgm:varLst>
+            <dgm:chMax val="0"/>
+            <dgm:chPref val="0"/>
+          </dgm:varLst>
+          <dgm:alg type="tx">
+            <dgm:param type="parTxLTRAlign" val="l"/>
+            <dgm:param type="parTxRTLAlign" val="r"/>
+          </dgm:alg>
+          <dgm:shape xmlns:r="http://schemas.openxmlformats.org/officeDocument/2006/relationships" type="round2SameRect" r:blip="" zOrderOff="3">
+            <dgm:adjLst>
+              <dgm:adj idx="1" val="0.45"/>
+            </dgm:adjLst>
+          </dgm:shape>
+          <dgm:presOf axis="self" ptType="node"/>
+          <dgm:constrLst>
+            <dgm:constr type="h" refType="w" op="lte" fact="0.3"/>
+            <dgm:constr type="h"/>
+            <dgm:constr type="tMarg" refType="w" fact="0.224"/>
+            <dgm:constr type="bMarg" refType="w" fact="0.224"/>
+            <dgm:constr type="lMarg" refType="w" fact="0.224"/>
+            <dgm:constr type="rMarg" refType="w" fact="0.224"/>
+          </dgm:constrLst>
+          <dgm:ruleLst>
+            <dgm:rule type="primFontSz" val="14" fact="NaN" max="NaN"/>
+          </dgm:ruleLst>
+        </dgm:layoutNode>
+        <dgm:layoutNode name="bgOutline" styleLbl="fgAcc1">
+          <dgm:varLst>
+            <dgm:bulletEnabled/>
+          </dgm:varLst>
+          <dgm:alg type="tx">
+            <dgm:param type="stBulletLvl" val="0"/>
+            <dgm:param type="txAnchorVert" val="t"/>
+            <dgm:param type="parTxLTRAlign" val="l"/>
+            <dgm:param type="shpTxLTRAlignCh" val="l"/>
+            <dgm:param type="parTxRTLAlign" val="r"/>
+            <dgm:param type="shpTxRTLAlignCh" val="r"/>
+          </dgm:alg>
+          <dgm:shape xmlns:r="http://schemas.openxmlformats.org/officeDocument/2006/relationships" rot="180" type="round2SameRect" r:blip="">
+            <dgm:adjLst>
+              <dgm:adj idx="1" val="0.15"/>
+              <dgm:adj idx="2" val="0"/>
+            </dgm:adjLst>
+          </dgm:shape>
+          <dgm:presOf axis="des" ptType="node"/>
+          <dgm:constrLst>
+            <dgm:constr type="primFontSz" val="28"/>
+            <dgm:constr type="tMarg" refType="w" fact="0.12"/>
+            <dgm:constr type="bMarg" refType="w" fact="0.12"/>
+            <dgm:constr type="lMarg" refType="w" fact="0.12"/>
+            <dgm:constr type="rMarg" refType="w" fact="0.12"/>
+          </dgm:constrLst>
+          <dgm:ruleLst>
+            <dgm:rule type="primFontSz" val="11" fact="NaN" max="NaN"/>
+          </dgm:ruleLst>
+        </dgm:layoutNode>
+      </dgm:layoutNode>
+      <dgm:forEach name="Name19" axis="followSib" ptType="sibTrans" cnt="1">
+        <dgm:layoutNode name="space">
+          <dgm:alg type="sp"/>
+          <dgm:shape xmlns:r="http://schemas.openxmlformats.org/officeDocument/2006/relationships" r:blip="">
+            <dgm:adjLst/>
+          </dgm:shape>
+          <dgm:presOf/>
+          <dgm:constrLst/>
+          <dgm:ruleLst/>
+        </dgm:layoutNode>
+      </dgm:forEach>
+    </dgm:forEach>
+  </dgm:layoutNode>
+</dgm:layoutDef>
+</file>
+
 <file path=ppt/diagrams/quickStyle1.xml><?xml version="1.0" encoding="utf-8"?>
 <dgm:styleDef xmlns:dgm="http://schemas.openxmlformats.org/drawingml/2006/diagram" xmlns:a="http://schemas.openxmlformats.org/drawingml/2006/main" uniqueId="urn:microsoft.com/office/officeart/2005/8/quickstyle/simple1">
   <dgm:title val=""/>
@@ -7212,6 +8624,1040 @@
 </file>
 
 <file path=ppt/diagrams/quickStyle3.xml><?xml version="1.0" encoding="utf-8"?>
+<dgm:styleDef xmlns:dgm="http://schemas.openxmlformats.org/drawingml/2006/diagram" xmlns:a="http://schemas.openxmlformats.org/drawingml/2006/main" uniqueId="urn:microsoft.com/office/officeart/2005/8/quickstyle/simple1">
+  <dgm:title val=""/>
+  <dgm:desc val=""/>
+  <dgm:catLst>
+    <dgm:cat type="simple" pri="10100"/>
+  </dgm:catLst>
+  <dgm:scene3d>
+    <a:camera prst="orthographicFront"/>
+    <a:lightRig rig="threePt" dir="t"/>
+  </dgm:scene3d>
+  <dgm:styleLbl name="node0">
+    <dgm:scene3d>
+      <a:camera prst="orthographicFront"/>
+      <a:lightRig rig="threePt" dir="t"/>
+    </dgm:scene3d>
+    <dgm:sp3d/>
+    <dgm:txPr/>
+    <dgm:style>
+      <a:lnRef idx="2">
+        <a:scrgbClr r="0" g="0" b="0"/>
+      </a:lnRef>
+      <a:fillRef idx="1">
+        <a:scrgbClr r="0" g="0" b="0"/>
+      </a:fillRef>
+      <a:effectRef idx="0">
+        <a:scrgbClr r="0" g="0" b="0"/>
+      </a:effectRef>
+      <a:fontRef idx="minor">
+        <a:schemeClr val="lt1"/>
+      </a:fontRef>
+    </dgm:style>
+  </dgm:styleLbl>
+  <dgm:styleLbl name="lnNode1">
+    <dgm:scene3d>
+      <a:camera prst="orthographicFront"/>
+      <a:lightRig rig="threePt" dir="t"/>
+    </dgm:scene3d>
+    <dgm:sp3d/>
+    <dgm:txPr/>
+    <dgm:style>
+      <a:lnRef idx="2">
+        <a:scrgbClr r="0" g="0" b="0"/>
+      </a:lnRef>
+      <a:fillRef idx="1">
+        <a:scrgbClr r="0" g="0" b="0"/>
+      </a:fillRef>
+      <a:effectRef idx="0">
+        <a:scrgbClr r="0" g="0" b="0"/>
+      </a:effectRef>
+      <a:fontRef idx="minor">
+        <a:schemeClr val="lt1"/>
+      </a:fontRef>
+    </dgm:style>
+  </dgm:styleLbl>
+  <dgm:styleLbl name="vennNode1">
+    <dgm:scene3d>
+      <a:camera prst="orthographicFront"/>
+      <a:lightRig rig="threePt" dir="t"/>
+    </dgm:scene3d>
+    <dgm:sp3d/>
+    <dgm:txPr/>
+    <dgm:style>
+      <a:lnRef idx="2">
+        <a:scrgbClr r="0" g="0" b="0"/>
+      </a:lnRef>
+      <a:fillRef idx="1">
+        <a:scrgbClr r="0" g="0" b="0"/>
+      </a:fillRef>
+      <a:effectRef idx="0">
+        <a:scrgbClr r="0" g="0" b="0"/>
+      </a:effectRef>
+      <a:fontRef idx="minor">
+        <a:schemeClr val="tx1"/>
+      </a:fontRef>
+    </dgm:style>
+  </dgm:styleLbl>
+  <dgm:styleLbl name="alignNode1">
+    <dgm:scene3d>
+      <a:camera prst="orthographicFront"/>
+      <a:lightRig rig="threePt" dir="t"/>
+    </dgm:scene3d>
+    <dgm:sp3d/>
+    <dgm:txPr/>
+    <dgm:style>
+      <a:lnRef idx="2">
+        <a:scrgbClr r="0" g="0" b="0"/>
+      </a:lnRef>
+      <a:fillRef idx="1">
+        <a:scrgbClr r="0" g="0" b="0"/>
+      </a:fillRef>
+      <a:effectRef idx="0">
+        <a:scrgbClr r="0" g="0" b="0"/>
+      </a:effectRef>
+      <a:fontRef idx="minor">
+        <a:schemeClr val="lt1"/>
+      </a:fontRef>
+    </dgm:style>
+  </dgm:styleLbl>
+  <dgm:styleLbl name="node1">
+    <dgm:scene3d>
+      <a:camera prst="orthographicFront"/>
+      <a:lightRig rig="threePt" dir="t"/>
+    </dgm:scene3d>
+    <dgm:sp3d/>
+    <dgm:txPr/>
+    <dgm:style>
+      <a:lnRef idx="2">
+        <a:scrgbClr r="0" g="0" b="0"/>
+      </a:lnRef>
+      <a:fillRef idx="1">
+        <a:scrgbClr r="0" g="0" b="0"/>
+      </a:fillRef>
+      <a:effectRef idx="0">
+        <a:scrgbClr r="0" g="0" b="0"/>
+      </a:effectRef>
+      <a:fontRef idx="minor">
+        <a:schemeClr val="lt1"/>
+      </a:fontRef>
+    </dgm:style>
+  </dgm:styleLbl>
+  <dgm:styleLbl name="node2">
+    <dgm:scene3d>
+      <a:camera prst="orthographicFront"/>
+      <a:lightRig rig="threePt" dir="t"/>
+    </dgm:scene3d>
+    <dgm:sp3d/>
+    <dgm:txPr/>
+    <dgm:style>
+      <a:lnRef idx="2">
+        <a:scrgbClr r="0" g="0" b="0"/>
+      </a:lnRef>
+      <a:fillRef idx="1">
+        <a:scrgbClr r="0" g="0" b="0"/>
+      </a:fillRef>
+      <a:effectRef idx="0">
+        <a:scrgbClr r="0" g="0" b="0"/>
+      </a:effectRef>
+      <a:fontRef idx="minor">
+        <a:schemeClr val="lt1"/>
+      </a:fontRef>
+    </dgm:style>
+  </dgm:styleLbl>
+  <dgm:styleLbl name="node3">
+    <dgm:scene3d>
+      <a:camera prst="orthographicFront"/>
+      <a:lightRig rig="threePt" dir="t"/>
+    </dgm:scene3d>
+    <dgm:sp3d/>
+    <dgm:txPr/>
+    <dgm:style>
+      <a:lnRef idx="2">
+        <a:scrgbClr r="0" g="0" b="0"/>
+      </a:lnRef>
+      <a:fillRef idx="1">
+        <a:scrgbClr r="0" g="0" b="0"/>
+      </a:fillRef>
+      <a:effectRef idx="0">
+        <a:scrgbClr r="0" g="0" b="0"/>
+      </a:effectRef>
+      <a:fontRef idx="minor">
+        <a:schemeClr val="lt1"/>
+      </a:fontRef>
+    </dgm:style>
+  </dgm:styleLbl>
+  <dgm:styleLbl name="node4">
+    <dgm:scene3d>
+      <a:camera prst="orthographicFront"/>
+      <a:lightRig rig="threePt" dir="t"/>
+    </dgm:scene3d>
+    <dgm:sp3d/>
+    <dgm:txPr/>
+    <dgm:style>
+      <a:lnRef idx="2">
+        <a:scrgbClr r="0" g="0" b="0"/>
+      </a:lnRef>
+      <a:fillRef idx="1">
+        <a:scrgbClr r="0" g="0" b="0"/>
+      </a:fillRef>
+      <a:effectRef idx="0">
+        <a:scrgbClr r="0" g="0" b="0"/>
+      </a:effectRef>
+      <a:fontRef idx="minor">
+        <a:schemeClr val="lt1"/>
+      </a:fontRef>
+    </dgm:style>
+  </dgm:styleLbl>
+  <dgm:styleLbl name="fgImgPlace1">
+    <dgm:scene3d>
+      <a:camera prst="orthographicFront"/>
+      <a:lightRig rig="threePt" dir="t"/>
+    </dgm:scene3d>
+    <dgm:sp3d/>
+    <dgm:txPr/>
+    <dgm:style>
+      <a:lnRef idx="2">
+        <a:scrgbClr r="0" g="0" b="0"/>
+      </a:lnRef>
+      <a:fillRef idx="1">
+        <a:scrgbClr r="0" g="0" b="0"/>
+      </a:fillRef>
+      <a:effectRef idx="0">
+        <a:scrgbClr r="0" g="0" b="0"/>
+      </a:effectRef>
+      <a:fontRef idx="minor"/>
+    </dgm:style>
+  </dgm:styleLbl>
+  <dgm:styleLbl name="alignImgPlace1">
+    <dgm:scene3d>
+      <a:camera prst="orthographicFront"/>
+      <a:lightRig rig="threePt" dir="t"/>
+    </dgm:scene3d>
+    <dgm:sp3d/>
+    <dgm:txPr/>
+    <dgm:style>
+      <a:lnRef idx="2">
+        <a:scrgbClr r="0" g="0" b="0"/>
+      </a:lnRef>
+      <a:fillRef idx="1">
+        <a:scrgbClr r="0" g="0" b="0"/>
+      </a:fillRef>
+      <a:effectRef idx="0">
+        <a:scrgbClr r="0" g="0" b="0"/>
+      </a:effectRef>
+      <a:fontRef idx="minor"/>
+    </dgm:style>
+  </dgm:styleLbl>
+  <dgm:styleLbl name="bgImgPlace1">
+    <dgm:scene3d>
+      <a:camera prst="orthographicFront"/>
+      <a:lightRig rig="threePt" dir="t"/>
+    </dgm:scene3d>
+    <dgm:sp3d/>
+    <dgm:txPr/>
+    <dgm:style>
+      <a:lnRef idx="2">
+        <a:scrgbClr r="0" g="0" b="0"/>
+      </a:lnRef>
+      <a:fillRef idx="1">
+        <a:scrgbClr r="0" g="0" b="0"/>
+      </a:fillRef>
+      <a:effectRef idx="0">
+        <a:scrgbClr r="0" g="0" b="0"/>
+      </a:effectRef>
+      <a:fontRef idx="minor"/>
+    </dgm:style>
+  </dgm:styleLbl>
+  <dgm:styleLbl name="sibTrans2D1">
+    <dgm:scene3d>
+      <a:camera prst="orthographicFront"/>
+      <a:lightRig rig="threePt" dir="t"/>
+    </dgm:scene3d>
+    <dgm:sp3d/>
+    <dgm:txPr/>
+    <dgm:style>
+      <a:lnRef idx="0">
+        <a:scrgbClr r="0" g="0" b="0"/>
+      </a:lnRef>
+      <a:fillRef idx="1">
+        <a:scrgbClr r="0" g="0" b="0"/>
+      </a:fillRef>
+      <a:effectRef idx="0">
+        <a:scrgbClr r="0" g="0" b="0"/>
+      </a:effectRef>
+      <a:fontRef idx="minor">
+        <a:schemeClr val="lt1"/>
+      </a:fontRef>
+    </dgm:style>
+  </dgm:styleLbl>
+  <dgm:styleLbl name="fgSibTrans2D1">
+    <dgm:scene3d>
+      <a:camera prst="orthographicFront"/>
+      <a:lightRig rig="threePt" dir="t"/>
+    </dgm:scene3d>
+    <dgm:sp3d/>
+    <dgm:txPr/>
+    <dgm:style>
+      <a:lnRef idx="0">
+        <a:scrgbClr r="0" g="0" b="0"/>
+      </a:lnRef>
+      <a:fillRef idx="1">
+        <a:scrgbClr r="0" g="0" b="0"/>
+      </a:fillRef>
+      <a:effectRef idx="0">
+        <a:scrgbClr r="0" g="0" b="0"/>
+      </a:effectRef>
+      <a:fontRef idx="minor">
+        <a:schemeClr val="lt1"/>
+      </a:fontRef>
+    </dgm:style>
+  </dgm:styleLbl>
+  <dgm:styleLbl name="bgSibTrans2D1">
+    <dgm:scene3d>
+      <a:camera prst="orthographicFront"/>
+      <a:lightRig rig="threePt" dir="t"/>
+    </dgm:scene3d>
+    <dgm:sp3d/>
+    <dgm:txPr/>
+    <dgm:style>
+      <a:lnRef idx="0">
+        <a:scrgbClr r="0" g="0" b="0"/>
+      </a:lnRef>
+      <a:fillRef idx="1">
+        <a:scrgbClr r="0" g="0" b="0"/>
+      </a:fillRef>
+      <a:effectRef idx="0">
+        <a:scrgbClr r="0" g="0" b="0"/>
+      </a:effectRef>
+      <a:fontRef idx="minor">
+        <a:schemeClr val="lt1"/>
+      </a:fontRef>
+    </dgm:style>
+  </dgm:styleLbl>
+  <dgm:styleLbl name="sibTrans1D1">
+    <dgm:scene3d>
+      <a:camera prst="orthographicFront"/>
+      <a:lightRig rig="threePt" dir="t"/>
+    </dgm:scene3d>
+    <dgm:sp3d/>
+    <dgm:txPr/>
+    <dgm:style>
+      <a:lnRef idx="1">
+        <a:scrgbClr r="0" g="0" b="0"/>
+      </a:lnRef>
+      <a:fillRef idx="0">
+        <a:scrgbClr r="0" g="0" b="0"/>
+      </a:fillRef>
+      <a:effectRef idx="0">
+        <a:scrgbClr r="0" g="0" b="0"/>
+      </a:effectRef>
+      <a:fontRef idx="minor"/>
+    </dgm:style>
+  </dgm:styleLbl>
+  <dgm:styleLbl name="callout">
+    <dgm:scene3d>
+      <a:camera prst="orthographicFront"/>
+      <a:lightRig rig="threePt" dir="t"/>
+    </dgm:scene3d>
+    <dgm:sp3d/>
+    <dgm:txPr/>
+    <dgm:style>
+      <a:lnRef idx="2">
+        <a:scrgbClr r="0" g="0" b="0"/>
+      </a:lnRef>
+      <a:fillRef idx="1">
+        <a:scrgbClr r="0" g="0" b="0"/>
+      </a:fillRef>
+      <a:effectRef idx="0">
+        <a:scrgbClr r="0" g="0" b="0"/>
+      </a:effectRef>
+      <a:fontRef idx="minor"/>
+    </dgm:style>
+  </dgm:styleLbl>
+  <dgm:styleLbl name="asst0">
+    <dgm:scene3d>
+      <a:camera prst="orthographicFront"/>
+      <a:lightRig rig="threePt" dir="t"/>
+    </dgm:scene3d>
+    <dgm:sp3d/>
+    <dgm:txPr/>
+    <dgm:style>
+      <a:lnRef idx="2">
+        <a:scrgbClr r="0" g="0" b="0"/>
+      </a:lnRef>
+      <a:fillRef idx="1">
+        <a:scrgbClr r="0" g="0" b="0"/>
+      </a:fillRef>
+      <a:effectRef idx="0">
+        <a:scrgbClr r="0" g="0" b="0"/>
+      </a:effectRef>
+      <a:fontRef idx="minor">
+        <a:schemeClr val="lt1"/>
+      </a:fontRef>
+    </dgm:style>
+  </dgm:styleLbl>
+  <dgm:styleLbl name="asst1">
+    <dgm:scene3d>
+      <a:camera prst="orthographicFront"/>
+      <a:lightRig rig="threePt" dir="t"/>
+    </dgm:scene3d>
+    <dgm:sp3d/>
+    <dgm:txPr/>
+    <dgm:style>
+      <a:lnRef idx="2">
+        <a:scrgbClr r="0" g="0" b="0"/>
+      </a:lnRef>
+      <a:fillRef idx="1">
+        <a:scrgbClr r="0" g="0" b="0"/>
+      </a:fillRef>
+      <a:effectRef idx="0">
+        <a:scrgbClr r="0" g="0" b="0"/>
+      </a:effectRef>
+      <a:fontRef idx="minor">
+        <a:schemeClr val="lt1"/>
+      </a:fontRef>
+    </dgm:style>
+  </dgm:styleLbl>
+  <dgm:styleLbl name="asst2">
+    <dgm:scene3d>
+      <a:camera prst="orthographicFront"/>
+      <a:lightRig rig="threePt" dir="t"/>
+    </dgm:scene3d>
+    <dgm:sp3d/>
+    <dgm:txPr/>
+    <dgm:style>
+      <a:lnRef idx="2">
+        <a:scrgbClr r="0" g="0" b="0"/>
+      </a:lnRef>
+      <a:fillRef idx="1">
+        <a:scrgbClr r="0" g="0" b="0"/>
+      </a:fillRef>
+      <a:effectRef idx="0">
+        <a:scrgbClr r="0" g="0" b="0"/>
+      </a:effectRef>
+      <a:fontRef idx="minor">
+        <a:schemeClr val="lt1"/>
+      </a:fontRef>
+    </dgm:style>
+  </dgm:styleLbl>
+  <dgm:styleLbl name="asst3">
+    <dgm:scene3d>
+      <a:camera prst="orthographicFront"/>
+      <a:lightRig rig="threePt" dir="t"/>
+    </dgm:scene3d>
+    <dgm:sp3d/>
+    <dgm:txPr/>
+    <dgm:style>
+      <a:lnRef idx="2">
+        <a:scrgbClr r="0" g="0" b="0"/>
+      </a:lnRef>
+      <a:fillRef idx="1">
+        <a:scrgbClr r="0" g="0" b="0"/>
+      </a:fillRef>
+      <a:effectRef idx="0">
+        <a:scrgbClr r="0" g="0" b="0"/>
+      </a:effectRef>
+      <a:fontRef idx="minor">
+        <a:schemeClr val="lt1"/>
+      </a:fontRef>
+    </dgm:style>
+  </dgm:styleLbl>
+  <dgm:styleLbl name="asst4">
+    <dgm:scene3d>
+      <a:camera prst="orthographicFront"/>
+      <a:lightRig rig="threePt" dir="t"/>
+    </dgm:scene3d>
+    <dgm:sp3d/>
+    <dgm:txPr/>
+    <dgm:style>
+      <a:lnRef idx="2">
+        <a:scrgbClr r="0" g="0" b="0"/>
+      </a:lnRef>
+      <a:fillRef idx="1">
+        <a:scrgbClr r="0" g="0" b="0"/>
+      </a:fillRef>
+      <a:effectRef idx="0">
+        <a:scrgbClr r="0" g="0" b="0"/>
+      </a:effectRef>
+      <a:fontRef idx="minor">
+        <a:schemeClr val="lt1"/>
+      </a:fontRef>
+    </dgm:style>
+  </dgm:styleLbl>
+  <dgm:styleLbl name="parChTrans2D1">
+    <dgm:scene3d>
+      <a:camera prst="orthographicFront"/>
+      <a:lightRig rig="threePt" dir="t"/>
+    </dgm:scene3d>
+    <dgm:sp3d/>
+    <dgm:txPr/>
+    <dgm:style>
+      <a:lnRef idx="2">
+        <a:scrgbClr r="0" g="0" b="0"/>
+      </a:lnRef>
+      <a:fillRef idx="1">
+        <a:scrgbClr r="0" g="0" b="0"/>
+      </a:fillRef>
+      <a:effectRef idx="0">
+        <a:scrgbClr r="0" g="0" b="0"/>
+      </a:effectRef>
+      <a:fontRef idx="minor">
+        <a:schemeClr val="lt1"/>
+      </a:fontRef>
+    </dgm:style>
+  </dgm:styleLbl>
+  <dgm:styleLbl name="parChTrans2D2">
+    <dgm:scene3d>
+      <a:camera prst="orthographicFront"/>
+      <a:lightRig rig="threePt" dir="t"/>
+    </dgm:scene3d>
+    <dgm:sp3d/>
+    <dgm:txPr/>
+    <dgm:style>
+      <a:lnRef idx="2">
+        <a:scrgbClr r="0" g="0" b="0"/>
+      </a:lnRef>
+      <a:fillRef idx="1">
+        <a:scrgbClr r="0" g="0" b="0"/>
+      </a:fillRef>
+      <a:effectRef idx="0">
+        <a:scrgbClr r="0" g="0" b="0"/>
+      </a:effectRef>
+      <a:fontRef idx="minor">
+        <a:schemeClr val="lt1"/>
+      </a:fontRef>
+    </dgm:style>
+  </dgm:styleLbl>
+  <dgm:styleLbl name="parChTrans2D3">
+    <dgm:scene3d>
+      <a:camera prst="orthographicFront"/>
+      <a:lightRig rig="threePt" dir="t"/>
+    </dgm:scene3d>
+    <dgm:sp3d/>
+    <dgm:txPr/>
+    <dgm:style>
+      <a:lnRef idx="2">
+        <a:scrgbClr r="0" g="0" b="0"/>
+      </a:lnRef>
+      <a:fillRef idx="1">
+        <a:scrgbClr r="0" g="0" b="0"/>
+      </a:fillRef>
+      <a:effectRef idx="0">
+        <a:scrgbClr r="0" g="0" b="0"/>
+      </a:effectRef>
+      <a:fontRef idx="minor">
+        <a:schemeClr val="lt1"/>
+      </a:fontRef>
+    </dgm:style>
+  </dgm:styleLbl>
+  <dgm:styleLbl name="parChTrans2D4">
+    <dgm:scene3d>
+      <a:camera prst="orthographicFront"/>
+      <a:lightRig rig="threePt" dir="t"/>
+    </dgm:scene3d>
+    <dgm:sp3d/>
+    <dgm:txPr/>
+    <dgm:style>
+      <a:lnRef idx="2">
+        <a:scrgbClr r="0" g="0" b="0"/>
+      </a:lnRef>
+      <a:fillRef idx="1">
+        <a:scrgbClr r="0" g="0" b="0"/>
+      </a:fillRef>
+      <a:effectRef idx="0">
+        <a:scrgbClr r="0" g="0" b="0"/>
+      </a:effectRef>
+      <a:fontRef idx="minor">
+        <a:schemeClr val="lt1"/>
+      </a:fontRef>
+    </dgm:style>
+  </dgm:styleLbl>
+  <dgm:styleLbl name="parChTrans1D1">
+    <dgm:scene3d>
+      <a:camera prst="orthographicFront"/>
+      <a:lightRig rig="threePt" dir="t"/>
+    </dgm:scene3d>
+    <dgm:sp3d/>
+    <dgm:txPr/>
+    <dgm:style>
+      <a:lnRef idx="2">
+        <a:scrgbClr r="0" g="0" b="0"/>
+      </a:lnRef>
+      <a:fillRef idx="0">
+        <a:scrgbClr r="0" g="0" b="0"/>
+      </a:fillRef>
+      <a:effectRef idx="0">
+        <a:scrgbClr r="0" g="0" b="0"/>
+      </a:effectRef>
+      <a:fontRef idx="minor"/>
+    </dgm:style>
+  </dgm:styleLbl>
+  <dgm:styleLbl name="parChTrans1D2">
+    <dgm:scene3d>
+      <a:camera prst="orthographicFront"/>
+      <a:lightRig rig="threePt" dir="t"/>
+    </dgm:scene3d>
+    <dgm:sp3d/>
+    <dgm:txPr/>
+    <dgm:style>
+      <a:lnRef idx="2">
+        <a:scrgbClr r="0" g="0" b="0"/>
+      </a:lnRef>
+      <a:fillRef idx="0">
+        <a:scrgbClr r="0" g="0" b="0"/>
+      </a:fillRef>
+      <a:effectRef idx="0">
+        <a:scrgbClr r="0" g="0" b="0"/>
+      </a:effectRef>
+      <a:fontRef idx="minor"/>
+    </dgm:style>
+  </dgm:styleLbl>
+  <dgm:styleLbl name="parChTrans1D3">
+    <dgm:scene3d>
+      <a:camera prst="orthographicFront"/>
+      <a:lightRig rig="threePt" dir="t"/>
+    </dgm:scene3d>
+    <dgm:sp3d/>
+    <dgm:txPr/>
+    <dgm:style>
+      <a:lnRef idx="2">
+        <a:scrgbClr r="0" g="0" b="0"/>
+      </a:lnRef>
+      <a:fillRef idx="0">
+        <a:scrgbClr r="0" g="0" b="0"/>
+      </a:fillRef>
+      <a:effectRef idx="0">
+        <a:scrgbClr r="0" g="0" b="0"/>
+      </a:effectRef>
+      <a:fontRef idx="minor"/>
+    </dgm:style>
+  </dgm:styleLbl>
+  <dgm:styleLbl name="parChTrans1D4">
+    <dgm:scene3d>
+      <a:camera prst="orthographicFront"/>
+      <a:lightRig rig="threePt" dir="t"/>
+    </dgm:scene3d>
+    <dgm:sp3d/>
+    <dgm:txPr/>
+    <dgm:style>
+      <a:lnRef idx="2">
+        <a:scrgbClr r="0" g="0" b="0"/>
+      </a:lnRef>
+      <a:fillRef idx="0">
+        <a:scrgbClr r="0" g="0" b="0"/>
+      </a:fillRef>
+      <a:effectRef idx="0">
+        <a:scrgbClr r="0" g="0" b="0"/>
+      </a:effectRef>
+      <a:fontRef idx="minor"/>
+    </dgm:style>
+  </dgm:styleLbl>
+  <dgm:styleLbl name="fgAcc1">
+    <dgm:scene3d>
+      <a:camera prst="orthographicFront"/>
+      <a:lightRig rig="threePt" dir="t"/>
+    </dgm:scene3d>
+    <dgm:sp3d/>
+    <dgm:txPr/>
+    <dgm:style>
+      <a:lnRef idx="2">
+        <a:scrgbClr r="0" g="0" b="0"/>
+      </a:lnRef>
+      <a:fillRef idx="1">
+        <a:scrgbClr r="0" g="0" b="0"/>
+      </a:fillRef>
+      <a:effectRef idx="0">
+        <a:scrgbClr r="0" g="0" b="0"/>
+      </a:effectRef>
+      <a:fontRef idx="minor"/>
+    </dgm:style>
+  </dgm:styleLbl>
+  <dgm:styleLbl name="conFgAcc1">
+    <dgm:scene3d>
+      <a:camera prst="orthographicFront"/>
+      <a:lightRig rig="threePt" dir="t"/>
+    </dgm:scene3d>
+    <dgm:sp3d/>
+    <dgm:txPr/>
+    <dgm:style>
+      <a:lnRef idx="2">
+        <a:scrgbClr r="0" g="0" b="0"/>
+      </a:lnRef>
+      <a:fillRef idx="1">
+        <a:scrgbClr r="0" g="0" b="0"/>
+      </a:fillRef>
+      <a:effectRef idx="0">
+        <a:scrgbClr r="0" g="0" b="0"/>
+      </a:effectRef>
+      <a:fontRef idx="minor"/>
+    </dgm:style>
+  </dgm:styleLbl>
+  <dgm:styleLbl name="alignAcc1">
+    <dgm:scene3d>
+      <a:camera prst="orthographicFront"/>
+      <a:lightRig rig="threePt" dir="t"/>
+    </dgm:scene3d>
+    <dgm:sp3d/>
+    <dgm:txPr/>
+    <dgm:style>
+      <a:lnRef idx="2">
+        <a:scrgbClr r="0" g="0" b="0"/>
+      </a:lnRef>
+      <a:fillRef idx="1">
+        <a:scrgbClr r="0" g="0" b="0"/>
+      </a:fillRef>
+      <a:effectRef idx="0">
+        <a:scrgbClr r="0" g="0" b="0"/>
+      </a:effectRef>
+      <a:fontRef idx="minor"/>
+    </dgm:style>
+  </dgm:styleLbl>
+  <dgm:styleLbl name="trAlignAcc1">
+    <dgm:scene3d>
+      <a:camera prst="orthographicFront"/>
+      <a:lightRig rig="threePt" dir="t"/>
+    </dgm:scene3d>
+    <dgm:sp3d/>
+    <dgm:txPr/>
+    <dgm:style>
+      <a:lnRef idx="1">
+        <a:scrgbClr r="0" g="0" b="0"/>
+      </a:lnRef>
+      <a:fillRef idx="1">
+        <a:scrgbClr r="0" g="0" b="0"/>
+      </a:fillRef>
+      <a:effectRef idx="0">
+        <a:scrgbClr r="0" g="0" b="0"/>
+      </a:effectRef>
+      <a:fontRef idx="minor"/>
+    </dgm:style>
+  </dgm:styleLbl>
+  <dgm:styleLbl name="bgAcc1">
+    <dgm:scene3d>
+      <a:camera prst="orthographicFront"/>
+      <a:lightRig rig="threePt" dir="t"/>
+    </dgm:scene3d>
+    <dgm:sp3d/>
+    <dgm:txPr/>
+    <dgm:style>
+      <a:lnRef idx="2">
+        <a:scrgbClr r="0" g="0" b="0"/>
+      </a:lnRef>
+      <a:fillRef idx="1">
+        <a:scrgbClr r="0" g="0" b="0"/>
+      </a:fillRef>
+      <a:effectRef idx="0">
+        <a:scrgbClr r="0" g="0" b="0"/>
+      </a:effectRef>
+      <a:fontRef idx="minor"/>
+    </dgm:style>
+  </dgm:styleLbl>
+  <dgm:styleLbl name="solidFgAcc1">
+    <dgm:scene3d>
+      <a:camera prst="orthographicFront"/>
+      <a:lightRig rig="threePt" dir="t"/>
+    </dgm:scene3d>
+    <dgm:sp3d/>
+    <dgm:txPr/>
+    <dgm:style>
+      <a:lnRef idx="2">
+        <a:scrgbClr r="0" g="0" b="0"/>
+      </a:lnRef>
+      <a:fillRef idx="1">
+        <a:scrgbClr r="0" g="0" b="0"/>
+      </a:fillRef>
+      <a:effectRef idx="0">
+        <a:scrgbClr r="0" g="0" b="0"/>
+      </a:effectRef>
+      <a:fontRef idx="minor"/>
+    </dgm:style>
+  </dgm:styleLbl>
+  <dgm:styleLbl name="solidAlignAcc1">
+    <dgm:scene3d>
+      <a:camera prst="orthographicFront"/>
+      <a:lightRig rig="threePt" dir="t"/>
+    </dgm:scene3d>
+    <dgm:sp3d/>
+    <dgm:txPr/>
+    <dgm:style>
+      <a:lnRef idx="2">
+        <a:scrgbClr r="0" g="0" b="0"/>
+      </a:lnRef>
+      <a:fillRef idx="1">
+        <a:scrgbClr r="0" g="0" b="0"/>
+      </a:fillRef>
+      <a:effectRef idx="0">
+        <a:scrgbClr r="0" g="0" b="0"/>
+      </a:effectRef>
+      <a:fontRef idx="minor"/>
+    </dgm:style>
+  </dgm:styleLbl>
+  <dgm:styleLbl name="solidBgAcc1">
+    <dgm:scene3d>
+      <a:camera prst="orthographicFront"/>
+      <a:lightRig rig="threePt" dir="t"/>
+    </dgm:scene3d>
+    <dgm:sp3d/>
+    <dgm:txPr/>
+    <dgm:style>
+      <a:lnRef idx="2">
+        <a:scrgbClr r="0" g="0" b="0"/>
+      </a:lnRef>
+      <a:fillRef idx="1">
+        <a:scrgbClr r="0" g="0" b="0"/>
+      </a:fillRef>
+      <a:effectRef idx="0">
+        <a:scrgbClr r="0" g="0" b="0"/>
+      </a:effectRef>
+      <a:fontRef idx="minor"/>
+    </dgm:style>
+  </dgm:styleLbl>
+  <dgm:styleLbl name="fgAccFollowNode1">
+    <dgm:scene3d>
+      <a:camera prst="orthographicFront"/>
+      <a:lightRig rig="threePt" dir="t"/>
+    </dgm:scene3d>
+    <dgm:sp3d/>
+    <dgm:txPr/>
+    <dgm:style>
+      <a:lnRef idx="2">
+        <a:scrgbClr r="0" g="0" b="0"/>
+      </a:lnRef>
+      <a:fillRef idx="1">
+        <a:scrgbClr r="0" g="0" b="0"/>
+      </a:fillRef>
+      <a:effectRef idx="0">
+        <a:scrgbClr r="0" g="0" b="0"/>
+      </a:effectRef>
+      <a:fontRef idx="minor"/>
+    </dgm:style>
+  </dgm:styleLbl>
+  <dgm:styleLbl name="alignAccFollowNode1">
+    <dgm:scene3d>
+      <a:camera prst="orthographicFront"/>
+      <a:lightRig rig="threePt" dir="t"/>
+    </dgm:scene3d>
+    <dgm:sp3d/>
+    <dgm:txPr/>
+    <dgm:style>
+      <a:lnRef idx="2">
+        <a:scrgbClr r="0" g="0" b="0"/>
+      </a:lnRef>
+      <a:fillRef idx="1">
+        <a:scrgbClr r="0" g="0" b="0"/>
+      </a:fillRef>
+      <a:effectRef idx="0">
+        <a:scrgbClr r="0" g="0" b="0"/>
+      </a:effectRef>
+      <a:fontRef idx="minor"/>
+    </dgm:style>
+  </dgm:styleLbl>
+  <dgm:styleLbl name="bgAccFollowNode1">
+    <dgm:scene3d>
+      <a:camera prst="orthographicFront"/>
+      <a:lightRig rig="threePt" dir="t"/>
+    </dgm:scene3d>
+    <dgm:sp3d/>
+    <dgm:txPr/>
+    <dgm:style>
+      <a:lnRef idx="2">
+        <a:scrgbClr r="0" g="0" b="0"/>
+      </a:lnRef>
+      <a:fillRef idx="1">
+        <a:scrgbClr r="0" g="0" b="0"/>
+      </a:fillRef>
+      <a:effectRef idx="0">
+        <a:scrgbClr r="0" g="0" b="0"/>
+      </a:effectRef>
+      <a:fontRef idx="minor"/>
+    </dgm:style>
+  </dgm:styleLbl>
+  <dgm:styleLbl name="fgAcc0">
+    <dgm:scene3d>
+      <a:camera prst="orthographicFront"/>
+      <a:lightRig rig="threePt" dir="t"/>
+    </dgm:scene3d>
+    <dgm:sp3d/>
+    <dgm:txPr/>
+    <dgm:style>
+      <a:lnRef idx="2">
+        <a:scrgbClr r="0" g="0" b="0"/>
+      </a:lnRef>
+      <a:fillRef idx="1">
+        <a:scrgbClr r="0" g="0" b="0"/>
+      </a:fillRef>
+      <a:effectRef idx="0">
+        <a:scrgbClr r="0" g="0" b="0"/>
+      </a:effectRef>
+      <a:fontRef idx="minor"/>
+    </dgm:style>
+  </dgm:styleLbl>
+  <dgm:styleLbl name="fgAcc2">
+    <dgm:scene3d>
+      <a:camera prst="orthographicFront"/>
+      <a:lightRig rig="threePt" dir="t"/>
+    </dgm:scene3d>
+    <dgm:sp3d/>
+    <dgm:txPr/>
+    <dgm:style>
+      <a:lnRef idx="2">
+        <a:scrgbClr r="0" g="0" b="0"/>
+      </a:lnRef>
+      <a:fillRef idx="1">
+        <a:scrgbClr r="0" g="0" b="0"/>
+      </a:fillRef>
+      <a:effectRef idx="0">
+        <a:scrgbClr r="0" g="0" b="0"/>
+      </a:effectRef>
+      <a:fontRef idx="minor"/>
+    </dgm:style>
+  </dgm:styleLbl>
+  <dgm:styleLbl name="fgAcc3">
+    <dgm:scene3d>
+      <a:camera prst="orthographicFront"/>
+      <a:lightRig rig="threePt" dir="t"/>
+    </dgm:scene3d>
+    <dgm:sp3d/>
+    <dgm:txPr/>
+    <dgm:style>
+      <a:lnRef idx="2">
+        <a:scrgbClr r="0" g="0" b="0"/>
+      </a:lnRef>
+      <a:fillRef idx="1">
+        <a:scrgbClr r="0" g="0" b="0"/>
+      </a:fillRef>
+      <a:effectRef idx="0">
+        <a:scrgbClr r="0" g="0" b="0"/>
+      </a:effectRef>
+      <a:fontRef idx="minor"/>
+    </dgm:style>
+  </dgm:styleLbl>
+  <dgm:styleLbl name="fgAcc4">
+    <dgm:scene3d>
+      <a:camera prst="orthographicFront"/>
+      <a:lightRig rig="threePt" dir="t"/>
+    </dgm:scene3d>
+    <dgm:sp3d/>
+    <dgm:txPr/>
+    <dgm:style>
+      <a:lnRef idx="2">
+        <a:scrgbClr r="0" g="0" b="0"/>
+      </a:lnRef>
+      <a:fillRef idx="1">
+        <a:scrgbClr r="0" g="0" b="0"/>
+      </a:fillRef>
+      <a:effectRef idx="0">
+        <a:scrgbClr r="0" g="0" b="0"/>
+      </a:effectRef>
+      <a:fontRef idx="minor"/>
+    </dgm:style>
+  </dgm:styleLbl>
+  <dgm:styleLbl name="bgShp">
+    <dgm:scene3d>
+      <a:camera prst="orthographicFront"/>
+      <a:lightRig rig="threePt" dir="t"/>
+    </dgm:scene3d>
+    <dgm:sp3d/>
+    <dgm:txPr/>
+    <dgm:style>
+      <a:lnRef idx="0">
+        <a:scrgbClr r="0" g="0" b="0"/>
+      </a:lnRef>
+      <a:fillRef idx="1">
+        <a:scrgbClr r="0" g="0" b="0"/>
+      </a:fillRef>
+      <a:effectRef idx="0">
+        <a:scrgbClr r="0" g="0" b="0"/>
+      </a:effectRef>
+      <a:fontRef idx="minor"/>
+    </dgm:style>
+  </dgm:styleLbl>
+  <dgm:styleLbl name="dkBgShp">
+    <dgm:scene3d>
+      <a:camera prst="orthographicFront"/>
+      <a:lightRig rig="threePt" dir="t"/>
+    </dgm:scene3d>
+    <dgm:sp3d/>
+    <dgm:txPr/>
+    <dgm:style>
+      <a:lnRef idx="0">
+        <a:scrgbClr r="0" g="0" b="0"/>
+      </a:lnRef>
+      <a:fillRef idx="1">
+        <a:scrgbClr r="0" g="0" b="0"/>
+      </a:fillRef>
+      <a:effectRef idx="0">
+        <a:scrgbClr r="0" g="0" b="0"/>
+      </a:effectRef>
+      <a:fontRef idx="minor"/>
+    </dgm:style>
+  </dgm:styleLbl>
+  <dgm:styleLbl name="trBgShp">
+    <dgm:scene3d>
+      <a:camera prst="orthographicFront"/>
+      <a:lightRig rig="threePt" dir="t"/>
+    </dgm:scene3d>
+    <dgm:sp3d/>
+    <dgm:txPr/>
+    <dgm:style>
+      <a:lnRef idx="0">
+        <a:scrgbClr r="0" g="0" b="0"/>
+      </a:lnRef>
+      <a:fillRef idx="1">
+        <a:scrgbClr r="0" g="0" b="0"/>
+      </a:fillRef>
+      <a:effectRef idx="0">
+        <a:scrgbClr r="0" g="0" b="0"/>
+      </a:effectRef>
+      <a:fontRef idx="minor"/>
+    </dgm:style>
+  </dgm:styleLbl>
+  <dgm:styleLbl name="fgShp">
+    <dgm:scene3d>
+      <a:camera prst="orthographicFront"/>
+      <a:lightRig rig="threePt" dir="t"/>
+    </dgm:scene3d>
+    <dgm:sp3d/>
+    <dgm:txPr/>
+    <dgm:style>
+      <a:lnRef idx="2">
+        <a:scrgbClr r="0" g="0" b="0"/>
+      </a:lnRef>
+      <a:fillRef idx="1">
+        <a:scrgbClr r="0" g="0" b="0"/>
+      </a:fillRef>
+      <a:effectRef idx="0">
+        <a:scrgbClr r="0" g="0" b="0"/>
+      </a:effectRef>
+      <a:fontRef idx="minor"/>
+    </dgm:style>
+  </dgm:styleLbl>
+  <dgm:styleLbl name="revTx">
+    <dgm:scene3d>
+      <a:camera prst="orthographicFront"/>
+      <a:lightRig rig="threePt" dir="t"/>
+    </dgm:scene3d>
+    <dgm:sp3d/>
+    <dgm:txPr/>
+    <dgm:style>
+      <a:lnRef idx="0">
+        <a:scrgbClr r="0" g="0" b="0"/>
+      </a:lnRef>
+      <a:fillRef idx="0">
+        <a:scrgbClr r="0" g="0" b="0"/>
+      </a:fillRef>
+      <a:effectRef idx="0">
+        <a:scrgbClr r="0" g="0" b="0"/>
+      </a:effectRef>
+      <a:fontRef idx="minor"/>
+    </dgm:style>
+  </dgm:styleLbl>
+</dgm:styleDef>
+</file>
+
+<file path=ppt/diagrams/quickStyle4.xml><?xml version="1.0" encoding="utf-8"?>
 <dgm:styleDef xmlns:dgm="http://schemas.openxmlformats.org/drawingml/2006/diagram" xmlns:a="http://schemas.openxmlformats.org/drawingml/2006/main" uniqueId="urn:microsoft.com/office/officeart/2005/8/quickstyle/simple1">
   <dgm:title val=""/>
   <dgm:desc val=""/>
@@ -8327,7 +10773,7 @@
           <a:p>
             <a:fld id="{00B92C5A-80A0-4C6E-9437-3D460B84558E}" type="datetimeFigureOut">
               <a:rPr lang="nl-BE" smtClean="0"/>
-              <a:t>4/07/2026</a:t>
+              <a:t>5/07/2026</a:t>
             </a:fld>
             <a:endParaRPr lang="nl-BE"/>
           </a:p>
@@ -8744,7 +11190,7 @@
           <a:p>
             <a:fld id="{00E43CE8-0ECF-46D5-95BF-B0947A229023}" type="datetimeFigureOut">
               <a:rPr lang="nl-BE" smtClean="0"/>
-              <a:t>4/07/2026</a:t>
+              <a:t>5/07/2026</a:t>
             </a:fld>
             <a:endParaRPr lang="nl-BE"/>
           </a:p>
@@ -8944,7 +11390,7 @@
           <a:p>
             <a:fld id="{00E43CE8-0ECF-46D5-95BF-B0947A229023}" type="datetimeFigureOut">
               <a:rPr lang="nl-BE" smtClean="0"/>
-              <a:t>4/07/2026</a:t>
+              <a:t>5/07/2026</a:t>
             </a:fld>
             <a:endParaRPr lang="nl-BE"/>
           </a:p>
@@ -9154,7 +11600,7 @@
           <a:p>
             <a:fld id="{00E43CE8-0ECF-46D5-95BF-B0947A229023}" type="datetimeFigureOut">
               <a:rPr lang="nl-BE" smtClean="0"/>
-              <a:t>4/07/2026</a:t>
+              <a:t>5/07/2026</a:t>
             </a:fld>
             <a:endParaRPr lang="nl-BE"/>
           </a:p>
@@ -9354,7 +11800,7 @@
           <a:p>
             <a:fld id="{00E43CE8-0ECF-46D5-95BF-B0947A229023}" type="datetimeFigureOut">
               <a:rPr lang="nl-BE" smtClean="0"/>
-              <a:t>4/07/2026</a:t>
+              <a:t>5/07/2026</a:t>
             </a:fld>
             <a:endParaRPr lang="nl-BE"/>
           </a:p>
@@ -9630,7 +12076,7 @@
           <a:p>
             <a:fld id="{00E43CE8-0ECF-46D5-95BF-B0947A229023}" type="datetimeFigureOut">
               <a:rPr lang="nl-BE" smtClean="0"/>
-              <a:t>4/07/2026</a:t>
+              <a:t>5/07/2026</a:t>
             </a:fld>
             <a:endParaRPr lang="nl-BE"/>
           </a:p>
@@ -9898,7 +12344,7 @@
           <a:p>
             <a:fld id="{00E43CE8-0ECF-46D5-95BF-B0947A229023}" type="datetimeFigureOut">
               <a:rPr lang="nl-BE" smtClean="0"/>
-              <a:t>4/07/2026</a:t>
+              <a:t>5/07/2026</a:t>
             </a:fld>
             <a:endParaRPr lang="nl-BE"/>
           </a:p>
@@ -10313,7 +12759,7 @@
           <a:p>
             <a:fld id="{00E43CE8-0ECF-46D5-95BF-B0947A229023}" type="datetimeFigureOut">
               <a:rPr lang="nl-BE" smtClean="0"/>
-              <a:t>4/07/2026</a:t>
+              <a:t>5/07/2026</a:t>
             </a:fld>
             <a:endParaRPr lang="nl-BE"/>
           </a:p>
@@ -10455,7 +12901,7 @@
           <a:p>
             <a:fld id="{00E43CE8-0ECF-46D5-95BF-B0947A229023}" type="datetimeFigureOut">
               <a:rPr lang="nl-BE" smtClean="0"/>
-              <a:t>4/07/2026</a:t>
+              <a:t>5/07/2026</a:t>
             </a:fld>
             <a:endParaRPr lang="nl-BE"/>
           </a:p>
@@ -10568,7 +13014,7 @@
           <a:p>
             <a:fld id="{00E43CE8-0ECF-46D5-95BF-B0947A229023}" type="datetimeFigureOut">
               <a:rPr lang="nl-BE" smtClean="0"/>
-              <a:t>4/07/2026</a:t>
+              <a:t>5/07/2026</a:t>
             </a:fld>
             <a:endParaRPr lang="nl-BE"/>
           </a:p>
@@ -10881,7 +13327,7 @@
           <a:p>
             <a:fld id="{00E43CE8-0ECF-46D5-95BF-B0947A229023}" type="datetimeFigureOut">
               <a:rPr lang="nl-BE" smtClean="0"/>
-              <a:t>4/07/2026</a:t>
+              <a:t>5/07/2026</a:t>
             </a:fld>
             <a:endParaRPr lang="nl-BE"/>
           </a:p>
@@ -11170,7 +13616,7 @@
           <a:p>
             <a:fld id="{00E43CE8-0ECF-46D5-95BF-B0947A229023}" type="datetimeFigureOut">
               <a:rPr lang="nl-BE" smtClean="0"/>
-              <a:t>4/07/2026</a:t>
+              <a:t>5/07/2026</a:t>
             </a:fld>
             <a:endParaRPr lang="nl-BE"/>
           </a:p>
@@ -11413,7 +13859,7 @@
           <a:p>
             <a:fld id="{00E43CE8-0ECF-46D5-95BF-B0947A229023}" type="datetimeFigureOut">
               <a:rPr lang="nl-BE" smtClean="0"/>
-              <a:t>4/07/2026</a:t>
+              <a:t>5/07/2026</a:t>
             </a:fld>
             <a:endParaRPr lang="nl-BE"/>
           </a:p>
@@ -13213,6 +15659,66 @@
       </p:grpSpPr>
       <p:graphicFrame>
         <p:nvGraphicFramePr>
+          <p:cNvPr id="4" name="Tijdelijke aanduiding voor inhoud 3">
+            <a:extLst>
+              <a:ext uri="{FF2B5EF4-FFF2-40B4-BE49-F238E27FC236}">
+                <a16:creationId xmlns:a16="http://schemas.microsoft.com/office/drawing/2014/main" id="{5B705D16-192B-C699-16F1-56A13C790616}"/>
+              </a:ext>
+            </a:extLst>
+          </p:cNvPr>
+          <p:cNvGraphicFramePr>
+            <a:graphicFrameLocks/>
+          </p:cNvGraphicFramePr>
+          <p:nvPr>
+            <p:extLst>
+              <p:ext uri="{D42A27DB-BD31-4B8C-83A1-F6EECF244321}">
+                <p14:modId xmlns:p14="http://schemas.microsoft.com/office/powerpoint/2010/main" val="3620044377"/>
+              </p:ext>
+            </p:extLst>
+          </p:nvPr>
+        </p:nvGraphicFramePr>
+        <p:xfrm>
+          <a:off x="2463969" y="925975"/>
+          <a:ext cx="7264062" cy="4626019"/>
+        </p:xfrm>
+        <a:graphic>
+          <a:graphicData uri="http://schemas.openxmlformats.org/drawingml/2006/diagram">
+            <dgm:relIds xmlns:dgm="http://schemas.openxmlformats.org/drawingml/2006/diagram" xmlns:r="http://schemas.openxmlformats.org/officeDocument/2006/relationships" r:dm="rId2" r:lo="rId3" r:qs="rId4" r:cs="rId5"/>
+          </a:graphicData>
+        </a:graphic>
+      </p:graphicFrame>
+    </p:spTree>
+    <p:extLst>
+      <p:ext uri="{BB962C8B-B14F-4D97-AF65-F5344CB8AC3E}">
+        <p14:creationId xmlns:p14="http://schemas.microsoft.com/office/powerpoint/2010/main" val="1810863273"/>
+      </p:ext>
+    </p:extLst>
+  </p:cSld>
+  <p:clrMapOvr>
+    <a:masterClrMapping/>
+  </p:clrMapOvr>
+</p:sld>
+</file>
+
+<file path=ppt/slides/slide5.xml><?xml version="1.0" encoding="utf-8"?>
+<p:sld xmlns:a="http://schemas.openxmlformats.org/drawingml/2006/main" xmlns:r="http://schemas.openxmlformats.org/officeDocument/2006/relationships" xmlns:p="http://schemas.openxmlformats.org/presentationml/2006/main">
+  <p:cSld>
+    <p:spTree>
+      <p:nvGrpSpPr>
+        <p:cNvPr id="1" name=""/>
+        <p:cNvGrpSpPr/>
+        <p:nvPr/>
+      </p:nvGrpSpPr>
+      <p:grpSpPr>
+        <a:xfrm>
+          <a:off x="0" y="0"/>
+          <a:ext cx="0" cy="0"/>
+          <a:chOff x="0" y="0"/>
+          <a:chExt cx="0" cy="0"/>
+        </a:xfrm>
+      </p:grpSpPr>
+      <p:graphicFrame>
+        <p:nvGraphicFramePr>
           <p:cNvPr id="7" name="Tijdelijke aanduiding voor inhoud 3">
             <a:extLst>
               <a:ext uri="{FF2B5EF4-FFF2-40B4-BE49-F238E27FC236}">
@@ -13227,7 +15733,7 @@
             <p:ph idx="1"/>
             <p:extLst>
               <p:ext uri="{D42A27DB-BD31-4B8C-83A1-F6EECF244321}">
-                <p14:modId xmlns:p14="http://schemas.microsoft.com/office/powerpoint/2010/main" val="666099895"/>
+                <p14:modId xmlns:p14="http://schemas.microsoft.com/office/powerpoint/2010/main" val="48661341"/>
               </p:ext>
             </p:extLst>
           </p:nvPr>
@@ -13430,7 +15936,7 @@
             <a:pPr algn="ctr"/>
             <a:r>
               <a:rPr lang="en-US" sz="1600" b="1" dirty="0"/>
-              <a:t>Reorder strokes in queues</a:t>
+              <a:t>Sort strokes into color buckets</a:t>
             </a:r>
             <a:endParaRPr lang="nl-BE" sz="1600" b="1" dirty="0"/>
           </a:p>
@@ -13655,10 +16161,10 @@
         </p:nvGrpSpPr>
         <p:grpSpPr>
           <a:xfrm>
-            <a:off x="5075744" y="4982165"/>
-            <a:ext cx="1020256" cy="720324"/>
-            <a:chOff x="5075744" y="4958080"/>
-            <a:chExt cx="1020256" cy="720324"/>
+            <a:off x="4976096" y="6373857"/>
+            <a:ext cx="1020256" cy="390525"/>
+            <a:chOff x="5075744" y="5287879"/>
+            <a:chExt cx="1020256" cy="390525"/>
           </a:xfrm>
         </p:grpSpPr>
         <p:sp>
@@ -13674,7 +16180,7 @@
             <p:nvPr/>
           </p:nvSpPr>
           <p:spPr>
-            <a:xfrm rot="5400000">
+            <a:xfrm rot="16200000">
               <a:off x="5390609" y="4973014"/>
               <a:ext cx="390525" cy="1020256"/>
             </a:xfrm>
@@ -13720,8 +16226,8 @@
           </p:nvSpPr>
           <p:spPr>
             <a:xfrm>
-              <a:off x="5085809" y="4958080"/>
-              <a:ext cx="1010191" cy="369332"/>
+              <a:off x="5463738" y="5298476"/>
+              <a:ext cx="221782" cy="369332"/>
             </a:xfrm>
             <a:prstGeom prst="rect">
               <a:avLst/>
@@ -13744,219 +16250,6 @@
           </p:txBody>
         </p:sp>
       </p:grpSp>
-      <p:grpSp>
-        <p:nvGrpSpPr>
-          <p:cNvPr id="30" name="Groep 29">
-            <a:extLst>
-              <a:ext uri="{FF2B5EF4-FFF2-40B4-BE49-F238E27FC236}">
-                <a16:creationId xmlns:a16="http://schemas.microsoft.com/office/drawing/2014/main" id="{B0EEFAC2-652A-939B-D092-1B291D1724DD}"/>
-              </a:ext>
-            </a:extLst>
-          </p:cNvPr>
-          <p:cNvGrpSpPr/>
-          <p:nvPr/>
-        </p:nvGrpSpPr>
-        <p:grpSpPr>
-          <a:xfrm>
-            <a:off x="7779855" y="4982165"/>
-            <a:ext cx="1020256" cy="720324"/>
-            <a:chOff x="5075744" y="4958080"/>
-            <a:chExt cx="1020256" cy="720324"/>
-          </a:xfrm>
-        </p:grpSpPr>
-        <p:sp>
-          <p:nvSpPr>
-            <p:cNvPr id="31" name="Vierkante haak links 30">
-              <a:extLst>
-                <a:ext uri="{FF2B5EF4-FFF2-40B4-BE49-F238E27FC236}">
-                  <a16:creationId xmlns:a16="http://schemas.microsoft.com/office/drawing/2014/main" id="{D5882D11-F42C-17FA-1116-DA7FF909A572}"/>
-                </a:ext>
-              </a:extLst>
-            </p:cNvPr>
-            <p:cNvSpPr/>
-            <p:nvPr/>
-          </p:nvSpPr>
-          <p:spPr>
-            <a:xfrm rot="5400000">
-              <a:off x="5390609" y="4973014"/>
-              <a:ext cx="390525" cy="1020256"/>
-            </a:xfrm>
-            <a:prstGeom prst="leftBracket">
-              <a:avLst/>
-            </a:prstGeom>
-            <a:ln w="38100">
-              <a:solidFill>
-                <a:srgbClr val="FF0000"/>
-              </a:solidFill>
-            </a:ln>
-          </p:spPr>
-          <p:style>
-            <a:lnRef idx="2">
-              <a:schemeClr val="accent1"/>
-            </a:lnRef>
-            <a:fillRef idx="0">
-              <a:schemeClr val="accent1"/>
-            </a:fillRef>
-            <a:effectRef idx="1">
-              <a:schemeClr val="accent1"/>
-            </a:effectRef>
-            <a:fontRef idx="minor">
-              <a:schemeClr val="tx1"/>
-            </a:fontRef>
-          </p:style>
-          <p:txBody>
-            <a:bodyPr rtlCol="0" anchor="ctr"/>
-            <a:lstStyle/>
-            <a:p>
-              <a:pPr algn="ctr"/>
-              <a:endParaRPr lang="nl-BE"/>
-            </a:p>
-          </p:txBody>
-        </p:sp>
-        <p:sp>
-          <p:nvSpPr>
-            <p:cNvPr id="32" name="Tekstvak 31">
-              <a:extLst>
-                <a:ext uri="{FF2B5EF4-FFF2-40B4-BE49-F238E27FC236}">
-                  <a16:creationId xmlns:a16="http://schemas.microsoft.com/office/drawing/2014/main" id="{82567BE4-EA7E-E4FF-D6F4-95C4C54E4B12}"/>
-                </a:ext>
-              </a:extLst>
-            </p:cNvPr>
-            <p:cNvSpPr txBox="1"/>
-            <p:nvPr/>
-          </p:nvSpPr>
-          <p:spPr>
-            <a:xfrm>
-              <a:off x="5085809" y="4958080"/>
-              <a:ext cx="1010191" cy="369332"/>
-            </a:xfrm>
-            <a:prstGeom prst="rect">
-              <a:avLst/>
-            </a:prstGeom>
-            <a:noFill/>
-          </p:spPr>
-          <p:txBody>
-            <a:bodyPr wrap="square" rtlCol="0">
-              <a:spAutoFit/>
-            </a:bodyPr>
-            <a:lstStyle/>
-            <a:p>
-              <a:pPr algn="ctr"/>
-              <a:r>
-                <a:rPr lang="en-US" dirty="0"/>
-                <a:t>2</a:t>
-              </a:r>
-              <a:endParaRPr lang="nl-BE" dirty="0"/>
-            </a:p>
-          </p:txBody>
-        </p:sp>
-      </p:grpSp>
-      <p:grpSp>
-        <p:nvGrpSpPr>
-          <p:cNvPr id="33" name="Groep 32">
-            <a:extLst>
-              <a:ext uri="{FF2B5EF4-FFF2-40B4-BE49-F238E27FC236}">
-                <a16:creationId xmlns:a16="http://schemas.microsoft.com/office/drawing/2014/main" id="{D3ADB382-D1EE-6538-9D5C-778F045DE14E}"/>
-              </a:ext>
-            </a:extLst>
-          </p:cNvPr>
-          <p:cNvGrpSpPr/>
-          <p:nvPr/>
-        </p:nvGrpSpPr>
-        <p:grpSpPr>
-          <a:xfrm>
-            <a:off x="10483965" y="4982165"/>
-            <a:ext cx="1020256" cy="720324"/>
-            <a:chOff x="5075744" y="4958080"/>
-            <a:chExt cx="1020256" cy="720324"/>
-          </a:xfrm>
-        </p:grpSpPr>
-        <p:sp>
-          <p:nvSpPr>
-            <p:cNvPr id="34" name="Vierkante haak links 33">
-              <a:extLst>
-                <a:ext uri="{FF2B5EF4-FFF2-40B4-BE49-F238E27FC236}">
-                  <a16:creationId xmlns:a16="http://schemas.microsoft.com/office/drawing/2014/main" id="{179489B8-927B-8838-D89F-C3F344E1CC45}"/>
-                </a:ext>
-              </a:extLst>
-            </p:cNvPr>
-            <p:cNvSpPr/>
-            <p:nvPr/>
-          </p:nvSpPr>
-          <p:spPr>
-            <a:xfrm rot="5400000">
-              <a:off x="5390609" y="4973014"/>
-              <a:ext cx="390525" cy="1020256"/>
-            </a:xfrm>
-            <a:prstGeom prst="leftBracket">
-              <a:avLst/>
-            </a:prstGeom>
-            <a:ln w="38100">
-              <a:solidFill>
-                <a:schemeClr val="accent6"/>
-              </a:solidFill>
-            </a:ln>
-          </p:spPr>
-          <p:style>
-            <a:lnRef idx="2">
-              <a:schemeClr val="accent1"/>
-            </a:lnRef>
-            <a:fillRef idx="0">
-              <a:schemeClr val="accent1"/>
-            </a:fillRef>
-            <a:effectRef idx="1">
-              <a:schemeClr val="accent1"/>
-            </a:effectRef>
-            <a:fontRef idx="minor">
-              <a:schemeClr val="tx1"/>
-            </a:fontRef>
-          </p:style>
-          <p:txBody>
-            <a:bodyPr rtlCol="0" anchor="ctr"/>
-            <a:lstStyle/>
-            <a:p>
-              <a:pPr algn="ctr"/>
-              <a:endParaRPr lang="nl-BE" dirty="0"/>
-            </a:p>
-          </p:txBody>
-        </p:sp>
-        <p:sp>
-          <p:nvSpPr>
-            <p:cNvPr id="35" name="Tekstvak 34">
-              <a:extLst>
-                <a:ext uri="{FF2B5EF4-FFF2-40B4-BE49-F238E27FC236}">
-                  <a16:creationId xmlns:a16="http://schemas.microsoft.com/office/drawing/2014/main" id="{1655254B-DB20-02D2-DFDD-C020D7B49FFA}"/>
-                </a:ext>
-              </a:extLst>
-            </p:cNvPr>
-            <p:cNvSpPr txBox="1"/>
-            <p:nvPr/>
-          </p:nvSpPr>
-          <p:spPr>
-            <a:xfrm>
-              <a:off x="5085809" y="4958080"/>
-              <a:ext cx="1010191" cy="369332"/>
-            </a:xfrm>
-            <a:prstGeom prst="rect">
-              <a:avLst/>
-            </a:prstGeom>
-            <a:noFill/>
-          </p:spPr>
-          <p:txBody>
-            <a:bodyPr wrap="square" rtlCol="0">
-              <a:spAutoFit/>
-            </a:bodyPr>
-            <a:lstStyle/>
-            <a:p>
-              <a:pPr algn="ctr"/>
-              <a:r>
-                <a:rPr lang="en-US" dirty="0"/>
-                <a:t>3</a:t>
-              </a:r>
-            </a:p>
-          </p:txBody>
-        </p:sp>
-      </p:grpSp>
       <p:cxnSp>
         <p:nvCxnSpPr>
           <p:cNvPr id="40" name="Rechte verbindingslijn met pijl 39">
@@ -13966,13 +16259,15 @@
               </a:ext>
             </a:extLst>
           </p:cNvPr>
-          <p:cNvCxnSpPr/>
+          <p:cNvCxnSpPr>
+            <a:cxnSpLocks/>
+          </p:cNvCxnSpPr>
           <p:nvPr/>
         </p:nvCxnSpPr>
         <p:spPr>
           <a:xfrm>
             <a:off x="5510893" y="4425043"/>
-            <a:ext cx="0" cy="1277447"/>
+            <a:ext cx="0" cy="1804307"/>
           </a:xfrm>
           <a:prstGeom prst="straightConnector1">
             <a:avLst/>
@@ -14007,13 +16302,14 @@
           </p:cNvPr>
           <p:cNvCxnSpPr>
             <a:cxnSpLocks/>
+            <a:endCxn id="9" idx="0"/>
           </p:cNvCxnSpPr>
           <p:nvPr/>
         </p:nvCxnSpPr>
         <p:spPr>
           <a:xfrm>
             <a:off x="6831332" y="4343441"/>
-            <a:ext cx="1300297" cy="1163786"/>
+            <a:ext cx="1440748" cy="2041013"/>
           </a:xfrm>
           <a:prstGeom prst="straightConnector1">
             <a:avLst/>
@@ -14057,7 +16353,7 @@
         <p:spPr>
           <a:xfrm>
             <a:off x="7920748" y="4258552"/>
-            <a:ext cx="3011231" cy="1303348"/>
+            <a:ext cx="2939341" cy="2112024"/>
           </a:xfrm>
           <a:prstGeom prst="straightConnector1">
             <a:avLst/>
@@ -14169,10 +16465,1372 @@
           </a:fontRef>
         </p:style>
       </p:cxnSp>
+      <p:grpSp>
+        <p:nvGrpSpPr>
+          <p:cNvPr id="3" name="Groep 2">
+            <a:extLst>
+              <a:ext uri="{FF2B5EF4-FFF2-40B4-BE49-F238E27FC236}">
+                <a16:creationId xmlns:a16="http://schemas.microsoft.com/office/drawing/2014/main" id="{294CF237-1F89-E849-7633-5FE0E01C8234}"/>
+              </a:ext>
+            </a:extLst>
+          </p:cNvPr>
+          <p:cNvGrpSpPr/>
+          <p:nvPr/>
+        </p:nvGrpSpPr>
+        <p:grpSpPr>
+          <a:xfrm>
+            <a:off x="10570294" y="6373857"/>
+            <a:ext cx="1020256" cy="390525"/>
+            <a:chOff x="5075744" y="5287879"/>
+            <a:chExt cx="1020256" cy="390525"/>
+          </a:xfrm>
+        </p:grpSpPr>
+        <p:sp>
+          <p:nvSpPr>
+            <p:cNvPr id="4" name="Vierkante haak links 3">
+              <a:extLst>
+                <a:ext uri="{FF2B5EF4-FFF2-40B4-BE49-F238E27FC236}">
+                  <a16:creationId xmlns:a16="http://schemas.microsoft.com/office/drawing/2014/main" id="{BC4C9615-E13A-5149-3CA9-E23419EC9DCB}"/>
+                </a:ext>
+              </a:extLst>
+            </p:cNvPr>
+            <p:cNvSpPr/>
+            <p:nvPr/>
+          </p:nvSpPr>
+          <p:spPr>
+            <a:xfrm rot="16200000">
+              <a:off x="5390609" y="4973014"/>
+              <a:ext cx="390525" cy="1020256"/>
+            </a:xfrm>
+            <a:prstGeom prst="leftBracket">
+              <a:avLst/>
+            </a:prstGeom>
+            <a:ln w="38100">
+              <a:solidFill>
+                <a:schemeClr val="accent6"/>
+              </a:solidFill>
+            </a:ln>
+          </p:spPr>
+          <p:style>
+            <a:lnRef idx="2">
+              <a:schemeClr val="accent1"/>
+            </a:lnRef>
+            <a:fillRef idx="0">
+              <a:schemeClr val="accent1"/>
+            </a:fillRef>
+            <a:effectRef idx="1">
+              <a:schemeClr val="accent1"/>
+            </a:effectRef>
+            <a:fontRef idx="minor">
+              <a:schemeClr val="tx1"/>
+            </a:fontRef>
+          </p:style>
+          <p:txBody>
+            <a:bodyPr rtlCol="0" anchor="ctr"/>
+            <a:lstStyle/>
+            <a:p>
+              <a:pPr algn="ctr"/>
+              <a:endParaRPr lang="nl-BE" dirty="0"/>
+            </a:p>
+          </p:txBody>
+        </p:sp>
+        <p:sp>
+          <p:nvSpPr>
+            <p:cNvPr id="5" name="Tekstvak 4">
+              <a:extLst>
+                <a:ext uri="{FF2B5EF4-FFF2-40B4-BE49-F238E27FC236}">
+                  <a16:creationId xmlns:a16="http://schemas.microsoft.com/office/drawing/2014/main" id="{4DAD97ED-D3C6-9F76-64F4-1CD2B2E5B3C4}"/>
+                </a:ext>
+              </a:extLst>
+            </p:cNvPr>
+            <p:cNvSpPr txBox="1"/>
+            <p:nvPr/>
+          </p:nvSpPr>
+          <p:spPr>
+            <a:xfrm>
+              <a:off x="5506434" y="5298476"/>
+              <a:ext cx="136390" cy="369332"/>
+            </a:xfrm>
+            <a:prstGeom prst="rect">
+              <a:avLst/>
+            </a:prstGeom>
+            <a:noFill/>
+          </p:spPr>
+          <p:txBody>
+            <a:bodyPr wrap="square" rtlCol="0">
+              <a:spAutoFit/>
+            </a:bodyPr>
+            <a:lstStyle/>
+            <a:p>
+              <a:pPr algn="ctr"/>
+              <a:r>
+                <a:rPr lang="en-US" dirty="0"/>
+                <a:t>3</a:t>
+              </a:r>
+              <a:endParaRPr lang="nl-BE" dirty="0"/>
+            </a:p>
+          </p:txBody>
+        </p:sp>
+      </p:grpSp>
+      <p:grpSp>
+        <p:nvGrpSpPr>
+          <p:cNvPr id="6" name="Groep 5">
+            <a:extLst>
+              <a:ext uri="{FF2B5EF4-FFF2-40B4-BE49-F238E27FC236}">
+                <a16:creationId xmlns:a16="http://schemas.microsoft.com/office/drawing/2014/main" id="{3C12D316-9BC1-4079-FA90-649C99F4BB87}"/>
+              </a:ext>
+            </a:extLst>
+          </p:cNvPr>
+          <p:cNvGrpSpPr/>
+          <p:nvPr/>
+        </p:nvGrpSpPr>
+        <p:grpSpPr>
+          <a:xfrm>
+            <a:off x="7773195" y="6373857"/>
+            <a:ext cx="1020256" cy="390525"/>
+            <a:chOff x="5075744" y="5287879"/>
+            <a:chExt cx="1020256" cy="390525"/>
+          </a:xfrm>
+        </p:grpSpPr>
+        <p:sp>
+          <p:nvSpPr>
+            <p:cNvPr id="8" name="Vierkante haak links 7">
+              <a:extLst>
+                <a:ext uri="{FF2B5EF4-FFF2-40B4-BE49-F238E27FC236}">
+                  <a16:creationId xmlns:a16="http://schemas.microsoft.com/office/drawing/2014/main" id="{9EA9D016-C17D-725F-7711-F253E7E7C2D5}"/>
+                </a:ext>
+              </a:extLst>
+            </p:cNvPr>
+            <p:cNvSpPr/>
+            <p:nvPr/>
+          </p:nvSpPr>
+          <p:spPr>
+            <a:xfrm rot="16200000">
+              <a:off x="5390609" y="4973014"/>
+              <a:ext cx="390525" cy="1020256"/>
+            </a:xfrm>
+            <a:prstGeom prst="leftBracket">
+              <a:avLst/>
+            </a:prstGeom>
+            <a:ln w="38100">
+              <a:solidFill>
+                <a:srgbClr val="FF0000"/>
+              </a:solidFill>
+            </a:ln>
+          </p:spPr>
+          <p:style>
+            <a:lnRef idx="2">
+              <a:schemeClr val="accent1"/>
+            </a:lnRef>
+            <a:fillRef idx="0">
+              <a:schemeClr val="accent1"/>
+            </a:fillRef>
+            <a:effectRef idx="1">
+              <a:schemeClr val="accent1"/>
+            </a:effectRef>
+            <a:fontRef idx="minor">
+              <a:schemeClr val="tx1"/>
+            </a:fontRef>
+          </p:style>
+          <p:txBody>
+            <a:bodyPr rtlCol="0" anchor="ctr"/>
+            <a:lstStyle/>
+            <a:p>
+              <a:pPr algn="ctr"/>
+              <a:endParaRPr lang="nl-BE" dirty="0"/>
+            </a:p>
+          </p:txBody>
+        </p:sp>
+        <p:sp>
+          <p:nvSpPr>
+            <p:cNvPr id="9" name="Tekstvak 8">
+              <a:extLst>
+                <a:ext uri="{FF2B5EF4-FFF2-40B4-BE49-F238E27FC236}">
+                  <a16:creationId xmlns:a16="http://schemas.microsoft.com/office/drawing/2014/main" id="{4A255E26-6733-B3CC-8584-B090B268EDE3}"/>
+                </a:ext>
+              </a:extLst>
+            </p:cNvPr>
+            <p:cNvSpPr txBox="1"/>
+            <p:nvPr/>
+          </p:nvSpPr>
+          <p:spPr>
+            <a:xfrm>
+              <a:off x="5489544" y="5298476"/>
+              <a:ext cx="170170" cy="369332"/>
+            </a:xfrm>
+            <a:prstGeom prst="rect">
+              <a:avLst/>
+            </a:prstGeom>
+            <a:noFill/>
+          </p:spPr>
+          <p:txBody>
+            <a:bodyPr wrap="square" rtlCol="0">
+              <a:spAutoFit/>
+            </a:bodyPr>
+            <a:lstStyle/>
+            <a:p>
+              <a:pPr algn="ctr"/>
+              <a:r>
+                <a:rPr lang="en-US" dirty="0"/>
+                <a:t>2</a:t>
+              </a:r>
+              <a:endParaRPr lang="nl-BE" dirty="0"/>
+            </a:p>
+          </p:txBody>
+        </p:sp>
+      </p:grpSp>
+      <p:sp>
+        <p:nvSpPr>
+          <p:cNvPr id="19" name="Tekstvak 18">
+            <a:extLst>
+              <a:ext uri="{FF2B5EF4-FFF2-40B4-BE49-F238E27FC236}">
+                <a16:creationId xmlns:a16="http://schemas.microsoft.com/office/drawing/2014/main" id="{97403517-6E7A-FDB0-15C1-870BF09C5198}"/>
+              </a:ext>
+            </a:extLst>
+          </p:cNvPr>
+          <p:cNvSpPr txBox="1"/>
+          <p:nvPr/>
+        </p:nvSpPr>
+        <p:spPr>
+          <a:xfrm>
+            <a:off x="3506471" y="774120"/>
+            <a:ext cx="5179059" cy="461665"/>
+          </a:xfrm>
+          <a:prstGeom prst="rect">
+            <a:avLst/>
+          </a:prstGeom>
+          <a:noFill/>
+        </p:spPr>
+        <p:txBody>
+          <a:bodyPr wrap="square" rtlCol="0">
+            <a:spAutoFit/>
+          </a:bodyPr>
+          <a:lstStyle/>
+          <a:p>
+            <a:pPr algn="ctr"/>
+            <a:r>
+              <a:rPr lang="en-US" sz="2400" b="1" dirty="0"/>
+              <a:t>Bucket Partitioning</a:t>
+            </a:r>
+            <a:endParaRPr lang="nl-BE" sz="2400" b="1" dirty="0"/>
+          </a:p>
+        </p:txBody>
+      </p:sp>
     </p:spTree>
     <p:extLst>
       <p:ext uri="{BB962C8B-B14F-4D97-AF65-F5344CB8AC3E}">
         <p14:creationId xmlns:p14="http://schemas.microsoft.com/office/powerpoint/2010/main" val="1996057303"/>
+      </p:ext>
+    </p:extLst>
+  </p:cSld>
+  <p:clrMapOvr>
+    <a:masterClrMapping/>
+  </p:clrMapOvr>
+</p:sld>
+</file>
+
+<file path=ppt/slides/slide6.xml><?xml version="1.0" encoding="utf-8"?>
+<p:sld xmlns:a="http://schemas.openxmlformats.org/drawingml/2006/main" xmlns:r="http://schemas.openxmlformats.org/officeDocument/2006/relationships" xmlns:p="http://schemas.openxmlformats.org/presentationml/2006/main">
+  <p:cSld>
+    <p:spTree>
+      <p:nvGrpSpPr>
+        <p:cNvPr id="1" name="">
+          <a:extLst>
+            <a:ext uri="{FF2B5EF4-FFF2-40B4-BE49-F238E27FC236}">
+              <a16:creationId xmlns:a16="http://schemas.microsoft.com/office/drawing/2014/main" id="{2592C0A3-48FE-64AE-5047-572D57D6DA98}"/>
+            </a:ext>
+          </a:extLst>
+        </p:cNvPr>
+        <p:cNvGrpSpPr/>
+        <p:nvPr/>
+      </p:nvGrpSpPr>
+      <p:grpSpPr>
+        <a:xfrm>
+          <a:off x="0" y="0"/>
+          <a:ext cx="0" cy="0"/>
+          <a:chOff x="0" y="0"/>
+          <a:chExt cx="0" cy="0"/>
+        </a:xfrm>
+      </p:grpSpPr>
+      <p:sp>
+        <p:nvSpPr>
+          <p:cNvPr id="13" name="Tekstvak 12">
+            <a:extLst>
+              <a:ext uri="{FF2B5EF4-FFF2-40B4-BE49-F238E27FC236}">
+                <a16:creationId xmlns:a16="http://schemas.microsoft.com/office/drawing/2014/main" id="{A60746AB-AA81-5A21-37F2-31B3509F8B40}"/>
+              </a:ext>
+            </a:extLst>
+          </p:cNvPr>
+          <p:cNvSpPr txBox="1"/>
+          <p:nvPr/>
+        </p:nvSpPr>
+        <p:spPr>
+          <a:xfrm>
+            <a:off x="3506469" y="184761"/>
+            <a:ext cx="5179059" cy="461665"/>
+          </a:xfrm>
+          <a:prstGeom prst="rect">
+            <a:avLst/>
+          </a:prstGeom>
+          <a:noFill/>
+        </p:spPr>
+        <p:txBody>
+          <a:bodyPr wrap="square" rtlCol="0">
+            <a:spAutoFit/>
+          </a:bodyPr>
+          <a:lstStyle/>
+          <a:p>
+            <a:pPr algn="ctr"/>
+            <a:r>
+              <a:rPr lang="en-US" sz="2400" b="1" dirty="0"/>
+              <a:t>Bucket Ordering</a:t>
+            </a:r>
+            <a:endParaRPr lang="nl-BE" sz="2400" b="1" dirty="0"/>
+          </a:p>
+        </p:txBody>
+      </p:sp>
+      <p:graphicFrame>
+        <p:nvGraphicFramePr>
+          <p:cNvPr id="21" name="Tabel 20">
+            <a:extLst>
+              <a:ext uri="{FF2B5EF4-FFF2-40B4-BE49-F238E27FC236}">
+                <a16:creationId xmlns:a16="http://schemas.microsoft.com/office/drawing/2014/main" id="{51DA7216-B1F8-3E83-1F3E-A91CE63C7C3C}"/>
+              </a:ext>
+            </a:extLst>
+          </p:cNvPr>
+          <p:cNvGraphicFramePr>
+            <a:graphicFrameLocks noGrp="1"/>
+          </p:cNvGraphicFramePr>
+          <p:nvPr>
+            <p:extLst>
+              <p:ext uri="{D42A27DB-BD31-4B8C-83A1-F6EECF244321}">
+                <p14:modId xmlns:p14="http://schemas.microsoft.com/office/powerpoint/2010/main" val="4014710366"/>
+              </p:ext>
+            </p:extLst>
+          </p:nvPr>
+        </p:nvGraphicFramePr>
+        <p:xfrm>
+          <a:off x="1400514" y="3251990"/>
+          <a:ext cx="9390972" cy="3431329"/>
+        </p:xfrm>
+        <a:graphic>
+          <a:graphicData uri="http://schemas.openxmlformats.org/drawingml/2006/table">
+            <a:tbl>
+              <a:tblPr firstRow="1" bandRow="1">
+                <a:tableStyleId>{5C22544A-7EE6-4342-B048-85BDC9FD1C3A}</a:tableStyleId>
+              </a:tblPr>
+              <a:tblGrid>
+                <a:gridCol w="3130324">
+                  <a:extLst>
+                    <a:ext uri="{9D8B030D-6E8A-4147-A177-3AD203B41FA5}">
+                      <a16:colId xmlns:a16="http://schemas.microsoft.com/office/drawing/2014/main" val="1450405179"/>
+                    </a:ext>
+                  </a:extLst>
+                </a:gridCol>
+                <a:gridCol w="3130324">
+                  <a:extLst>
+                    <a:ext uri="{9D8B030D-6E8A-4147-A177-3AD203B41FA5}">
+                      <a16:colId xmlns:a16="http://schemas.microsoft.com/office/drawing/2014/main" val="628484222"/>
+                    </a:ext>
+                  </a:extLst>
+                </a:gridCol>
+                <a:gridCol w="3130324">
+                  <a:extLst>
+                    <a:ext uri="{9D8B030D-6E8A-4147-A177-3AD203B41FA5}">
+                      <a16:colId xmlns:a16="http://schemas.microsoft.com/office/drawing/2014/main" val="1958657008"/>
+                    </a:ext>
+                  </a:extLst>
+                </a:gridCol>
+              </a:tblGrid>
+              <a:tr h="534227">
+                <a:tc>
+                  <a:txBody>
+                    <a:bodyPr/>
+                    <a:lstStyle/>
+                    <a:p>
+                      <a:r>
+                        <a:rPr lang="en-US" dirty="0"/>
+                        <a:t>Queue 1</a:t>
+                      </a:r>
+                      <a:endParaRPr lang="nl-BE" dirty="0"/>
+                    </a:p>
+                  </a:txBody>
+                  <a:tcPr/>
+                </a:tc>
+                <a:tc>
+                  <a:txBody>
+                    <a:bodyPr/>
+                    <a:lstStyle/>
+                    <a:p>
+                      <a:pPr marL="0" marR="0" lvl="0" indent="0" algn="l" defTabSz="914400" rtl="0" eaLnBrk="1" fontAlgn="auto" latinLnBrk="0" hangingPunct="1">
+                        <a:lnSpc>
+                          <a:spcPct val="100000"/>
+                        </a:lnSpc>
+                        <a:spcBef>
+                          <a:spcPts val="0"/>
+                        </a:spcBef>
+                        <a:spcAft>
+                          <a:spcPts val="0"/>
+                        </a:spcAft>
+                        <a:buClrTx/>
+                        <a:buSzTx/>
+                        <a:buFontTx/>
+                        <a:buNone/>
+                        <a:tabLst/>
+                        <a:defRPr/>
+                      </a:pPr>
+                      <a:r>
+                        <a:rPr lang="en-US" dirty="0"/>
+                        <a:t>Queue 2</a:t>
+                      </a:r>
+                      <a:endParaRPr lang="nl-BE" dirty="0"/>
+                    </a:p>
+                  </a:txBody>
+                  <a:tcPr/>
+                </a:tc>
+                <a:tc>
+                  <a:txBody>
+                    <a:bodyPr/>
+                    <a:lstStyle/>
+                    <a:p>
+                      <a:pPr marL="0" marR="0" lvl="0" indent="0" algn="l" defTabSz="914400" rtl="0" eaLnBrk="1" fontAlgn="auto" latinLnBrk="0" hangingPunct="1">
+                        <a:lnSpc>
+                          <a:spcPct val="100000"/>
+                        </a:lnSpc>
+                        <a:spcBef>
+                          <a:spcPts val="0"/>
+                        </a:spcBef>
+                        <a:spcAft>
+                          <a:spcPts val="0"/>
+                        </a:spcAft>
+                        <a:buClrTx/>
+                        <a:buSzTx/>
+                        <a:buFontTx/>
+                        <a:buNone/>
+                        <a:tabLst/>
+                        <a:defRPr/>
+                      </a:pPr>
+                      <a:r>
+                        <a:rPr lang="en-US" dirty="0"/>
+                        <a:t>Queue 3</a:t>
+                      </a:r>
+                      <a:endParaRPr lang="nl-BE" dirty="0"/>
+                    </a:p>
+                  </a:txBody>
+                  <a:tcPr/>
+                </a:tc>
+                <a:extLst>
+                  <a:ext uri="{0D108BD9-81ED-4DB2-BD59-A6C34878D82A}">
+                    <a16:rowId xmlns:a16="http://schemas.microsoft.com/office/drawing/2014/main" val="2750164555"/>
+                  </a:ext>
+                </a:extLst>
+              </a:tr>
+              <a:tr h="2897102">
+                <a:tc>
+                  <a:txBody>
+                    <a:bodyPr/>
+                    <a:lstStyle/>
+                    <a:p>
+                      <a:endParaRPr lang="nl-BE"/>
+                    </a:p>
+                  </a:txBody>
+                  <a:tcPr/>
+                </a:tc>
+                <a:tc>
+                  <a:txBody>
+                    <a:bodyPr/>
+                    <a:lstStyle/>
+                    <a:p>
+                      <a:endParaRPr lang="nl-BE"/>
+                    </a:p>
+                  </a:txBody>
+                  <a:tcPr/>
+                </a:tc>
+                <a:tc>
+                  <a:txBody>
+                    <a:bodyPr/>
+                    <a:lstStyle/>
+                    <a:p>
+                      <a:endParaRPr lang="nl-BE" dirty="0"/>
+                    </a:p>
+                  </a:txBody>
+                  <a:tcPr/>
+                </a:tc>
+                <a:extLst>
+                  <a:ext uri="{0D108BD9-81ED-4DB2-BD59-A6C34878D82A}">
+                    <a16:rowId xmlns:a16="http://schemas.microsoft.com/office/drawing/2014/main" val="3299396156"/>
+                  </a:ext>
+                </a:extLst>
+              </a:tr>
+            </a:tbl>
+          </a:graphicData>
+        </a:graphic>
+      </p:graphicFrame>
+      <p:grpSp>
+        <p:nvGrpSpPr>
+          <p:cNvPr id="51" name="Groep 50">
+            <a:extLst>
+              <a:ext uri="{FF2B5EF4-FFF2-40B4-BE49-F238E27FC236}">
+                <a16:creationId xmlns:a16="http://schemas.microsoft.com/office/drawing/2014/main" id="{902F70D0-9432-5E78-FA4A-7F39A2A454E1}"/>
+              </a:ext>
+            </a:extLst>
+          </p:cNvPr>
+          <p:cNvGrpSpPr/>
+          <p:nvPr/>
+        </p:nvGrpSpPr>
+        <p:grpSpPr>
+          <a:xfrm>
+            <a:off x="970068" y="774121"/>
+            <a:ext cx="9408373" cy="1083772"/>
+            <a:chOff x="119873" y="258856"/>
+            <a:chExt cx="11092923" cy="2114300"/>
+          </a:xfrm>
+        </p:grpSpPr>
+        <p:sp>
+          <p:nvSpPr>
+            <p:cNvPr id="18" name="Rechthoek 17">
+              <a:extLst>
+                <a:ext uri="{FF2B5EF4-FFF2-40B4-BE49-F238E27FC236}">
+                  <a16:creationId xmlns:a16="http://schemas.microsoft.com/office/drawing/2014/main" id="{11009105-671D-C14A-7B3D-908C1CDEEC9C}"/>
+                </a:ext>
+              </a:extLst>
+            </p:cNvPr>
+            <p:cNvSpPr/>
+            <p:nvPr/>
+          </p:nvSpPr>
+          <p:spPr>
+            <a:xfrm rot="15296541">
+              <a:off x="4873390" y="610753"/>
+              <a:ext cx="399066" cy="1371600"/>
+            </a:xfrm>
+            <a:prstGeom prst="rect">
+              <a:avLst/>
+            </a:prstGeom>
+            <a:solidFill>
+              <a:schemeClr val="accent6">
+                <a:lumMod val="75000"/>
+              </a:schemeClr>
+            </a:solidFill>
+            <a:ln>
+              <a:noFill/>
+            </a:ln>
+          </p:spPr>
+          <p:style>
+            <a:lnRef idx="2">
+              <a:schemeClr val="accent1">
+                <a:shade val="15000"/>
+              </a:schemeClr>
+            </a:lnRef>
+            <a:fillRef idx="1">
+              <a:schemeClr val="accent1"/>
+            </a:fillRef>
+            <a:effectRef idx="0">
+              <a:schemeClr val="accent1"/>
+            </a:effectRef>
+            <a:fontRef idx="minor">
+              <a:schemeClr val="lt1"/>
+            </a:fontRef>
+          </p:style>
+          <p:txBody>
+            <a:bodyPr rtlCol="0" anchor="ctr"/>
+            <a:lstStyle/>
+            <a:p>
+              <a:pPr algn="ctr"/>
+              <a:endParaRPr lang="nl-BE"/>
+            </a:p>
+          </p:txBody>
+        </p:sp>
+        <p:sp>
+          <p:nvSpPr>
+            <p:cNvPr id="22" name="Rechthoek 21">
+              <a:extLst>
+                <a:ext uri="{FF2B5EF4-FFF2-40B4-BE49-F238E27FC236}">
+                  <a16:creationId xmlns:a16="http://schemas.microsoft.com/office/drawing/2014/main" id="{DBF44B49-31E5-DCCE-0422-94484679E0F6}"/>
+                </a:ext>
+              </a:extLst>
+            </p:cNvPr>
+            <p:cNvSpPr/>
+            <p:nvPr/>
+          </p:nvSpPr>
+          <p:spPr>
+            <a:xfrm rot="19848144">
+              <a:off x="3212958" y="593396"/>
+              <a:ext cx="399066" cy="1371600"/>
+            </a:xfrm>
+            <a:prstGeom prst="rect">
+              <a:avLst/>
+            </a:prstGeom>
+            <a:solidFill>
+              <a:schemeClr val="accent6">
+                <a:lumMod val="50000"/>
+              </a:schemeClr>
+            </a:solidFill>
+            <a:ln>
+              <a:noFill/>
+            </a:ln>
+          </p:spPr>
+          <p:style>
+            <a:lnRef idx="2">
+              <a:schemeClr val="accent1">
+                <a:shade val="15000"/>
+              </a:schemeClr>
+            </a:lnRef>
+            <a:fillRef idx="1">
+              <a:schemeClr val="accent1"/>
+            </a:fillRef>
+            <a:effectRef idx="0">
+              <a:schemeClr val="accent1"/>
+            </a:effectRef>
+            <a:fontRef idx="minor">
+              <a:schemeClr val="lt1"/>
+            </a:fontRef>
+          </p:style>
+          <p:txBody>
+            <a:bodyPr rtlCol="0" anchor="ctr"/>
+            <a:lstStyle/>
+            <a:p>
+              <a:pPr algn="ctr"/>
+              <a:endParaRPr lang="nl-BE"/>
+            </a:p>
+          </p:txBody>
+        </p:sp>
+        <p:grpSp>
+          <p:nvGrpSpPr>
+            <p:cNvPr id="29" name="Groep 28">
+              <a:extLst>
+                <a:ext uri="{FF2B5EF4-FFF2-40B4-BE49-F238E27FC236}">
+                  <a16:creationId xmlns:a16="http://schemas.microsoft.com/office/drawing/2014/main" id="{AAF16BA7-A9F6-E830-07BD-08B96629BCE8}"/>
+                </a:ext>
+              </a:extLst>
+            </p:cNvPr>
+            <p:cNvGrpSpPr/>
+            <p:nvPr/>
+          </p:nvGrpSpPr>
+          <p:grpSpPr>
+            <a:xfrm rot="5400000">
+              <a:off x="-597324" y="976053"/>
+              <a:ext cx="2114300" cy="679905"/>
+              <a:chOff x="4849964" y="5201459"/>
+              <a:chExt cx="1471815" cy="563368"/>
+            </a:xfrm>
+          </p:grpSpPr>
+          <p:sp>
+            <p:nvSpPr>
+              <p:cNvPr id="25" name="Vierkante haak links 24">
+                <a:extLst>
+                  <a:ext uri="{FF2B5EF4-FFF2-40B4-BE49-F238E27FC236}">
+                    <a16:creationId xmlns:a16="http://schemas.microsoft.com/office/drawing/2014/main" id="{D4466E79-D59F-BA3E-8554-F2ADD3BC93EB}"/>
+                  </a:ext>
+                </a:extLst>
+              </p:cNvPr>
+              <p:cNvSpPr/>
+              <p:nvPr/>
+            </p:nvSpPr>
+            <p:spPr>
+              <a:xfrm rot="16200000">
+                <a:off x="5304188" y="4747235"/>
+                <a:ext cx="563368" cy="1471815"/>
+              </a:xfrm>
+              <a:prstGeom prst="leftBracket">
+                <a:avLst/>
+              </a:prstGeom>
+              <a:ln w="57150">
+                <a:solidFill>
+                  <a:schemeClr val="accent6"/>
+                </a:solidFill>
+              </a:ln>
+            </p:spPr>
+            <p:style>
+              <a:lnRef idx="2">
+                <a:schemeClr val="accent1"/>
+              </a:lnRef>
+              <a:fillRef idx="0">
+                <a:schemeClr val="accent1"/>
+              </a:fillRef>
+              <a:effectRef idx="1">
+                <a:schemeClr val="accent1"/>
+              </a:effectRef>
+              <a:fontRef idx="minor">
+                <a:schemeClr val="tx1"/>
+              </a:fontRef>
+            </p:style>
+            <p:txBody>
+              <a:bodyPr rtlCol="0" anchor="ctr"/>
+              <a:lstStyle/>
+              <a:p>
+                <a:pPr algn="ctr"/>
+                <a:endParaRPr lang="nl-BE" dirty="0"/>
+              </a:p>
+            </p:txBody>
+          </p:sp>
+          <p:sp>
+            <p:nvSpPr>
+              <p:cNvPr id="28" name="Tekstvak 27">
+                <a:extLst>
+                  <a:ext uri="{FF2B5EF4-FFF2-40B4-BE49-F238E27FC236}">
+                    <a16:creationId xmlns:a16="http://schemas.microsoft.com/office/drawing/2014/main" id="{5147EE62-864C-8148-526B-6B8E0881CDCE}"/>
+                  </a:ext>
+                </a:extLst>
+              </p:cNvPr>
+              <p:cNvSpPr txBox="1"/>
+              <p:nvPr/>
+            </p:nvSpPr>
+            <p:spPr>
+              <a:xfrm rot="16200000">
+                <a:off x="5529858" y="5232357"/>
+                <a:ext cx="221782" cy="501571"/>
+              </a:xfrm>
+              <a:prstGeom prst="rect">
+                <a:avLst/>
+              </a:prstGeom>
+              <a:noFill/>
+            </p:spPr>
+            <p:txBody>
+              <a:bodyPr wrap="square" rtlCol="0">
+                <a:spAutoFit/>
+              </a:bodyPr>
+              <a:lstStyle/>
+              <a:p>
+                <a:pPr algn="ctr"/>
+                <a:r>
+                  <a:rPr lang="en-US" dirty="0"/>
+                  <a:t>2</a:t>
+                </a:r>
+                <a:endParaRPr lang="nl-BE" dirty="0"/>
+              </a:p>
+            </p:txBody>
+          </p:sp>
+        </p:grpSp>
+        <p:sp>
+          <p:nvSpPr>
+            <p:cNvPr id="24" name="Rechthoek 23">
+              <a:extLst>
+                <a:ext uri="{FF2B5EF4-FFF2-40B4-BE49-F238E27FC236}">
+                  <a16:creationId xmlns:a16="http://schemas.microsoft.com/office/drawing/2014/main" id="{24D03914-7DDE-18AF-6FF2-8C5FF44CF4D3}"/>
+                </a:ext>
+              </a:extLst>
+            </p:cNvPr>
+            <p:cNvSpPr/>
+            <p:nvPr/>
+          </p:nvSpPr>
+          <p:spPr>
+            <a:xfrm rot="167888">
+              <a:off x="6791251" y="610753"/>
+              <a:ext cx="399066" cy="1371600"/>
+            </a:xfrm>
+            <a:prstGeom prst="rect">
+              <a:avLst/>
+            </a:prstGeom>
+            <a:solidFill>
+              <a:schemeClr val="accent6">
+                <a:lumMod val="60000"/>
+                <a:lumOff val="40000"/>
+              </a:schemeClr>
+            </a:solidFill>
+            <a:ln>
+              <a:noFill/>
+            </a:ln>
+          </p:spPr>
+          <p:style>
+            <a:lnRef idx="2">
+              <a:schemeClr val="accent1">
+                <a:shade val="15000"/>
+              </a:schemeClr>
+            </a:lnRef>
+            <a:fillRef idx="1">
+              <a:schemeClr val="accent1"/>
+            </a:fillRef>
+            <a:effectRef idx="0">
+              <a:schemeClr val="accent1"/>
+            </a:effectRef>
+            <a:fontRef idx="minor">
+              <a:schemeClr val="lt1"/>
+            </a:fontRef>
+          </p:style>
+          <p:txBody>
+            <a:bodyPr rtlCol="0" anchor="ctr"/>
+            <a:lstStyle/>
+            <a:p>
+              <a:pPr algn="ctr"/>
+              <a:endParaRPr lang="nl-BE"/>
+            </a:p>
+          </p:txBody>
+        </p:sp>
+        <p:sp>
+          <p:nvSpPr>
+            <p:cNvPr id="27" name="Rechthoek 26">
+              <a:extLst>
+                <a:ext uri="{FF2B5EF4-FFF2-40B4-BE49-F238E27FC236}">
+                  <a16:creationId xmlns:a16="http://schemas.microsoft.com/office/drawing/2014/main" id="{659E9690-D825-85A2-DD90-670147B433C4}"/>
+                </a:ext>
+              </a:extLst>
+            </p:cNvPr>
+            <p:cNvSpPr/>
+            <p:nvPr/>
+          </p:nvSpPr>
+          <p:spPr>
+            <a:xfrm rot="6844391">
+              <a:off x="10327463" y="769175"/>
+              <a:ext cx="399066" cy="1371600"/>
+            </a:xfrm>
+            <a:prstGeom prst="rect">
+              <a:avLst/>
+            </a:prstGeom>
+            <a:solidFill>
+              <a:schemeClr val="accent6">
+                <a:lumMod val="20000"/>
+                <a:lumOff val="80000"/>
+              </a:schemeClr>
+            </a:solidFill>
+            <a:ln>
+              <a:noFill/>
+            </a:ln>
+          </p:spPr>
+          <p:style>
+            <a:lnRef idx="2">
+              <a:schemeClr val="accent1">
+                <a:shade val="15000"/>
+              </a:schemeClr>
+            </a:lnRef>
+            <a:fillRef idx="1">
+              <a:schemeClr val="accent1"/>
+            </a:fillRef>
+            <a:effectRef idx="0">
+              <a:schemeClr val="accent1"/>
+            </a:effectRef>
+            <a:fontRef idx="minor">
+              <a:schemeClr val="lt1"/>
+            </a:fontRef>
+          </p:style>
+          <p:txBody>
+            <a:bodyPr rtlCol="0" anchor="ctr"/>
+            <a:lstStyle/>
+            <a:p>
+              <a:pPr algn="ctr"/>
+              <a:endParaRPr lang="nl-BE"/>
+            </a:p>
+          </p:txBody>
+        </p:sp>
+        <p:sp>
+          <p:nvSpPr>
+            <p:cNvPr id="31" name="Rechthoek 30">
+              <a:extLst>
+                <a:ext uri="{FF2B5EF4-FFF2-40B4-BE49-F238E27FC236}">
+                  <a16:creationId xmlns:a16="http://schemas.microsoft.com/office/drawing/2014/main" id="{A6826F09-6DAF-D86E-B342-167A3BFF524E}"/>
+                </a:ext>
+              </a:extLst>
+            </p:cNvPr>
+            <p:cNvSpPr/>
+            <p:nvPr/>
+          </p:nvSpPr>
+          <p:spPr>
+            <a:xfrm rot="2799454">
+              <a:off x="8667031" y="751818"/>
+              <a:ext cx="399066" cy="1371600"/>
+            </a:xfrm>
+            <a:prstGeom prst="rect">
+              <a:avLst/>
+            </a:prstGeom>
+            <a:solidFill>
+              <a:schemeClr val="accent6">
+                <a:lumMod val="40000"/>
+                <a:lumOff val="60000"/>
+              </a:schemeClr>
+            </a:solidFill>
+            <a:ln>
+              <a:noFill/>
+            </a:ln>
+          </p:spPr>
+          <p:style>
+            <a:lnRef idx="2">
+              <a:schemeClr val="accent1">
+                <a:shade val="15000"/>
+              </a:schemeClr>
+            </a:lnRef>
+            <a:fillRef idx="1">
+              <a:schemeClr val="accent1"/>
+            </a:fillRef>
+            <a:effectRef idx="0">
+              <a:schemeClr val="accent1"/>
+            </a:effectRef>
+            <a:fontRef idx="minor">
+              <a:schemeClr val="lt1"/>
+            </a:fontRef>
+          </p:style>
+          <p:txBody>
+            <a:bodyPr rtlCol="0" anchor="ctr"/>
+            <a:lstStyle/>
+            <a:p>
+              <a:pPr algn="ctr"/>
+              <a:endParaRPr lang="nl-BE"/>
+            </a:p>
+          </p:txBody>
+        </p:sp>
+        <p:sp>
+          <p:nvSpPr>
+            <p:cNvPr id="33" name="Rechthoek 32">
+              <a:extLst>
+                <a:ext uri="{FF2B5EF4-FFF2-40B4-BE49-F238E27FC236}">
+                  <a16:creationId xmlns:a16="http://schemas.microsoft.com/office/drawing/2014/main" id="{0550947C-398C-109C-C615-1FD58AE81C08}"/>
+                </a:ext>
+              </a:extLst>
+            </p:cNvPr>
+            <p:cNvSpPr/>
+            <p:nvPr/>
+          </p:nvSpPr>
+          <p:spPr>
+            <a:xfrm rot="17702890">
+              <a:off x="1677840" y="610752"/>
+              <a:ext cx="399066" cy="1371600"/>
+            </a:xfrm>
+            <a:prstGeom prst="rect">
+              <a:avLst/>
+            </a:prstGeom>
+            <a:solidFill>
+              <a:schemeClr val="accent3">
+                <a:lumMod val="50000"/>
+              </a:schemeClr>
+            </a:solidFill>
+            <a:ln>
+              <a:noFill/>
+            </a:ln>
+          </p:spPr>
+          <p:style>
+            <a:lnRef idx="2">
+              <a:schemeClr val="accent1">
+                <a:shade val="15000"/>
+              </a:schemeClr>
+            </a:lnRef>
+            <a:fillRef idx="1">
+              <a:schemeClr val="accent1"/>
+            </a:fillRef>
+            <a:effectRef idx="0">
+              <a:schemeClr val="accent1"/>
+            </a:effectRef>
+            <a:fontRef idx="minor">
+              <a:schemeClr val="lt1"/>
+            </a:fontRef>
+          </p:style>
+          <p:txBody>
+            <a:bodyPr rtlCol="0" anchor="ctr"/>
+            <a:lstStyle/>
+            <a:p>
+              <a:pPr algn="ctr"/>
+              <a:endParaRPr lang="nl-BE" dirty="0"/>
+            </a:p>
+          </p:txBody>
+        </p:sp>
+      </p:grpSp>
+      <p:sp>
+        <p:nvSpPr>
+          <p:cNvPr id="35" name="Rechthoek 34">
+            <a:extLst>
+              <a:ext uri="{FF2B5EF4-FFF2-40B4-BE49-F238E27FC236}">
+                <a16:creationId xmlns:a16="http://schemas.microsoft.com/office/drawing/2014/main" id="{B81993CE-E818-8F85-4D98-A988A4AA87A0}"/>
+              </a:ext>
+            </a:extLst>
+          </p:cNvPr>
+          <p:cNvSpPr/>
+          <p:nvPr/>
+        </p:nvSpPr>
+        <p:spPr>
+          <a:xfrm rot="17702890">
+            <a:off x="2704228" y="3687437"/>
+            <a:ext cx="399066" cy="1371600"/>
+          </a:xfrm>
+          <a:prstGeom prst="rect">
+            <a:avLst/>
+          </a:prstGeom>
+          <a:solidFill>
+            <a:schemeClr val="accent3">
+              <a:lumMod val="50000"/>
+            </a:schemeClr>
+          </a:solidFill>
+          <a:ln>
+            <a:noFill/>
+          </a:ln>
+        </p:spPr>
+        <p:style>
+          <a:lnRef idx="2">
+            <a:schemeClr val="accent1">
+              <a:shade val="15000"/>
+            </a:schemeClr>
+          </a:lnRef>
+          <a:fillRef idx="1">
+            <a:schemeClr val="accent1"/>
+          </a:fillRef>
+          <a:effectRef idx="0">
+            <a:schemeClr val="accent1"/>
+          </a:effectRef>
+          <a:fontRef idx="minor">
+            <a:schemeClr val="lt1"/>
+          </a:fontRef>
+        </p:style>
+        <p:txBody>
+          <a:bodyPr rtlCol="0" anchor="ctr"/>
+          <a:lstStyle/>
+          <a:p>
+            <a:pPr algn="ctr"/>
+            <a:endParaRPr lang="nl-BE" dirty="0"/>
+          </a:p>
+        </p:txBody>
+      </p:sp>
+      <p:sp>
+        <p:nvSpPr>
+          <p:cNvPr id="37" name="Rechthoek 36">
+            <a:extLst>
+              <a:ext uri="{FF2B5EF4-FFF2-40B4-BE49-F238E27FC236}">
+                <a16:creationId xmlns:a16="http://schemas.microsoft.com/office/drawing/2014/main" id="{4119A9C6-3337-5BAF-386E-0FC1C98D1EFA}"/>
+              </a:ext>
+            </a:extLst>
+          </p:cNvPr>
+          <p:cNvSpPr/>
+          <p:nvPr/>
+        </p:nvSpPr>
+        <p:spPr>
+          <a:xfrm rot="19848144">
+            <a:off x="5896464" y="3869981"/>
+            <a:ext cx="399066" cy="1371600"/>
+          </a:xfrm>
+          <a:prstGeom prst="rect">
+            <a:avLst/>
+          </a:prstGeom>
+          <a:solidFill>
+            <a:schemeClr val="accent6">
+              <a:lumMod val="50000"/>
+            </a:schemeClr>
+          </a:solidFill>
+          <a:ln>
+            <a:noFill/>
+          </a:ln>
+        </p:spPr>
+        <p:style>
+          <a:lnRef idx="2">
+            <a:schemeClr val="accent1">
+              <a:shade val="15000"/>
+            </a:schemeClr>
+          </a:lnRef>
+          <a:fillRef idx="1">
+            <a:schemeClr val="accent1"/>
+          </a:fillRef>
+          <a:effectRef idx="0">
+            <a:schemeClr val="accent1"/>
+          </a:effectRef>
+          <a:fontRef idx="minor">
+            <a:schemeClr val="lt1"/>
+          </a:fontRef>
+        </p:style>
+        <p:txBody>
+          <a:bodyPr rtlCol="0" anchor="ctr"/>
+          <a:lstStyle/>
+          <a:p>
+            <a:pPr algn="ctr"/>
+            <a:endParaRPr lang="nl-BE"/>
+          </a:p>
+        </p:txBody>
+      </p:sp>
+      <p:sp>
+        <p:nvSpPr>
+          <p:cNvPr id="39" name="Rechthoek 38">
+            <a:extLst>
+              <a:ext uri="{FF2B5EF4-FFF2-40B4-BE49-F238E27FC236}">
+                <a16:creationId xmlns:a16="http://schemas.microsoft.com/office/drawing/2014/main" id="{9EDB07E9-91C1-6DC6-352E-2704ABCFDF59}"/>
+              </a:ext>
+            </a:extLst>
+          </p:cNvPr>
+          <p:cNvSpPr/>
+          <p:nvPr/>
+        </p:nvSpPr>
+        <p:spPr>
+          <a:xfrm rot="15296541">
+            <a:off x="9170915" y="3687437"/>
+            <a:ext cx="399066" cy="1371600"/>
+          </a:xfrm>
+          <a:prstGeom prst="rect">
+            <a:avLst/>
+          </a:prstGeom>
+          <a:solidFill>
+            <a:schemeClr val="accent6">
+              <a:lumMod val="75000"/>
+            </a:schemeClr>
+          </a:solidFill>
+          <a:ln>
+            <a:noFill/>
+          </a:ln>
+        </p:spPr>
+        <p:style>
+          <a:lnRef idx="2">
+            <a:schemeClr val="accent1">
+              <a:shade val="15000"/>
+            </a:schemeClr>
+          </a:lnRef>
+          <a:fillRef idx="1">
+            <a:schemeClr val="accent1"/>
+          </a:fillRef>
+          <a:effectRef idx="0">
+            <a:schemeClr val="accent1"/>
+          </a:effectRef>
+          <a:fontRef idx="minor">
+            <a:schemeClr val="lt1"/>
+          </a:fontRef>
+        </p:style>
+        <p:txBody>
+          <a:bodyPr rtlCol="0" anchor="ctr"/>
+          <a:lstStyle/>
+          <a:p>
+            <a:pPr algn="ctr"/>
+            <a:endParaRPr lang="nl-BE"/>
+          </a:p>
+        </p:txBody>
+      </p:sp>
+      <p:sp>
+        <p:nvSpPr>
+          <p:cNvPr id="44" name="Rechthoek 43">
+            <a:extLst>
+              <a:ext uri="{FF2B5EF4-FFF2-40B4-BE49-F238E27FC236}">
+                <a16:creationId xmlns:a16="http://schemas.microsoft.com/office/drawing/2014/main" id="{9B2BE72D-3D85-EA66-C5B8-7C6ED4C6F02B}"/>
+              </a:ext>
+            </a:extLst>
+          </p:cNvPr>
+          <p:cNvSpPr/>
+          <p:nvPr/>
+        </p:nvSpPr>
+        <p:spPr>
+          <a:xfrm rot="167888">
+            <a:off x="2601155" y="4854560"/>
+            <a:ext cx="399066" cy="1371600"/>
+          </a:xfrm>
+          <a:prstGeom prst="rect">
+            <a:avLst/>
+          </a:prstGeom>
+          <a:solidFill>
+            <a:schemeClr val="accent6">
+              <a:lumMod val="60000"/>
+              <a:lumOff val="40000"/>
+            </a:schemeClr>
+          </a:solidFill>
+          <a:ln>
+            <a:noFill/>
+          </a:ln>
+        </p:spPr>
+        <p:style>
+          <a:lnRef idx="2">
+            <a:schemeClr val="accent1">
+              <a:shade val="15000"/>
+            </a:schemeClr>
+          </a:lnRef>
+          <a:fillRef idx="1">
+            <a:schemeClr val="accent1"/>
+          </a:fillRef>
+          <a:effectRef idx="0">
+            <a:schemeClr val="accent1"/>
+          </a:effectRef>
+          <a:fontRef idx="minor">
+            <a:schemeClr val="lt1"/>
+          </a:fontRef>
+        </p:style>
+        <p:txBody>
+          <a:bodyPr rtlCol="0" anchor="ctr"/>
+          <a:lstStyle/>
+          <a:p>
+            <a:pPr algn="ctr"/>
+            <a:endParaRPr lang="nl-BE"/>
+          </a:p>
+        </p:txBody>
+      </p:sp>
+      <p:sp>
+        <p:nvSpPr>
+          <p:cNvPr id="48" name="Rechthoek 47">
+            <a:extLst>
+              <a:ext uri="{FF2B5EF4-FFF2-40B4-BE49-F238E27FC236}">
+                <a16:creationId xmlns:a16="http://schemas.microsoft.com/office/drawing/2014/main" id="{DCE02F86-A069-3A5B-C6CD-7A514480DD97}"/>
+              </a:ext>
+            </a:extLst>
+          </p:cNvPr>
+          <p:cNvSpPr/>
+          <p:nvPr/>
+        </p:nvSpPr>
+        <p:spPr>
+          <a:xfrm rot="2799454">
+            <a:off x="5896464" y="5258419"/>
+            <a:ext cx="399066" cy="1371600"/>
+          </a:xfrm>
+          <a:prstGeom prst="rect">
+            <a:avLst/>
+          </a:prstGeom>
+          <a:solidFill>
+            <a:schemeClr val="accent6">
+              <a:lumMod val="40000"/>
+              <a:lumOff val="60000"/>
+            </a:schemeClr>
+          </a:solidFill>
+          <a:ln>
+            <a:noFill/>
+          </a:ln>
+        </p:spPr>
+        <p:style>
+          <a:lnRef idx="2">
+            <a:schemeClr val="accent1">
+              <a:shade val="15000"/>
+            </a:schemeClr>
+          </a:lnRef>
+          <a:fillRef idx="1">
+            <a:schemeClr val="accent1"/>
+          </a:fillRef>
+          <a:effectRef idx="0">
+            <a:schemeClr val="accent1"/>
+          </a:effectRef>
+          <a:fontRef idx="minor">
+            <a:schemeClr val="lt1"/>
+          </a:fontRef>
+        </p:style>
+        <p:txBody>
+          <a:bodyPr rtlCol="0" anchor="ctr"/>
+          <a:lstStyle/>
+          <a:p>
+            <a:pPr algn="ctr"/>
+            <a:endParaRPr lang="nl-BE"/>
+          </a:p>
+        </p:txBody>
+      </p:sp>
+      <p:sp>
+        <p:nvSpPr>
+          <p:cNvPr id="50" name="Rechthoek 49">
+            <a:extLst>
+              <a:ext uri="{FF2B5EF4-FFF2-40B4-BE49-F238E27FC236}">
+                <a16:creationId xmlns:a16="http://schemas.microsoft.com/office/drawing/2014/main" id="{0ACAC206-9163-3B5B-128B-7445805CDD71}"/>
+              </a:ext>
+            </a:extLst>
+          </p:cNvPr>
+          <p:cNvSpPr/>
+          <p:nvPr/>
+        </p:nvSpPr>
+        <p:spPr>
+          <a:xfrm rot="6844391">
+            <a:off x="9092532" y="5027900"/>
+            <a:ext cx="399066" cy="1371600"/>
+          </a:xfrm>
+          <a:prstGeom prst="rect">
+            <a:avLst/>
+          </a:prstGeom>
+          <a:solidFill>
+            <a:schemeClr val="accent6">
+              <a:lumMod val="20000"/>
+              <a:lumOff val="80000"/>
+            </a:schemeClr>
+          </a:solidFill>
+          <a:ln>
+            <a:noFill/>
+          </a:ln>
+        </p:spPr>
+        <p:style>
+          <a:lnRef idx="2">
+            <a:schemeClr val="accent1">
+              <a:shade val="15000"/>
+            </a:schemeClr>
+          </a:lnRef>
+          <a:fillRef idx="1">
+            <a:schemeClr val="accent1"/>
+          </a:fillRef>
+          <a:effectRef idx="0">
+            <a:schemeClr val="accent1"/>
+          </a:effectRef>
+          <a:fontRef idx="minor">
+            <a:schemeClr val="lt1"/>
+          </a:fontRef>
+        </p:style>
+        <p:txBody>
+          <a:bodyPr rtlCol="0" anchor="ctr"/>
+          <a:lstStyle/>
+          <a:p>
+            <a:pPr algn="ctr"/>
+            <a:endParaRPr lang="nl-BE"/>
+          </a:p>
+        </p:txBody>
+      </p:sp>
+      <p:cxnSp>
+        <p:nvCxnSpPr>
+          <p:cNvPr id="53" name="Rechte verbindingslijn met pijl 52">
+            <a:extLst>
+              <a:ext uri="{FF2B5EF4-FFF2-40B4-BE49-F238E27FC236}">
+                <a16:creationId xmlns:a16="http://schemas.microsoft.com/office/drawing/2014/main" id="{09C45E33-904F-E4F5-9BDD-9249A344BE1C}"/>
+              </a:ext>
+            </a:extLst>
+          </p:cNvPr>
+          <p:cNvCxnSpPr/>
+          <p:nvPr/>
+        </p:nvCxnSpPr>
+        <p:spPr>
+          <a:xfrm>
+            <a:off x="1890423" y="2243470"/>
+            <a:ext cx="8805930" cy="0"/>
+          </a:xfrm>
+          <a:prstGeom prst="straightConnector1">
+            <a:avLst/>
+          </a:prstGeom>
+          <a:ln w="57150">
+            <a:solidFill>
+              <a:srgbClr val="2980B9"/>
+            </a:solidFill>
+            <a:tailEnd type="triangle"/>
+          </a:ln>
+        </p:spPr>
+        <p:style>
+          <a:lnRef idx="2">
+            <a:schemeClr val="accent1"/>
+          </a:lnRef>
+          <a:fillRef idx="0">
+            <a:schemeClr val="accent1"/>
+          </a:fillRef>
+          <a:effectRef idx="1">
+            <a:schemeClr val="accent1"/>
+          </a:effectRef>
+          <a:fontRef idx="minor">
+            <a:schemeClr val="tx1"/>
+          </a:fontRef>
+        </p:style>
+      </p:cxnSp>
+      <p:sp>
+        <p:nvSpPr>
+          <p:cNvPr id="54" name="Tekstvak 53">
+            <a:extLst>
+              <a:ext uri="{FF2B5EF4-FFF2-40B4-BE49-F238E27FC236}">
+                <a16:creationId xmlns:a16="http://schemas.microsoft.com/office/drawing/2014/main" id="{BAFF7C56-85D2-BAB8-C890-AC623EDB335D}"/>
+              </a:ext>
+            </a:extLst>
+          </p:cNvPr>
+          <p:cNvSpPr txBox="1"/>
+          <p:nvPr/>
+        </p:nvSpPr>
+        <p:spPr>
+          <a:xfrm>
+            <a:off x="4663440" y="2316480"/>
+            <a:ext cx="2865120" cy="369332"/>
+          </a:xfrm>
+          <a:prstGeom prst="rect">
+            <a:avLst/>
+          </a:prstGeom>
+          <a:noFill/>
+        </p:spPr>
+        <p:txBody>
+          <a:bodyPr wrap="square" rtlCol="0">
+            <a:spAutoFit/>
+          </a:bodyPr>
+          <a:lstStyle/>
+          <a:p>
+            <a:pPr algn="ctr"/>
+            <a:r>
+              <a:rPr lang="en-US" dirty="0"/>
+              <a:t>More to less pigment</a:t>
+            </a:r>
+            <a:endParaRPr lang="nl-BE" dirty="0"/>
+          </a:p>
+        </p:txBody>
+      </p:sp>
+    </p:spTree>
+    <p:extLst>
+      <p:ext uri="{BB962C8B-B14F-4D97-AF65-F5344CB8AC3E}">
+        <p14:creationId xmlns:p14="http://schemas.microsoft.com/office/powerpoint/2010/main" val="46880012"/>
       </p:ext>
     </p:extLst>
   </p:cSld>

</xml_diff>